<commit_message>
Update timelines for product implementation and results on website and decks
Update implementation and results timelines across the Homepage, 4-minute pitch deck, and full investor deck to reflect a 2-4 week timeframe for initial results and a 90-day validation program.

Replit-Commit-Author: Agent
Replit-Commit-Session-Id: 85f09f3c-352d-446d-b98e-3f307c26fc5a
Replit-Commit-Checkpoint-Type: full_checkpoint
Replit-Commit-Event-Id: c4f5bcd9-3269-404e-acd8-5e144b9dc426
Replit-Commit-Screenshot-Url: https://storage.googleapis.com/screenshot-production-us-central1/3bd53afc-ff4f-401b-9e3d-b367791ef629/85f09f3c-352d-446d-b98e-3f307c26fc5a/jSCsBno
Replit-Helium-Checkpoint-Created: true
</commit_message>
<xml_diff>
--- a/attached_assets/VaughnMartin-4min-Pitch.pptx
+++ b/attached_assets/VaughnMartin-4min-Pitch.pptx
@@ -12411,7 +12411,7 @@
             <a:r>
               <a:rPr sz="850" b="0" i="1">
                 <a:solidFill>
-                  <a:srgbClr val="C9A84C"/>
+                  <a:srgbClr val="AAB4CC"/>
                 </a:solidFill>
                 <a:latin typeface="Calibri"/>
               </a:rPr>
@@ -15402,11 +15402,11 @@
             <a:r>
               <a:rPr sz="2600" b="1" i="0">
                 <a:solidFill>
-                  <a:srgbClr val="AAB4CC"/>
+                  <a:srgbClr val="2B8A6E"/>
                 </a:solidFill>
                 <a:latin typeface="Georgia"/>
               </a:rPr>
-              <a:t>&lt;6 mo</a:t>
+              <a:t>2–4 Weeks</a:t>
             </a:r>
           </a:p>
         </p:txBody>
@@ -15441,7 +15441,7 @@
                 </a:solidFill>
                 <a:latin typeface="Calibri"/>
               </a:rPr>
-              <a:t>Implementation</a:t>
+              <a:t>First Results</a:t>
             </a:r>
           </a:p>
         </p:txBody>

</xml_diff>

<commit_message>
Update payback period to reflect faster customer value realization
Update presentation decks to show a payback period of less than 6 months, reflecting quicker customer ROI and aligning with internal metrics.

Replit-Commit-Author: Agent
Replit-Commit-Session-Id: 85f09f3c-352d-446d-b98e-3f307c26fc5a
Replit-Commit-Checkpoint-Type: full_checkpoint
Replit-Commit-Event-Id: 9bba9022-94a2-48b4-8283-e501a8fb9dc6
Replit-Commit-Screenshot-Url: https://storage.googleapis.com/screenshot-production-us-central1/3bd53afc-ff4f-401b-9e3d-b367791ef629/85f09f3c-352d-446d-b98e-3f307c26fc5a/jSCsBno
Replit-Helium-Checkpoint-Created: true
</commit_message>
<xml_diff>
--- a/attached_assets/VaughnMartin-4min-Pitch.pptx
+++ b/attached_assets/VaughnMartin-4min-Pitch.pptx
@@ -15517,11 +15517,11 @@
             <a:r>
               <a:rPr sz="2600" b="1" i="0">
                 <a:solidFill>
-                  <a:srgbClr val="AAB4CC"/>
+                  <a:srgbClr val="2B8A6E"/>
                 </a:solidFill>
                 <a:latin typeface="Georgia"/>
               </a:rPr>
-              <a:t>18 mo</a:t>
+              <a:t>&lt; 6 mo</a:t>
             </a:r>
           </a:p>
         </p:txBody>

</xml_diff>

<commit_message>
Add data and privacy talking points to investor decks
Update metadata and presentation files to include a new appendix slide addressing data privacy and security for investor discussions.

Replit-Commit-Author: Agent
Replit-Commit-Session-Id: 85f09f3c-352d-446d-b98e-3f307c26fc5a
Replit-Commit-Checkpoint-Type: full_checkpoint
Replit-Commit-Event-Id: 9fcd8d0e-aad9-4fe3-9c45-f4e1835a7835
Replit-Commit-Screenshot-Url: https://storage.googleapis.com/screenshot-production-us-central1/3bd53afc-ff4f-401b-9e3d-b367791ef629/85f09f3c-352d-446d-b98e-3f307c26fc5a/jSCsBno
Replit-Helium-Checkpoint-Created: true
</commit_message>
<xml_diff>
--- a/attached_assets/VaughnMartin-4min-Pitch.pptx
+++ b/attached_assets/VaughnMartin-4min-Pitch.pptx
@@ -15,6 +15,7 @@
     <p:sldId id="263" r:id="rId15"/>
     <p:sldId id="264" r:id="rId16"/>
     <p:sldId id="265" r:id="rId17"/>
+    <p:sldId id="266" r:id="rId18"/>
   </p:sldIdLst>
   <p:sldSz cx="12188952" cy="6858000" type="screen4x3"/>
   <p:notesSz cx="6858000" cy="9144000"/>
@@ -6281,6 +6282,1193 @@
                 <a:latin typeface="Calibri"/>
               </a:rPr>
               <a:t>4:00</a:t>
+            </a:r>
+          </a:p>
+        </p:txBody>
+      </p:sp>
+    </p:spTree>
+  </p:cSld>
+  <p:clrMapOvr>
+    <a:masterClrMapping/>
+  </p:clrMapOvr>
+</p:sld>
+</file>
+
+<file path=ppt/slides/slide11.xml><?xml version="1.0" encoding="utf-8"?>
+<p:sld xmlns:a="http://schemas.openxmlformats.org/drawingml/2006/main" xmlns:p="http://schemas.openxmlformats.org/presentationml/2006/main" xmlns:r="http://schemas.openxmlformats.org/officeDocument/2006/relationships">
+  <p:cSld>
+    <p:bg>
+      <p:bgPr>
+        <a:solidFill>
+          <a:srgbClr val="0A0F2E"/>
+        </a:solidFill>
+        <a:effectLst/>
+      </p:bgPr>
+    </p:bg>
+    <p:spTree>
+      <p:nvGrpSpPr>
+        <p:cNvPr id="1" name=""/>
+        <p:cNvGrpSpPr/>
+        <p:nvPr/>
+      </p:nvGrpSpPr>
+      <p:grpSpPr/>
+      <p:sp>
+        <p:nvSpPr>
+          <p:cNvPr id="2" name="Rectangle 1"/>
+          <p:cNvSpPr/>
+          <p:nvPr/>
+        </p:nvSpPr>
+        <p:spPr>
+          <a:xfrm>
+            <a:off x="0" y="502920"/>
+            <a:ext cx="12188952" cy="25400"/>
+          </a:xfrm>
+          <a:prstGeom prst="rect">
+            <a:avLst/>
+          </a:prstGeom>
+          <a:solidFill>
+            <a:srgbClr val="C9A84C"/>
+          </a:solidFill>
+          <a:ln>
+            <a:noFill/>
+          </a:ln>
+        </p:spPr>
+        <p:style>
+          <a:lnRef idx="1">
+            <a:schemeClr val="accent1"/>
+          </a:lnRef>
+          <a:fillRef idx="3">
+            <a:schemeClr val="accent1"/>
+          </a:fillRef>
+          <a:effectRef idx="2">
+            <a:schemeClr val="accent1"/>
+          </a:effectRef>
+          <a:fontRef idx="minor">
+            <a:schemeClr val="lt1"/>
+          </a:fontRef>
+        </p:style>
+        <p:txBody>
+          <a:bodyPr rtlCol="0" anchor="ctr"/>
+          <a:lstStyle/>
+          <a:p>
+            <a:pPr algn="ctr"/>
+          </a:p>
+        </p:txBody>
+      </p:sp>
+      <p:sp>
+        <p:nvSpPr>
+          <p:cNvPr id="3" name="TextBox 2"/>
+          <p:cNvSpPr txBox="1"/>
+          <p:nvPr/>
+        </p:nvSpPr>
+        <p:spPr>
+          <a:xfrm>
+            <a:off x="502920" y="228600"/>
+            <a:ext cx="5486400" cy="320040"/>
+          </a:xfrm>
+          <a:prstGeom prst="rect">
+            <a:avLst/>
+          </a:prstGeom>
+          <a:noFill/>
+        </p:spPr>
+        <p:txBody>
+          <a:bodyPr wrap="none">
+            <a:spAutoFit/>
+          </a:bodyPr>
+          <a:lstStyle/>
+          <a:p>
+            <a:pPr algn="l"/>
+            <a:r>
+              <a:rPr sz="800" b="1">
+                <a:solidFill>
+                  <a:srgbClr val="C9A84C"/>
+                </a:solidFill>
+                <a:latin typeface="Calibri"/>
+              </a:rPr>
+              <a:t>APPENDIX  ·  IF ASKED</a:t>
+            </a:r>
+          </a:p>
+        </p:txBody>
+      </p:sp>
+      <p:sp>
+        <p:nvSpPr>
+          <p:cNvPr id="4" name="TextBox 3"/>
+          <p:cNvSpPr txBox="1"/>
+          <p:nvPr/>
+        </p:nvSpPr>
+        <p:spPr>
+          <a:xfrm>
+            <a:off x="502920" y="658368"/>
+            <a:ext cx="10058400" cy="640080"/>
+          </a:xfrm>
+          <a:prstGeom prst="rect">
+            <a:avLst/>
+          </a:prstGeom>
+          <a:noFill/>
+        </p:spPr>
+        <p:txBody>
+          <a:bodyPr wrap="none">
+            <a:spAutoFit/>
+          </a:bodyPr>
+          <a:lstStyle/>
+          <a:p>
+            <a:pPr algn="l"/>
+            <a:r>
+              <a:rPr sz="3400" b="1">
+                <a:solidFill>
+                  <a:srgbClr val="FFFFFF"/>
+                </a:solidFill>
+                <a:latin typeface="Georgia"/>
+              </a:rPr>
+              <a:t>Data &amp; Privacy</a:t>
+            </a:r>
+          </a:p>
+        </p:txBody>
+      </p:sp>
+      <p:sp>
+        <p:nvSpPr>
+          <p:cNvPr id="5" name="TextBox 4"/>
+          <p:cNvSpPr txBox="1"/>
+          <p:nvPr/>
+        </p:nvSpPr>
+        <p:spPr>
+          <a:xfrm>
+            <a:off x="502920" y="1261872"/>
+            <a:ext cx="10058400" cy="320040"/>
+          </a:xfrm>
+          <a:prstGeom prst="rect">
+            <a:avLst/>
+          </a:prstGeom>
+          <a:noFill/>
+        </p:spPr>
+        <p:txBody>
+          <a:bodyPr wrap="none">
+            <a:spAutoFit/>
+          </a:bodyPr>
+          <a:lstStyle/>
+          <a:p>
+            <a:r>
+              <a:rPr sz="1200">
+                <a:solidFill>
+                  <a:srgbClr val="CCD2DF"/>
+                </a:solidFill>
+                <a:latin typeface="Calibri"/>
+              </a:rPr>
+              <a:t>Architecture built for enterprise trust — key facts for any procurement or investor conversation</a:t>
+            </a:r>
+          </a:p>
+        </p:txBody>
+      </p:sp>
+      <p:sp>
+        <p:nvSpPr>
+          <p:cNvPr id="6" name="Rectangle 5"/>
+          <p:cNvSpPr/>
+          <p:nvPr/>
+        </p:nvSpPr>
+        <p:spPr>
+          <a:xfrm>
+            <a:off x="502920" y="1664208"/>
+            <a:ext cx="1097280" cy="19050"/>
+          </a:xfrm>
+          <a:prstGeom prst="rect">
+            <a:avLst/>
+          </a:prstGeom>
+          <a:solidFill>
+            <a:srgbClr val="C9A84C"/>
+          </a:solidFill>
+          <a:ln>
+            <a:noFill/>
+          </a:ln>
+        </p:spPr>
+        <p:style>
+          <a:lnRef idx="1">
+            <a:schemeClr val="accent1"/>
+          </a:lnRef>
+          <a:fillRef idx="3">
+            <a:schemeClr val="accent1"/>
+          </a:fillRef>
+          <a:effectRef idx="2">
+            <a:schemeClr val="accent1"/>
+          </a:effectRef>
+          <a:fontRef idx="minor">
+            <a:schemeClr val="lt1"/>
+          </a:fontRef>
+        </p:style>
+        <p:txBody>
+          <a:bodyPr rtlCol="0" anchor="ctr"/>
+          <a:lstStyle/>
+          <a:p>
+            <a:pPr algn="ctr"/>
+          </a:p>
+        </p:txBody>
+      </p:sp>
+      <p:sp>
+        <p:nvSpPr>
+          <p:cNvPr id="7" name="Rectangle 6"/>
+          <p:cNvSpPr/>
+          <p:nvPr/>
+        </p:nvSpPr>
+        <p:spPr>
+          <a:xfrm>
+            <a:off x="502920" y="1828800"/>
+            <a:ext cx="5303520" cy="868680"/>
+          </a:xfrm>
+          <a:prstGeom prst="rect">
+            <a:avLst/>
+          </a:prstGeom>
+          <a:solidFill>
+            <a:srgbClr val="10173A"/>
+          </a:solidFill>
+          <a:ln w="6350">
+            <a:solidFill>
+              <a:srgbClr val="1E2858"/>
+            </a:solidFill>
+          </a:ln>
+        </p:spPr>
+        <p:style>
+          <a:lnRef idx="1">
+            <a:schemeClr val="accent1"/>
+          </a:lnRef>
+          <a:fillRef idx="3">
+            <a:schemeClr val="accent1"/>
+          </a:fillRef>
+          <a:effectRef idx="2">
+            <a:schemeClr val="accent1"/>
+          </a:effectRef>
+          <a:fontRef idx="minor">
+            <a:schemeClr val="lt1"/>
+          </a:fontRef>
+        </p:style>
+        <p:txBody>
+          <a:bodyPr rtlCol="0" anchor="ctr"/>
+          <a:lstStyle/>
+          <a:p>
+            <a:pPr algn="ctr"/>
+          </a:p>
+        </p:txBody>
+      </p:sp>
+      <p:sp>
+        <p:nvSpPr>
+          <p:cNvPr id="8" name="Rectangle 7"/>
+          <p:cNvSpPr/>
+          <p:nvPr/>
+        </p:nvSpPr>
+        <p:spPr>
+          <a:xfrm>
+            <a:off x="502920" y="1828800"/>
+            <a:ext cx="38100" cy="868680"/>
+          </a:xfrm>
+          <a:prstGeom prst="rect">
+            <a:avLst/>
+          </a:prstGeom>
+          <a:solidFill>
+            <a:srgbClr val="2B8A6E"/>
+          </a:solidFill>
+          <a:ln>
+            <a:noFill/>
+          </a:ln>
+        </p:spPr>
+        <p:style>
+          <a:lnRef idx="1">
+            <a:schemeClr val="accent1"/>
+          </a:lnRef>
+          <a:fillRef idx="3">
+            <a:schemeClr val="accent1"/>
+          </a:fillRef>
+          <a:effectRef idx="2">
+            <a:schemeClr val="accent1"/>
+          </a:effectRef>
+          <a:fontRef idx="minor">
+            <a:schemeClr val="lt1"/>
+          </a:fontRef>
+        </p:style>
+        <p:txBody>
+          <a:bodyPr rtlCol="0" anchor="ctr"/>
+          <a:lstStyle/>
+          <a:p>
+            <a:pPr algn="ctr"/>
+          </a:p>
+        </p:txBody>
+      </p:sp>
+      <p:sp>
+        <p:nvSpPr>
+          <p:cNvPr id="9" name="TextBox 8"/>
+          <p:cNvSpPr txBox="1"/>
+          <p:nvPr/>
+        </p:nvSpPr>
+        <p:spPr>
+          <a:xfrm>
+            <a:off x="629920" y="1901952"/>
+            <a:ext cx="5125720" cy="256032"/>
+          </a:xfrm>
+          <a:prstGeom prst="rect">
+            <a:avLst/>
+          </a:prstGeom>
+          <a:noFill/>
+        </p:spPr>
+        <p:txBody>
+          <a:bodyPr wrap="none">
+            <a:spAutoFit/>
+          </a:bodyPr>
+          <a:lstStyle/>
+          <a:p>
+            <a:r>
+              <a:rPr sz="800" b="1">
+                <a:solidFill>
+                  <a:srgbClr val="2B8A6E"/>
+                </a:solidFill>
+                <a:latin typeface="Calibri"/>
+              </a:rPr>
+              <a:t>DATA OWNERSHIP</a:t>
+            </a:r>
+          </a:p>
+        </p:txBody>
+      </p:sp>
+      <p:sp>
+        <p:nvSpPr>
+          <p:cNvPr id="10" name="TextBox 9"/>
+          <p:cNvSpPr txBox="1"/>
+          <p:nvPr/>
+        </p:nvSpPr>
+        <p:spPr>
+          <a:xfrm>
+            <a:off x="629920" y="2121408"/>
+            <a:ext cx="5125720" cy="530352"/>
+          </a:xfrm>
+          <a:prstGeom prst="rect">
+            <a:avLst/>
+          </a:prstGeom>
+          <a:noFill/>
+        </p:spPr>
+        <p:txBody>
+          <a:bodyPr wrap="square">
+            <a:spAutoFit/>
+          </a:bodyPr>
+          <a:lstStyle/>
+          <a:p>
+            <a:r>
+              <a:rPr sz="950">
+                <a:solidFill>
+                  <a:srgbClr val="CCD2DF"/>
+                </a:solidFill>
+                <a:latin typeface="Calibri"/>
+              </a:rPr>
+              <a:t>Customer data is exclusively owned by the customer. VaughnMartin cannot access it without explicit consent.</a:t>
+            </a:r>
+          </a:p>
+        </p:txBody>
+      </p:sp>
+      <p:sp>
+        <p:nvSpPr>
+          <p:cNvPr id="11" name="Rectangle 10"/>
+          <p:cNvSpPr/>
+          <p:nvPr/>
+        </p:nvSpPr>
+        <p:spPr>
+          <a:xfrm>
+            <a:off x="6217920" y="1828800"/>
+            <a:ext cx="5303520" cy="868680"/>
+          </a:xfrm>
+          <a:prstGeom prst="rect">
+            <a:avLst/>
+          </a:prstGeom>
+          <a:solidFill>
+            <a:srgbClr val="10173A"/>
+          </a:solidFill>
+          <a:ln w="6350">
+            <a:solidFill>
+              <a:srgbClr val="1E2858"/>
+            </a:solidFill>
+          </a:ln>
+        </p:spPr>
+        <p:style>
+          <a:lnRef idx="1">
+            <a:schemeClr val="accent1"/>
+          </a:lnRef>
+          <a:fillRef idx="3">
+            <a:schemeClr val="accent1"/>
+          </a:fillRef>
+          <a:effectRef idx="2">
+            <a:schemeClr val="accent1"/>
+          </a:effectRef>
+          <a:fontRef idx="minor">
+            <a:schemeClr val="lt1"/>
+          </a:fontRef>
+        </p:style>
+        <p:txBody>
+          <a:bodyPr rtlCol="0" anchor="ctr"/>
+          <a:lstStyle/>
+          <a:p>
+            <a:pPr algn="ctr"/>
+          </a:p>
+        </p:txBody>
+      </p:sp>
+      <p:sp>
+        <p:nvSpPr>
+          <p:cNvPr id="12" name="Rectangle 11"/>
+          <p:cNvSpPr/>
+          <p:nvPr/>
+        </p:nvSpPr>
+        <p:spPr>
+          <a:xfrm>
+            <a:off x="6217920" y="1828800"/>
+            <a:ext cx="38100" cy="868680"/>
+          </a:xfrm>
+          <a:prstGeom prst="rect">
+            <a:avLst/>
+          </a:prstGeom>
+          <a:solidFill>
+            <a:srgbClr val="2B8A6E"/>
+          </a:solidFill>
+          <a:ln>
+            <a:noFill/>
+          </a:ln>
+        </p:spPr>
+        <p:style>
+          <a:lnRef idx="1">
+            <a:schemeClr val="accent1"/>
+          </a:lnRef>
+          <a:fillRef idx="3">
+            <a:schemeClr val="accent1"/>
+          </a:fillRef>
+          <a:effectRef idx="2">
+            <a:schemeClr val="accent1"/>
+          </a:effectRef>
+          <a:fontRef idx="minor">
+            <a:schemeClr val="lt1"/>
+          </a:fontRef>
+        </p:style>
+        <p:txBody>
+          <a:bodyPr rtlCol="0" anchor="ctr"/>
+          <a:lstStyle/>
+          <a:p>
+            <a:pPr algn="ctr"/>
+          </a:p>
+        </p:txBody>
+      </p:sp>
+      <p:sp>
+        <p:nvSpPr>
+          <p:cNvPr id="13" name="TextBox 12"/>
+          <p:cNvSpPr txBox="1"/>
+          <p:nvPr/>
+        </p:nvSpPr>
+        <p:spPr>
+          <a:xfrm>
+            <a:off x="6344920" y="1901952"/>
+            <a:ext cx="5125720" cy="256032"/>
+          </a:xfrm>
+          <a:prstGeom prst="rect">
+            <a:avLst/>
+          </a:prstGeom>
+          <a:noFill/>
+        </p:spPr>
+        <p:txBody>
+          <a:bodyPr wrap="none">
+            <a:spAutoFit/>
+          </a:bodyPr>
+          <a:lstStyle/>
+          <a:p>
+            <a:r>
+              <a:rPr sz="800" b="1">
+                <a:solidFill>
+                  <a:srgbClr val="2B8A6E"/>
+                </a:solidFill>
+                <a:latin typeface="Calibri"/>
+              </a:rPr>
+              <a:t>TENANT ISOLATION</a:t>
+            </a:r>
+          </a:p>
+        </p:txBody>
+      </p:sp>
+      <p:sp>
+        <p:nvSpPr>
+          <p:cNvPr id="14" name="TextBox 13"/>
+          <p:cNvSpPr txBox="1"/>
+          <p:nvPr/>
+        </p:nvSpPr>
+        <p:spPr>
+          <a:xfrm>
+            <a:off x="6344920" y="2121408"/>
+            <a:ext cx="5125720" cy="530352"/>
+          </a:xfrm>
+          <a:prstGeom prst="rect">
+            <a:avLst/>
+          </a:prstGeom>
+          <a:noFill/>
+        </p:spPr>
+        <p:txBody>
+          <a:bodyPr wrap="square">
+            <a:spAutoFit/>
+          </a:bodyPr>
+          <a:lstStyle/>
+          <a:p>
+            <a:r>
+              <a:rPr sz="950">
+                <a:solidFill>
+                  <a:srgbClr val="CCD2DF"/>
+                </a:solidFill>
+                <a:latin typeface="Calibri"/>
+              </a:rPr>
+              <a:t>Every query is organization-scoped at the database layer — cross-tenant reads are architecturally prevented.</a:t>
+            </a:r>
+          </a:p>
+        </p:txBody>
+      </p:sp>
+      <p:sp>
+        <p:nvSpPr>
+          <p:cNvPr id="15" name="Rectangle 14"/>
+          <p:cNvSpPr/>
+          <p:nvPr/>
+        </p:nvSpPr>
+        <p:spPr>
+          <a:xfrm>
+            <a:off x="502920" y="2798064"/>
+            <a:ext cx="5303520" cy="868680"/>
+          </a:xfrm>
+          <a:prstGeom prst="rect">
+            <a:avLst/>
+          </a:prstGeom>
+          <a:solidFill>
+            <a:srgbClr val="10173A"/>
+          </a:solidFill>
+          <a:ln w="6350">
+            <a:solidFill>
+              <a:srgbClr val="1E2858"/>
+            </a:solidFill>
+          </a:ln>
+        </p:spPr>
+        <p:style>
+          <a:lnRef idx="1">
+            <a:schemeClr val="accent1"/>
+          </a:lnRef>
+          <a:fillRef idx="3">
+            <a:schemeClr val="accent1"/>
+          </a:fillRef>
+          <a:effectRef idx="2">
+            <a:schemeClr val="accent1"/>
+          </a:effectRef>
+          <a:fontRef idx="minor">
+            <a:schemeClr val="lt1"/>
+          </a:fontRef>
+        </p:style>
+        <p:txBody>
+          <a:bodyPr rtlCol="0" anchor="ctr"/>
+          <a:lstStyle/>
+          <a:p>
+            <a:pPr algn="ctr"/>
+          </a:p>
+        </p:txBody>
+      </p:sp>
+      <p:sp>
+        <p:nvSpPr>
+          <p:cNvPr id="16" name="Rectangle 15"/>
+          <p:cNvSpPr/>
+          <p:nvPr/>
+        </p:nvSpPr>
+        <p:spPr>
+          <a:xfrm>
+            <a:off x="502920" y="2798064"/>
+            <a:ext cx="38100" cy="868680"/>
+          </a:xfrm>
+          <a:prstGeom prst="rect">
+            <a:avLst/>
+          </a:prstGeom>
+          <a:solidFill>
+            <a:srgbClr val="2B8A6E"/>
+          </a:solidFill>
+          <a:ln>
+            <a:noFill/>
+          </a:ln>
+        </p:spPr>
+        <p:style>
+          <a:lnRef idx="1">
+            <a:schemeClr val="accent1"/>
+          </a:lnRef>
+          <a:fillRef idx="3">
+            <a:schemeClr val="accent1"/>
+          </a:fillRef>
+          <a:effectRef idx="2">
+            <a:schemeClr val="accent1"/>
+          </a:effectRef>
+          <a:fontRef idx="minor">
+            <a:schemeClr val="lt1"/>
+          </a:fontRef>
+        </p:style>
+        <p:txBody>
+          <a:bodyPr rtlCol="0" anchor="ctr"/>
+          <a:lstStyle/>
+          <a:p>
+            <a:pPr algn="ctr"/>
+          </a:p>
+        </p:txBody>
+      </p:sp>
+      <p:sp>
+        <p:nvSpPr>
+          <p:cNvPr id="17" name="TextBox 16"/>
+          <p:cNvSpPr txBox="1"/>
+          <p:nvPr/>
+        </p:nvSpPr>
+        <p:spPr>
+          <a:xfrm>
+            <a:off x="629920" y="2871216"/>
+            <a:ext cx="5125720" cy="256032"/>
+          </a:xfrm>
+          <a:prstGeom prst="rect">
+            <a:avLst/>
+          </a:prstGeom>
+          <a:noFill/>
+        </p:spPr>
+        <p:txBody>
+          <a:bodyPr wrap="none">
+            <a:spAutoFit/>
+          </a:bodyPr>
+          <a:lstStyle/>
+          <a:p>
+            <a:r>
+              <a:rPr sz="800" b="1">
+                <a:solidFill>
+                  <a:srgbClr val="2B8A6E"/>
+                </a:solidFill>
+                <a:latin typeface="Calibri"/>
+              </a:rPr>
+              <a:t>ENCRYPTION</a:t>
+            </a:r>
+          </a:p>
+        </p:txBody>
+      </p:sp>
+      <p:sp>
+        <p:nvSpPr>
+          <p:cNvPr id="18" name="TextBox 17"/>
+          <p:cNvSpPr txBox="1"/>
+          <p:nvPr/>
+        </p:nvSpPr>
+        <p:spPr>
+          <a:xfrm>
+            <a:off x="629920" y="3090672"/>
+            <a:ext cx="5125720" cy="530352"/>
+          </a:xfrm>
+          <a:prstGeom prst="rect">
+            <a:avLst/>
+          </a:prstGeom>
+          <a:noFill/>
+        </p:spPr>
+        <p:txBody>
+          <a:bodyPr wrap="square">
+            <a:spAutoFit/>
+          </a:bodyPr>
+          <a:lstStyle/>
+          <a:p>
+            <a:r>
+              <a:rPr sz="950">
+                <a:solidFill>
+                  <a:srgbClr val="CCD2DF"/>
+                </a:solidFill>
+                <a:latin typeface="Calibri"/>
+              </a:rPr>
+              <a:t>TLS encrypted in transit. Encrypted at rest via Neon PostgreSQL (SOC 2 Type II certified infrastructure).</a:t>
+            </a:r>
+          </a:p>
+        </p:txBody>
+      </p:sp>
+      <p:sp>
+        <p:nvSpPr>
+          <p:cNvPr id="19" name="Rectangle 18"/>
+          <p:cNvSpPr/>
+          <p:nvPr/>
+        </p:nvSpPr>
+        <p:spPr>
+          <a:xfrm>
+            <a:off x="6217920" y="2798064"/>
+            <a:ext cx="5303520" cy="868680"/>
+          </a:xfrm>
+          <a:prstGeom prst="rect">
+            <a:avLst/>
+          </a:prstGeom>
+          <a:solidFill>
+            <a:srgbClr val="10173A"/>
+          </a:solidFill>
+          <a:ln w="6350">
+            <a:solidFill>
+              <a:srgbClr val="1E2858"/>
+            </a:solidFill>
+          </a:ln>
+        </p:spPr>
+        <p:style>
+          <a:lnRef idx="1">
+            <a:schemeClr val="accent1"/>
+          </a:lnRef>
+          <a:fillRef idx="3">
+            <a:schemeClr val="accent1"/>
+          </a:fillRef>
+          <a:effectRef idx="2">
+            <a:schemeClr val="accent1"/>
+          </a:effectRef>
+          <a:fontRef idx="minor">
+            <a:schemeClr val="lt1"/>
+          </a:fontRef>
+        </p:style>
+        <p:txBody>
+          <a:bodyPr rtlCol="0" anchor="ctr"/>
+          <a:lstStyle/>
+          <a:p>
+            <a:pPr algn="ctr"/>
+          </a:p>
+        </p:txBody>
+      </p:sp>
+      <p:sp>
+        <p:nvSpPr>
+          <p:cNvPr id="20" name="Rectangle 19"/>
+          <p:cNvSpPr/>
+          <p:nvPr/>
+        </p:nvSpPr>
+        <p:spPr>
+          <a:xfrm>
+            <a:off x="6217920" y="2798064"/>
+            <a:ext cx="38100" cy="868680"/>
+          </a:xfrm>
+          <a:prstGeom prst="rect">
+            <a:avLst/>
+          </a:prstGeom>
+          <a:solidFill>
+            <a:srgbClr val="2B8A6E"/>
+          </a:solidFill>
+          <a:ln>
+            <a:noFill/>
+          </a:ln>
+        </p:spPr>
+        <p:style>
+          <a:lnRef idx="1">
+            <a:schemeClr val="accent1"/>
+          </a:lnRef>
+          <a:fillRef idx="3">
+            <a:schemeClr val="accent1"/>
+          </a:fillRef>
+          <a:effectRef idx="2">
+            <a:schemeClr val="accent1"/>
+          </a:effectRef>
+          <a:fontRef idx="minor">
+            <a:schemeClr val="lt1"/>
+          </a:fontRef>
+        </p:style>
+        <p:txBody>
+          <a:bodyPr rtlCol="0" anchor="ctr"/>
+          <a:lstStyle/>
+          <a:p>
+            <a:pPr algn="ctr"/>
+          </a:p>
+        </p:txBody>
+      </p:sp>
+      <p:sp>
+        <p:nvSpPr>
+          <p:cNvPr id="21" name="TextBox 20"/>
+          <p:cNvSpPr txBox="1"/>
+          <p:nvPr/>
+        </p:nvSpPr>
+        <p:spPr>
+          <a:xfrm>
+            <a:off x="6344920" y="2871216"/>
+            <a:ext cx="5125720" cy="256032"/>
+          </a:xfrm>
+          <a:prstGeom prst="rect">
+            <a:avLst/>
+          </a:prstGeom>
+          <a:noFill/>
+        </p:spPr>
+        <p:txBody>
+          <a:bodyPr wrap="none">
+            <a:spAutoFit/>
+          </a:bodyPr>
+          <a:lstStyle/>
+          <a:p>
+            <a:r>
+              <a:rPr sz="800" b="1">
+                <a:solidFill>
+                  <a:srgbClr val="2B8A6E"/>
+                </a:solidFill>
+                <a:latin typeface="Calibri"/>
+              </a:rPr>
+              <a:t>AI &amp; MODEL SAFETY</a:t>
+            </a:r>
+          </a:p>
+        </p:txBody>
+      </p:sp>
+      <p:sp>
+        <p:nvSpPr>
+          <p:cNvPr id="22" name="TextBox 21"/>
+          <p:cNvSpPr txBox="1"/>
+          <p:nvPr/>
+        </p:nvSpPr>
+        <p:spPr>
+          <a:xfrm>
+            <a:off x="6344920" y="3090672"/>
+            <a:ext cx="5125720" cy="530352"/>
+          </a:xfrm>
+          <a:prstGeom prst="rect">
+            <a:avLst/>
+          </a:prstGeom>
+          <a:noFill/>
+        </p:spPr>
+        <p:txBody>
+          <a:bodyPr wrap="square">
+            <a:spAutoFit/>
+          </a:bodyPr>
+          <a:lstStyle/>
+          <a:p>
+            <a:r>
+              <a:rPr sz="950">
+                <a:solidFill>
+                  <a:srgbClr val="CCD2DF"/>
+                </a:solidFill>
+                <a:latin typeface="Calibri"/>
+              </a:rPr>
+              <a:t>All AI processing runs through Azure OpenAI under enterprise data processing agreements — your data does not train the models. AI analysis is sandboxed and cannot directly modify org data.</a:t>
+            </a:r>
+          </a:p>
+        </p:txBody>
+      </p:sp>
+      <p:sp>
+        <p:nvSpPr>
+          <p:cNvPr id="23" name="Rectangle 22"/>
+          <p:cNvSpPr/>
+          <p:nvPr/>
+        </p:nvSpPr>
+        <p:spPr>
+          <a:xfrm>
+            <a:off x="502920" y="3767328"/>
+            <a:ext cx="5303520" cy="868680"/>
+          </a:xfrm>
+          <a:prstGeom prst="rect">
+            <a:avLst/>
+          </a:prstGeom>
+          <a:solidFill>
+            <a:srgbClr val="10173A"/>
+          </a:solidFill>
+          <a:ln w="6350">
+            <a:solidFill>
+              <a:srgbClr val="1E2858"/>
+            </a:solidFill>
+          </a:ln>
+        </p:spPr>
+        <p:style>
+          <a:lnRef idx="1">
+            <a:schemeClr val="accent1"/>
+          </a:lnRef>
+          <a:fillRef idx="3">
+            <a:schemeClr val="accent1"/>
+          </a:fillRef>
+          <a:effectRef idx="2">
+            <a:schemeClr val="accent1"/>
+          </a:effectRef>
+          <a:fontRef idx="minor">
+            <a:schemeClr val="lt1"/>
+          </a:fontRef>
+        </p:style>
+        <p:txBody>
+          <a:bodyPr rtlCol="0" anchor="ctr"/>
+          <a:lstStyle/>
+          <a:p>
+            <a:pPr algn="ctr"/>
+          </a:p>
+        </p:txBody>
+      </p:sp>
+      <p:sp>
+        <p:nvSpPr>
+          <p:cNvPr id="24" name="Rectangle 23"/>
+          <p:cNvSpPr/>
+          <p:nvPr/>
+        </p:nvSpPr>
+        <p:spPr>
+          <a:xfrm>
+            <a:off x="502920" y="3767328"/>
+            <a:ext cx="38100" cy="868680"/>
+          </a:xfrm>
+          <a:prstGeom prst="rect">
+            <a:avLst/>
+          </a:prstGeom>
+          <a:solidFill>
+            <a:srgbClr val="2B8A6E"/>
+          </a:solidFill>
+          <a:ln>
+            <a:noFill/>
+          </a:ln>
+        </p:spPr>
+        <p:style>
+          <a:lnRef idx="1">
+            <a:schemeClr val="accent1"/>
+          </a:lnRef>
+          <a:fillRef idx="3">
+            <a:schemeClr val="accent1"/>
+          </a:fillRef>
+          <a:effectRef idx="2">
+            <a:schemeClr val="accent1"/>
+          </a:effectRef>
+          <a:fontRef idx="minor">
+            <a:schemeClr val="lt1"/>
+          </a:fontRef>
+        </p:style>
+        <p:txBody>
+          <a:bodyPr rtlCol="0" anchor="ctr"/>
+          <a:lstStyle/>
+          <a:p>
+            <a:pPr algn="ctr"/>
+          </a:p>
+        </p:txBody>
+      </p:sp>
+      <p:sp>
+        <p:nvSpPr>
+          <p:cNvPr id="25" name="TextBox 24"/>
+          <p:cNvSpPr txBox="1"/>
+          <p:nvPr/>
+        </p:nvSpPr>
+        <p:spPr>
+          <a:xfrm>
+            <a:off x="629920" y="3840480"/>
+            <a:ext cx="5125720" cy="256032"/>
+          </a:xfrm>
+          <a:prstGeom prst="rect">
+            <a:avLst/>
+          </a:prstGeom>
+          <a:noFill/>
+        </p:spPr>
+        <p:txBody>
+          <a:bodyPr wrap="none">
+            <a:spAutoFit/>
+          </a:bodyPr>
+          <a:lstStyle/>
+          <a:p>
+            <a:r>
+              <a:rPr sz="800" b="1">
+                <a:solidFill>
+                  <a:srgbClr val="2B8A6E"/>
+                </a:solidFill>
+                <a:latin typeface="Calibri"/>
+              </a:rPr>
+              <a:t>GDPR ALIGNMENT</a:t>
+            </a:r>
+          </a:p>
+        </p:txBody>
+      </p:sp>
+      <p:sp>
+        <p:nvSpPr>
+          <p:cNvPr id="26" name="TextBox 25"/>
+          <p:cNvSpPr txBox="1"/>
+          <p:nvPr/>
+        </p:nvSpPr>
+        <p:spPr>
+          <a:xfrm>
+            <a:off x="629920" y="4059936"/>
+            <a:ext cx="5125720" cy="530352"/>
+          </a:xfrm>
+          <a:prstGeom prst="rect">
+            <a:avLst/>
+          </a:prstGeom>
+          <a:noFill/>
+        </p:spPr>
+        <p:txBody>
+          <a:bodyPr wrap="square">
+            <a:spAutoFit/>
+          </a:bodyPr>
+          <a:lstStyle/>
+          <a:p>
+            <a:r>
+              <a:rPr sz="950">
+                <a:solidFill>
+                  <a:srgbClr val="CCD2DF"/>
+                </a:solidFill>
+                <a:latin typeface="Calibri"/>
+              </a:rPr>
+              <a:t>Consent-based access, customer-controlled data deletion, and configurable retention policies are built in.</a:t>
+            </a:r>
+          </a:p>
+        </p:txBody>
+      </p:sp>
+      <p:sp>
+        <p:nvSpPr>
+          <p:cNvPr id="27" name="Rectangle 26"/>
+          <p:cNvSpPr/>
+          <p:nvPr/>
+        </p:nvSpPr>
+        <p:spPr>
+          <a:xfrm>
+            <a:off x="6217920" y="3767328"/>
+            <a:ext cx="5303520" cy="868680"/>
+          </a:xfrm>
+          <a:prstGeom prst="rect">
+            <a:avLst/>
+          </a:prstGeom>
+          <a:solidFill>
+            <a:srgbClr val="10173A"/>
+          </a:solidFill>
+          <a:ln w="6350">
+            <a:solidFill>
+              <a:srgbClr val="1E2858"/>
+            </a:solidFill>
+          </a:ln>
+        </p:spPr>
+        <p:style>
+          <a:lnRef idx="1">
+            <a:schemeClr val="accent1"/>
+          </a:lnRef>
+          <a:fillRef idx="3">
+            <a:schemeClr val="accent1"/>
+          </a:fillRef>
+          <a:effectRef idx="2">
+            <a:schemeClr val="accent1"/>
+          </a:effectRef>
+          <a:fontRef idx="minor">
+            <a:schemeClr val="lt1"/>
+          </a:fontRef>
+        </p:style>
+        <p:txBody>
+          <a:bodyPr rtlCol="0" anchor="ctr"/>
+          <a:lstStyle/>
+          <a:p>
+            <a:pPr algn="ctr"/>
+          </a:p>
+        </p:txBody>
+      </p:sp>
+      <p:sp>
+        <p:nvSpPr>
+          <p:cNvPr id="28" name="Rectangle 27"/>
+          <p:cNvSpPr/>
+          <p:nvPr/>
+        </p:nvSpPr>
+        <p:spPr>
+          <a:xfrm>
+            <a:off x="6217920" y="3767328"/>
+            <a:ext cx="38100" cy="868680"/>
+          </a:xfrm>
+          <a:prstGeom prst="rect">
+            <a:avLst/>
+          </a:prstGeom>
+          <a:solidFill>
+            <a:srgbClr val="2B8A6E"/>
+          </a:solidFill>
+          <a:ln>
+            <a:noFill/>
+          </a:ln>
+        </p:spPr>
+        <p:style>
+          <a:lnRef idx="1">
+            <a:schemeClr val="accent1"/>
+          </a:lnRef>
+          <a:fillRef idx="3">
+            <a:schemeClr val="accent1"/>
+          </a:fillRef>
+          <a:effectRef idx="2">
+            <a:schemeClr val="accent1"/>
+          </a:effectRef>
+          <a:fontRef idx="minor">
+            <a:schemeClr val="lt1"/>
+          </a:fontRef>
+        </p:style>
+        <p:txBody>
+          <a:bodyPr rtlCol="0" anchor="ctr"/>
+          <a:lstStyle/>
+          <a:p>
+            <a:pPr algn="ctr"/>
+          </a:p>
+        </p:txBody>
+      </p:sp>
+      <p:sp>
+        <p:nvSpPr>
+          <p:cNvPr id="29" name="TextBox 28"/>
+          <p:cNvSpPr txBox="1"/>
+          <p:nvPr/>
+        </p:nvSpPr>
+        <p:spPr>
+          <a:xfrm>
+            <a:off x="6344920" y="3840480"/>
+            <a:ext cx="5125720" cy="256032"/>
+          </a:xfrm>
+          <a:prstGeom prst="rect">
+            <a:avLst/>
+          </a:prstGeom>
+          <a:noFill/>
+        </p:spPr>
+        <p:txBody>
+          <a:bodyPr wrap="none">
+            <a:spAutoFit/>
+          </a:bodyPr>
+          <a:lstStyle/>
+          <a:p>
+            <a:r>
+              <a:rPr sz="800" b="1">
+                <a:solidFill>
+                  <a:srgbClr val="2B8A6E"/>
+                </a:solidFill>
+                <a:latin typeface="Calibri"/>
+              </a:rPr>
+              <a:t>SOC 2 ROADMAP</a:t>
+            </a:r>
+          </a:p>
+        </p:txBody>
+      </p:sp>
+      <p:sp>
+        <p:nvSpPr>
+          <p:cNvPr id="30" name="TextBox 29"/>
+          <p:cNvSpPr txBox="1"/>
+          <p:nvPr/>
+        </p:nvSpPr>
+        <p:spPr>
+          <a:xfrm>
+            <a:off x="6344920" y="4059936"/>
+            <a:ext cx="5125720" cy="530352"/>
+          </a:xfrm>
+          <a:prstGeom prst="rect">
+            <a:avLst/>
+          </a:prstGeom>
+          <a:noFill/>
+        </p:spPr>
+        <p:txBody>
+          <a:bodyPr wrap="square">
+            <a:spAutoFit/>
+          </a:bodyPr>
+          <a:lstStyle/>
+          <a:p>
+            <a:r>
+              <a:rPr sz="950">
+                <a:solidFill>
+                  <a:srgbClr val="CCD2DF"/>
+                </a:solidFill>
+                <a:latin typeface="Calibri"/>
+              </a:rPr>
+              <a:t>Database infrastructure is SOC 2 Type II certified today. Platform-level audit is on the GA roadmap. Architecture documentation available on request.</a:t>
+            </a:r>
+          </a:p>
+        </p:txBody>
+      </p:sp>
+      <p:sp>
+        <p:nvSpPr>
+          <p:cNvPr id="31" name="TextBox 30"/>
+          <p:cNvSpPr txBox="1"/>
+          <p:nvPr/>
+        </p:nvSpPr>
+        <p:spPr>
+          <a:xfrm>
+            <a:off x="502920" y="6327648"/>
+            <a:ext cx="10972800" cy="292608"/>
+          </a:xfrm>
+          <a:prstGeom prst="rect">
+            <a:avLst/>
+          </a:prstGeom>
+          <a:noFill/>
+        </p:spPr>
+        <p:txBody>
+          <a:bodyPr wrap="none">
+            <a:spAutoFit/>
+          </a:bodyPr>
+          <a:lstStyle/>
+          <a:p>
+            <a:pPr algn="ctr"/>
+            <a:r>
+              <a:rPr sz="850">
+                <a:solidFill>
+                  <a:srgbClr val="C9A84C"/>
+                </a:solidFill>
+                <a:latin typeface="Calibri"/>
+              </a:rPr>
+              <a:t>Full procurement-ready security overview available at /security-compliance  ·  Architecture documentation available on request</a:t>
             </a:r>
           </a:p>
         </p:txBody>

</xml_diff>

<commit_message>
Update the pitch deck with requested feedback
Modify presentation slides to address clipping issues, align calls to action, clarify performance metrics, and adjust fund allocation.

Replit-Commit-Author: Agent
Replit-Commit-Session-Id: 85f09f3c-352d-446d-b98e-3f307c26fc5a
Replit-Commit-Checkpoint-Type: full_checkpoint
Replit-Commit-Event-Id: 31e047f5-78db-4ce6-8a0b-1727c04471ad
Replit-Commit-Screenshot-Url: https://storage.googleapis.com/screenshot-production-us-central1/3bd53afc-ff4f-401b-9e3d-b367791ef629/85f09f3c-352d-446d-b98e-3f307c26fc5a/jSCsBno
Replit-Helium-Checkpoint-Created: true
</commit_message>
<xml_diff>
--- a/attached_assets/VaughnMartin-4min-Pitch.pptx
+++ b/attached_assets/VaughnMartin-4min-Pitch.pptx
@@ -4774,7 +4774,7 @@
           <a:p>
             <a:pPr algn="l"/>
             <a:r>
-              <a:rPr sz="4400" b="1" i="0">
+              <a:rPr sz="3600" b="1" i="0">
                 <a:solidFill>
                   <a:srgbClr val="FFFFFF"/>
                 </a:solidFill>
@@ -5393,7 +5393,7 @@
                 </a:solidFill>
                 <a:latin typeface="Calibri"/>
               </a:rPr>
-              <a:t>FOUNDING PARTNER PROGRAM</a:t>
+              <a:t>SCHEDULE A CONVERSATION</a:t>
             </a:r>
           </a:p>
         </p:txBody>
@@ -6075,7 +6075,7 @@
                 </a:solidFill>
                 <a:latin typeface="Calibri"/>
               </a:rPr>
-              <a:t>APPLY FOR FOUNDING PARTNER ACCESS</a:t>
+              <a:t>SCHEDULE A CONVERSATION</a:t>
             </a:r>
           </a:p>
         </p:txBody>
@@ -9000,11 +9000,11 @@
             <a:r>
               <a:rPr sz="2000" b="1" i="0">
                 <a:solidFill>
-                  <a:srgbClr val="2B8A6E"/>
+                  <a:srgbClr val="C9A84C"/>
                 </a:solidFill>
                 <a:latin typeface="Georgia"/>
               </a:rPr>
-              <a:t>01</a:t>
+              <a:t>1</a:t>
             </a:r>
           </a:p>
         </p:txBody>
@@ -9238,7 +9238,7 @@
                 </a:solidFill>
                 <a:latin typeface="Georgia"/>
               </a:rPr>
-              <a:t>02</a:t>
+              <a:t>2</a:t>
             </a:r>
           </a:p>
         </p:txBody>
@@ -9468,11 +9468,11 @@
             <a:r>
               <a:rPr sz="2000" b="1" i="0">
                 <a:solidFill>
-                  <a:srgbClr val="FFFFFF"/>
+                  <a:srgbClr val="C9A84C"/>
                 </a:solidFill>
                 <a:latin typeface="Georgia"/>
               </a:rPr>
-              <a:t>03</a:t>
+              <a:t>3</a:t>
             </a:r>
           </a:p>
         </p:txBody>
@@ -9706,7 +9706,7 @@
                 </a:solidFill>
                 <a:latin typeface="Georgia"/>
               </a:rPr>
-              <a:t>04</a:t>
+              <a:t>4</a:t>
             </a:r>
           </a:p>
         </p:txBody>
@@ -9936,11 +9936,11 @@
             <a:r>
               <a:rPr sz="2000" b="1" i="0">
                 <a:solidFill>
-                  <a:srgbClr val="2B8A6E"/>
+                  <a:srgbClr val="C9A84C"/>
                 </a:solidFill>
                 <a:latin typeface="Georgia"/>
               </a:rPr>
-              <a:t>05</a:t>
+              <a:t>5</a:t>
             </a:r>
           </a:p>
         </p:txBody>
@@ -13603,7 +13603,7 @@
                 </a:solidFill>
                 <a:latin typeface="Calibri"/>
               </a:rPr>
-              <a:t>→  67% avg improvement in execution time over 6 months</a:t>
+              <a:t>→  67% avg improvement in execution time over 6 months (simulation-validated)</a:t>
             </a:r>
           </a:p>
         </p:txBody>
@@ -16510,7 +16510,7 @@
             <a:r>
               <a:rPr sz="800" b="1" i="0">
                 <a:solidFill>
-                  <a:srgbClr val="AAB4CC"/>
+                  <a:srgbClr val="CCD2DF"/>
                 </a:solidFill>
                 <a:latin typeface="Calibri"/>
               </a:rPr>
@@ -16894,7 +16894,7 @@
                 </a:solidFill>
                 <a:latin typeface="Georgia"/>
               </a:rPr>
-              <a:t>$60K–$120K/yr</a:t>
+              <a:t>$75K–$120K/yr</a:t>
             </a:r>
           </a:p>
         </p:txBody>
@@ -18288,7 +18288,7 @@
                 </a:solidFill>
                 <a:latin typeface="Calibri"/>
               </a:rPr>
-              <a:t>USE OF FUNDS:  60% Product &amp; Engineering  ·  25% Go-to-Market  ·  15% Operations</a:t>
+              <a:t>USE OF FUNDS:  40% Go-to-Market  ·  35% Engineering  ·  15% Operations  ·  10% Reserves</a:t>
             </a:r>
           </a:p>
         </p:txBody>

</xml_diff>

<commit_message>
Add live product screenshots to the investor pitch deck appendix
Update presentation file metadata and the presentation itself to include new appendix slides showcasing live product features.

Replit-Commit-Author: Agent
Replit-Commit-Session-Id: 85f09f3c-352d-446d-b98e-3f307c26fc5a
Replit-Commit-Checkpoint-Type: full_checkpoint
Replit-Commit-Event-Id: cd7e8be8-f9d6-4f93-8250-a97dd75fee48
Replit-Commit-Screenshot-Url: https://storage.googleapis.com/screenshot-production-us-central1/3bd53afc-ff4f-401b-9e3d-b367791ef629/85f09f3c-352d-446d-b98e-3f307c26fc5a/jSCsBno
Replit-Helium-Checkpoint-Created: true
</commit_message>
<xml_diff>
--- a/attached_assets/VaughnMartin-4min-Pitch.pptx
+++ b/attached_assets/VaughnMartin-4min-Pitch.pptx
@@ -16,6 +16,8 @@
     <p:sldId id="264" r:id="rId16"/>
     <p:sldId id="265" r:id="rId17"/>
     <p:sldId id="266" r:id="rId18"/>
+    <p:sldId id="267" r:id="rId19"/>
+    <p:sldId id="268" r:id="rId20"/>
   </p:sldIdLst>
   <p:sldSz cx="12188952" cy="6858000" type="screen4x3"/>
   <p:notesSz cx="6858000" cy="9144000"/>
@@ -7469,6 +7471,1238 @@
                 <a:latin typeface="Calibri"/>
               </a:rPr>
               <a:t>Full procurement-ready security overview available at /security-compliance  ·  Architecture documentation available on request</a:t>
+            </a:r>
+          </a:p>
+        </p:txBody>
+      </p:sp>
+    </p:spTree>
+  </p:cSld>
+  <p:clrMapOvr>
+    <a:masterClrMapping/>
+  </p:clrMapOvr>
+</p:sld>
+</file>
+
+<file path=ppt/slides/slide12.xml><?xml version="1.0" encoding="utf-8"?>
+<p:sld xmlns:a="http://schemas.openxmlformats.org/drawingml/2006/main" xmlns:p="http://schemas.openxmlformats.org/presentationml/2006/main" xmlns:r="http://schemas.openxmlformats.org/officeDocument/2006/relationships">
+  <p:cSld>
+    <p:bg>
+      <p:bgPr>
+        <a:solidFill>
+          <a:srgbClr val="0A0F2E"/>
+        </a:solidFill>
+        <a:effectLst/>
+      </p:bgPr>
+    </p:bg>
+    <p:spTree>
+      <p:nvGrpSpPr>
+        <p:cNvPr id="1" name=""/>
+        <p:cNvGrpSpPr/>
+        <p:nvPr/>
+      </p:nvGrpSpPr>
+      <p:grpSpPr/>
+      <p:sp>
+        <p:nvSpPr>
+          <p:cNvPr id="2" name="Rectangle 1"/>
+          <p:cNvSpPr/>
+          <p:nvPr/>
+        </p:nvSpPr>
+        <p:spPr>
+          <a:xfrm>
+            <a:off x="0" y="502920"/>
+            <a:ext cx="12188952" cy="25400"/>
+          </a:xfrm>
+          <a:prstGeom prst="rect">
+            <a:avLst/>
+          </a:prstGeom>
+          <a:solidFill>
+            <a:srgbClr val="C9A84C"/>
+          </a:solidFill>
+          <a:ln>
+            <a:noFill/>
+          </a:ln>
+        </p:spPr>
+        <p:style>
+          <a:lnRef idx="1">
+            <a:schemeClr val="accent1"/>
+          </a:lnRef>
+          <a:fillRef idx="3">
+            <a:schemeClr val="accent1"/>
+          </a:fillRef>
+          <a:effectRef idx="2">
+            <a:schemeClr val="accent1"/>
+          </a:effectRef>
+          <a:fontRef idx="minor">
+            <a:schemeClr val="lt1"/>
+          </a:fontRef>
+        </p:style>
+        <p:txBody>
+          <a:bodyPr rtlCol="0" anchor="ctr"/>
+          <a:lstStyle/>
+          <a:p>
+            <a:pPr algn="ctr"/>
+          </a:p>
+        </p:txBody>
+      </p:sp>
+      <p:sp>
+        <p:nvSpPr>
+          <p:cNvPr id="3" name="TextBox 2"/>
+          <p:cNvSpPr txBox="1"/>
+          <p:nvPr/>
+        </p:nvSpPr>
+        <p:spPr>
+          <a:xfrm>
+            <a:off x="502920" y="201168"/>
+            <a:ext cx="9144000" cy="320040"/>
+          </a:xfrm>
+          <a:prstGeom prst="rect">
+            <a:avLst/>
+          </a:prstGeom>
+          <a:noFill/>
+        </p:spPr>
+        <p:txBody>
+          <a:bodyPr wrap="square">
+            <a:spAutoFit/>
+          </a:bodyPr>
+          <a:lstStyle/>
+          <a:p>
+            <a:pPr algn="l"/>
+            <a:r>
+              <a:rPr sz="800" b="1">
+                <a:solidFill>
+                  <a:srgbClr val="C9A84C"/>
+                </a:solidFill>
+                <a:latin typeface="Calibri"/>
+              </a:rPr>
+              <a:t>APPENDIX  ·  LIVE PRODUCT — SIGNAL INTELLIGENCE &amp; EXECUTION</a:t>
+            </a:r>
+          </a:p>
+        </p:txBody>
+      </p:sp>
+      <p:sp>
+        <p:nvSpPr>
+          <p:cNvPr id="4" name="TextBox 3"/>
+          <p:cNvSpPr txBox="1"/>
+          <p:nvPr/>
+        </p:nvSpPr>
+        <p:spPr>
+          <a:xfrm>
+            <a:off x="502920" y="621792"/>
+            <a:ext cx="10972800" cy="548640"/>
+          </a:xfrm>
+          <a:prstGeom prst="rect">
+            <a:avLst/>
+          </a:prstGeom>
+          <a:noFill/>
+        </p:spPr>
+        <p:txBody>
+          <a:bodyPr wrap="square">
+            <a:spAutoFit/>
+          </a:bodyPr>
+          <a:lstStyle/>
+          <a:p>
+            <a:pPr algn="l"/>
+            <a:r>
+              <a:rPr sz="2800" b="1">
+                <a:solidFill>
+                  <a:srgbClr val="FFFFFF"/>
+                </a:solidFill>
+                <a:latin typeface="Georgia"/>
+              </a:rPr>
+              <a:t>The System Is Always On.</a:t>
+            </a:r>
+          </a:p>
+        </p:txBody>
+      </p:sp>
+      <p:sp>
+        <p:nvSpPr>
+          <p:cNvPr id="5" name="TextBox 4"/>
+          <p:cNvSpPr txBox="1"/>
+          <p:nvPr/>
+        </p:nvSpPr>
+        <p:spPr>
+          <a:xfrm>
+            <a:off x="502920" y="1170432"/>
+            <a:ext cx="10058400" cy="320040"/>
+          </a:xfrm>
+          <a:prstGeom prst="rect">
+            <a:avLst/>
+          </a:prstGeom>
+          <a:noFill/>
+        </p:spPr>
+        <p:txBody>
+          <a:bodyPr wrap="square">
+            <a:spAutoFit/>
+          </a:bodyPr>
+          <a:lstStyle/>
+          <a:p>
+            <a:pPr algn="l"/>
+            <a:r>
+              <a:rPr sz="1100" b="0">
+                <a:solidFill>
+                  <a:srgbClr val="CCD2DF"/>
+                </a:solidFill>
+                <a:latin typeface="Calibri"/>
+              </a:rPr>
+              <a:t>Live signal monitoring → trigger detection → protocol staged → war room open. All in 12 minutes.</a:t>
+            </a:r>
+          </a:p>
+        </p:txBody>
+      </p:sp>
+      <p:sp>
+        <p:nvSpPr>
+          <p:cNvPr id="6" name="Rectangle 5"/>
+          <p:cNvSpPr/>
+          <p:nvPr/>
+        </p:nvSpPr>
+        <p:spPr>
+          <a:xfrm>
+            <a:off x="502920" y="1536192"/>
+            <a:ext cx="1280160" cy="19050"/>
+          </a:xfrm>
+          <a:prstGeom prst="rect">
+            <a:avLst/>
+          </a:prstGeom>
+          <a:solidFill>
+            <a:srgbClr val="C9A84C"/>
+          </a:solidFill>
+          <a:ln>
+            <a:noFill/>
+          </a:ln>
+        </p:spPr>
+        <p:style>
+          <a:lnRef idx="1">
+            <a:schemeClr val="accent1"/>
+          </a:lnRef>
+          <a:fillRef idx="3">
+            <a:schemeClr val="accent1"/>
+          </a:fillRef>
+          <a:effectRef idx="2">
+            <a:schemeClr val="accent1"/>
+          </a:effectRef>
+          <a:fontRef idx="minor">
+            <a:schemeClr val="lt1"/>
+          </a:fontRef>
+        </p:style>
+        <p:txBody>
+          <a:bodyPr rtlCol="0" anchor="ctr"/>
+          <a:lstStyle/>
+          <a:p>
+            <a:pPr algn="ctr"/>
+          </a:p>
+        </p:txBody>
+      </p:sp>
+      <p:sp>
+        <p:nvSpPr>
+          <p:cNvPr id="7" name="Rectangle 6"/>
+          <p:cNvSpPr/>
+          <p:nvPr/>
+        </p:nvSpPr>
+        <p:spPr>
+          <a:xfrm>
+            <a:off x="502920" y="1755648"/>
+            <a:ext cx="5532120" cy="4709160"/>
+          </a:xfrm>
+          <a:prstGeom prst="rect">
+            <a:avLst/>
+          </a:prstGeom>
+          <a:solidFill>
+            <a:srgbClr val="10173A"/>
+          </a:solidFill>
+          <a:ln w="9525">
+            <a:solidFill>
+              <a:srgbClr val="1E2858"/>
+            </a:solidFill>
+          </a:ln>
+        </p:spPr>
+        <p:style>
+          <a:lnRef idx="1">
+            <a:schemeClr val="accent1"/>
+          </a:lnRef>
+          <a:fillRef idx="3">
+            <a:schemeClr val="accent1"/>
+          </a:fillRef>
+          <a:effectRef idx="2">
+            <a:schemeClr val="accent1"/>
+          </a:effectRef>
+          <a:fontRef idx="minor">
+            <a:schemeClr val="lt1"/>
+          </a:fontRef>
+        </p:style>
+        <p:txBody>
+          <a:bodyPr rtlCol="0" anchor="ctr"/>
+          <a:lstStyle/>
+          <a:p>
+            <a:pPr algn="ctr"/>
+          </a:p>
+        </p:txBody>
+      </p:sp>
+      <p:sp>
+        <p:nvSpPr>
+          <p:cNvPr id="8" name="Rectangle 7"/>
+          <p:cNvSpPr/>
+          <p:nvPr/>
+        </p:nvSpPr>
+        <p:spPr>
+          <a:xfrm>
+            <a:off x="502920" y="1755648"/>
+            <a:ext cx="5532120" cy="31750"/>
+          </a:xfrm>
+          <a:prstGeom prst="rect">
+            <a:avLst/>
+          </a:prstGeom>
+          <a:solidFill>
+            <a:srgbClr val="2B8A6E"/>
+          </a:solidFill>
+          <a:ln>
+            <a:noFill/>
+          </a:ln>
+        </p:spPr>
+        <p:style>
+          <a:lnRef idx="1">
+            <a:schemeClr val="accent1"/>
+          </a:lnRef>
+          <a:fillRef idx="3">
+            <a:schemeClr val="accent1"/>
+          </a:fillRef>
+          <a:effectRef idx="2">
+            <a:schemeClr val="accent1"/>
+          </a:effectRef>
+          <a:fontRef idx="minor">
+            <a:schemeClr val="lt1"/>
+          </a:fontRef>
+        </p:style>
+        <p:txBody>
+          <a:bodyPr rtlCol="0" anchor="ctr"/>
+          <a:lstStyle/>
+          <a:p>
+            <a:pPr algn="ctr"/>
+          </a:p>
+        </p:txBody>
+      </p:sp>
+      <p:pic>
+        <p:nvPicPr>
+          <p:cNvPr id="9" name="Picture 8" descr="hq_command_tower.jpg"/>
+          <p:cNvPicPr>
+            <a:picLocks noChangeAspect="1"/>
+          </p:cNvPicPr>
+          <p:nvPr/>
+        </p:nvPicPr>
+        <p:blipFill>
+          <a:blip r:embed="rId2"/>
+          <a:stretch>
+            <a:fillRect/>
+          </a:stretch>
+        </p:blipFill>
+        <p:spPr>
+          <a:xfrm>
+            <a:off x="557784" y="1847088"/>
+            <a:ext cx="5422392" cy="3730752"/>
+          </a:xfrm>
+          <a:prstGeom prst="rect">
+            <a:avLst/>
+          </a:prstGeom>
+        </p:spPr>
+      </p:pic>
+      <p:sp>
+        <p:nvSpPr>
+          <p:cNvPr id="10" name="TextBox 9"/>
+          <p:cNvSpPr txBox="1"/>
+          <p:nvPr/>
+        </p:nvSpPr>
+        <p:spPr>
+          <a:xfrm>
+            <a:off x="640080" y="5650992"/>
+            <a:ext cx="5257800" cy="292608"/>
+          </a:xfrm>
+          <a:prstGeom prst="rect">
+            <a:avLst/>
+          </a:prstGeom>
+          <a:noFill/>
+        </p:spPr>
+        <p:txBody>
+          <a:bodyPr wrap="square">
+            <a:spAutoFit/>
+          </a:bodyPr>
+          <a:lstStyle/>
+          <a:p>
+            <a:pPr algn="l"/>
+            <a:r>
+              <a:rPr sz="1000" b="1">
+                <a:solidFill>
+                  <a:srgbClr val="FFFFFF"/>
+                </a:solidFill>
+                <a:latin typeface="Calibri"/>
+              </a:rPr>
+              <a:t>COMMAND TOWER — LIVE SIGNAL FEED</a:t>
+            </a:r>
+          </a:p>
+        </p:txBody>
+      </p:sp>
+      <p:sp>
+        <p:nvSpPr>
+          <p:cNvPr id="11" name="TextBox 10"/>
+          <p:cNvSpPr txBox="1"/>
+          <p:nvPr/>
+        </p:nvSpPr>
+        <p:spPr>
+          <a:xfrm>
+            <a:off x="640080" y="5907024"/>
+            <a:ext cx="5257800" cy="402336"/>
+          </a:xfrm>
+          <a:prstGeom prst="rect">
+            <a:avLst/>
+          </a:prstGeom>
+          <a:noFill/>
+        </p:spPr>
+        <p:txBody>
+          <a:bodyPr wrap="square">
+            <a:spAutoFit/>
+          </a:bodyPr>
+          <a:lstStyle/>
+          <a:p>
+            <a:pPr algn="l"/>
+            <a:r>
+              <a:rPr sz="850" b="0">
+                <a:solidFill>
+                  <a:srgbClr val="CCD2DF"/>
+                </a:solidFill>
+                <a:latin typeface="Calibri"/>
+              </a:rPr>
+              <a:t>221 strategic triggers monitored continuously across 8 intelligence sources. Signal groups scored in real time — threshold met means the protocol is already staged.</a:t>
+            </a:r>
+          </a:p>
+        </p:txBody>
+      </p:sp>
+      <p:sp>
+        <p:nvSpPr>
+          <p:cNvPr id="12" name="Rectangle 11"/>
+          <p:cNvSpPr/>
+          <p:nvPr/>
+        </p:nvSpPr>
+        <p:spPr>
+          <a:xfrm>
+            <a:off x="6199632" y="1755648"/>
+            <a:ext cx="5532120" cy="4709160"/>
+          </a:xfrm>
+          <a:prstGeom prst="rect">
+            <a:avLst/>
+          </a:prstGeom>
+          <a:solidFill>
+            <a:srgbClr val="10173A"/>
+          </a:solidFill>
+          <a:ln w="9525">
+            <a:solidFill>
+              <a:srgbClr val="1E2858"/>
+            </a:solidFill>
+          </a:ln>
+        </p:spPr>
+        <p:style>
+          <a:lnRef idx="1">
+            <a:schemeClr val="accent1"/>
+          </a:lnRef>
+          <a:fillRef idx="3">
+            <a:schemeClr val="accent1"/>
+          </a:fillRef>
+          <a:effectRef idx="2">
+            <a:schemeClr val="accent1"/>
+          </a:effectRef>
+          <a:fontRef idx="minor">
+            <a:schemeClr val="lt1"/>
+          </a:fontRef>
+        </p:style>
+        <p:txBody>
+          <a:bodyPr rtlCol="0" anchor="ctr"/>
+          <a:lstStyle/>
+          <a:p>
+            <a:pPr algn="ctr"/>
+          </a:p>
+        </p:txBody>
+      </p:sp>
+      <p:sp>
+        <p:nvSpPr>
+          <p:cNvPr id="13" name="Rectangle 12"/>
+          <p:cNvSpPr/>
+          <p:nvPr/>
+        </p:nvSpPr>
+        <p:spPr>
+          <a:xfrm>
+            <a:off x="6199632" y="1755648"/>
+            <a:ext cx="5532120" cy="31750"/>
+          </a:xfrm>
+          <a:prstGeom prst="rect">
+            <a:avLst/>
+          </a:prstGeom>
+          <a:solidFill>
+            <a:srgbClr val="C9A84C"/>
+          </a:solidFill>
+          <a:ln>
+            <a:noFill/>
+          </a:ln>
+        </p:spPr>
+        <p:style>
+          <a:lnRef idx="1">
+            <a:schemeClr val="accent1"/>
+          </a:lnRef>
+          <a:fillRef idx="3">
+            <a:schemeClr val="accent1"/>
+          </a:fillRef>
+          <a:effectRef idx="2">
+            <a:schemeClr val="accent1"/>
+          </a:effectRef>
+          <a:fontRef idx="minor">
+            <a:schemeClr val="lt1"/>
+          </a:fontRef>
+        </p:style>
+        <p:txBody>
+          <a:bodyPr rtlCol="0" anchor="ctr"/>
+          <a:lstStyle/>
+          <a:p>
+            <a:pPr algn="ctr"/>
+          </a:p>
+        </p:txBody>
+      </p:sp>
+      <p:pic>
+        <p:nvPicPr>
+          <p:cNvPr id="14" name="Picture 13" descr="hq_executes_chain.jpg"/>
+          <p:cNvPicPr>
+            <a:picLocks noChangeAspect="1"/>
+          </p:cNvPicPr>
+          <p:nvPr/>
+        </p:nvPicPr>
+        <p:blipFill>
+          <a:blip r:embed="rId3"/>
+          <a:stretch>
+            <a:fillRect/>
+          </a:stretch>
+        </p:blipFill>
+        <p:spPr>
+          <a:xfrm>
+            <a:off x="6254496" y="1847088"/>
+            <a:ext cx="5422392" cy="3730752"/>
+          </a:xfrm>
+          <a:prstGeom prst="rect">
+            <a:avLst/>
+          </a:prstGeom>
+        </p:spPr>
+      </p:pic>
+      <p:sp>
+        <p:nvSpPr>
+          <p:cNvPr id="15" name="TextBox 14"/>
+          <p:cNvSpPr txBox="1"/>
+          <p:nvPr/>
+        </p:nvSpPr>
+        <p:spPr>
+          <a:xfrm>
+            <a:off x="6336792" y="5650992"/>
+            <a:ext cx="5257800" cy="292608"/>
+          </a:xfrm>
+          <a:prstGeom prst="rect">
+            <a:avLst/>
+          </a:prstGeom>
+          <a:noFill/>
+        </p:spPr>
+        <p:txBody>
+          <a:bodyPr wrap="square">
+            <a:spAutoFit/>
+          </a:bodyPr>
+          <a:lstStyle/>
+          <a:p>
+            <a:pPr algn="l"/>
+            <a:r>
+              <a:rPr sz="1000" b="1">
+                <a:solidFill>
+                  <a:srgbClr val="FFFFFF"/>
+                </a:solidFill>
+                <a:latin typeface="Calibri"/>
+              </a:rPr>
+              <a:t>EXECUTION CHAIN — SIGNAL TO WAR ROOM</a:t>
+            </a:r>
+          </a:p>
+        </p:txBody>
+      </p:sp>
+      <p:sp>
+        <p:nvSpPr>
+          <p:cNvPr id="16" name="TextBox 15"/>
+          <p:cNvSpPr txBox="1"/>
+          <p:nvPr/>
+        </p:nvSpPr>
+        <p:spPr>
+          <a:xfrm>
+            <a:off x="6336792" y="5907024"/>
+            <a:ext cx="5257800" cy="402336"/>
+          </a:xfrm>
+          <a:prstGeom prst="rect">
+            <a:avLst/>
+          </a:prstGeom>
+          <a:noFill/>
+        </p:spPr>
+        <p:txBody>
+          <a:bodyPr wrap="square">
+            <a:spAutoFit/>
+          </a:bodyPr>
+          <a:lstStyle/>
+          <a:p>
+            <a:pPr algn="l"/>
+            <a:r>
+              <a:rPr sz="850" b="0">
+                <a:solidFill>
+                  <a:srgbClr val="CCD2DF"/>
+                </a:solidFill>
+                <a:latin typeface="Calibri"/>
+              </a:rPr>
+              <a:t>The animated signal → protocol → task assignment → executive authorization → war room open chain. 12 minutes complete. The response was pre-staged before this moment.</a:t>
+            </a:r>
+          </a:p>
+        </p:txBody>
+      </p:sp>
+      <p:sp>
+        <p:nvSpPr>
+          <p:cNvPr id="17" name="TextBox 16"/>
+          <p:cNvSpPr txBox="1"/>
+          <p:nvPr/>
+        </p:nvSpPr>
+        <p:spPr>
+          <a:xfrm>
+            <a:off x="502920" y="6510528"/>
+            <a:ext cx="10972800" cy="256032"/>
+          </a:xfrm>
+          <a:prstGeom prst="rect">
+            <a:avLst/>
+          </a:prstGeom>
+          <a:noFill/>
+        </p:spPr>
+        <p:txBody>
+          <a:bodyPr wrap="square">
+            <a:spAutoFit/>
+          </a:bodyPr>
+          <a:lstStyle/>
+          <a:p>
+            <a:pPr algn="ctr"/>
+            <a:r>
+              <a:rPr sz="800" b="0">
+                <a:solidFill>
+                  <a:srgbClr val="C9A84C"/>
+                </a:solidFill>
+                <a:latin typeface="Calibri"/>
+              </a:rPr>
+              <a:t>Live product — accessible now at vaughnmartin.com  ·  No login required for the 12-Minute Test Drive</a:t>
+            </a:r>
+          </a:p>
+        </p:txBody>
+      </p:sp>
+    </p:spTree>
+  </p:cSld>
+  <p:clrMapOvr>
+    <a:masterClrMapping/>
+  </p:clrMapOvr>
+</p:sld>
+</file>
+
+<file path=ppt/slides/slide13.xml><?xml version="1.0" encoding="utf-8"?>
+<p:sld xmlns:a="http://schemas.openxmlformats.org/drawingml/2006/main" xmlns:p="http://schemas.openxmlformats.org/presentationml/2006/main" xmlns:r="http://schemas.openxmlformats.org/officeDocument/2006/relationships">
+  <p:cSld>
+    <p:bg>
+      <p:bgPr>
+        <a:solidFill>
+          <a:srgbClr val="0A0F2E"/>
+        </a:solidFill>
+        <a:effectLst/>
+      </p:bgPr>
+    </p:bg>
+    <p:spTree>
+      <p:nvGrpSpPr>
+        <p:cNvPr id="1" name=""/>
+        <p:cNvGrpSpPr/>
+        <p:nvPr/>
+      </p:nvGrpSpPr>
+      <p:grpSpPr/>
+      <p:sp>
+        <p:nvSpPr>
+          <p:cNvPr id="2" name="Rectangle 1"/>
+          <p:cNvSpPr/>
+          <p:nvPr/>
+        </p:nvSpPr>
+        <p:spPr>
+          <a:xfrm>
+            <a:off x="0" y="502920"/>
+            <a:ext cx="12188952" cy="25400"/>
+          </a:xfrm>
+          <a:prstGeom prst="rect">
+            <a:avLst/>
+          </a:prstGeom>
+          <a:solidFill>
+            <a:srgbClr val="C9A84C"/>
+          </a:solidFill>
+          <a:ln>
+            <a:noFill/>
+          </a:ln>
+        </p:spPr>
+        <p:style>
+          <a:lnRef idx="1">
+            <a:schemeClr val="accent1"/>
+          </a:lnRef>
+          <a:fillRef idx="3">
+            <a:schemeClr val="accent1"/>
+          </a:fillRef>
+          <a:effectRef idx="2">
+            <a:schemeClr val="accent1"/>
+          </a:effectRef>
+          <a:fontRef idx="minor">
+            <a:schemeClr val="lt1"/>
+          </a:fontRef>
+        </p:style>
+        <p:txBody>
+          <a:bodyPr rtlCol="0" anchor="ctr"/>
+          <a:lstStyle/>
+          <a:p>
+            <a:pPr algn="ctr"/>
+          </a:p>
+        </p:txBody>
+      </p:sp>
+      <p:sp>
+        <p:nvSpPr>
+          <p:cNvPr id="3" name="TextBox 2"/>
+          <p:cNvSpPr txBox="1"/>
+          <p:nvPr/>
+        </p:nvSpPr>
+        <p:spPr>
+          <a:xfrm>
+            <a:off x="502920" y="201168"/>
+            <a:ext cx="9144000" cy="320040"/>
+          </a:xfrm>
+          <a:prstGeom prst="rect">
+            <a:avLst/>
+          </a:prstGeom>
+          <a:noFill/>
+        </p:spPr>
+        <p:txBody>
+          <a:bodyPr wrap="square">
+            <a:spAutoFit/>
+          </a:bodyPr>
+          <a:lstStyle/>
+          <a:p>
+            <a:pPr algn="l"/>
+            <a:r>
+              <a:rPr sz="800" b="1">
+                <a:solidFill>
+                  <a:srgbClr val="C9A84C"/>
+                </a:solidFill>
+                <a:latin typeface="Calibri"/>
+              </a:rPr>
+              <a:t>APPENDIX  ·  LIVE PRODUCT — TEST DRIVE &amp; PROTOCOL DEPTH</a:t>
+            </a:r>
+          </a:p>
+        </p:txBody>
+      </p:sp>
+      <p:sp>
+        <p:nvSpPr>
+          <p:cNvPr id="4" name="TextBox 3"/>
+          <p:cNvSpPr txBox="1"/>
+          <p:nvPr/>
+        </p:nvSpPr>
+        <p:spPr>
+          <a:xfrm>
+            <a:off x="502920" y="621792"/>
+            <a:ext cx="10972800" cy="548640"/>
+          </a:xfrm>
+          <a:prstGeom prst="rect">
+            <a:avLst/>
+          </a:prstGeom>
+          <a:noFill/>
+        </p:spPr>
+        <p:txBody>
+          <a:bodyPr wrap="square">
+            <a:spAutoFit/>
+          </a:bodyPr>
+          <a:lstStyle/>
+          <a:p>
+            <a:pPr algn="l"/>
+            <a:r>
+              <a:rPr sz="2800" b="1">
+                <a:solidFill>
+                  <a:srgbClr val="FFFFFF"/>
+                </a:solidFill>
+                <a:latin typeface="Georgia"/>
+              </a:rPr>
+              <a:t>Run It Right Now. 170 Protocols Ready.</a:t>
+            </a:r>
+          </a:p>
+        </p:txBody>
+      </p:sp>
+      <p:sp>
+        <p:nvSpPr>
+          <p:cNvPr id="5" name="TextBox 4"/>
+          <p:cNvSpPr txBox="1"/>
+          <p:nvPr/>
+        </p:nvSpPr>
+        <p:spPr>
+          <a:xfrm>
+            <a:off x="502920" y="1170432"/>
+            <a:ext cx="10058400" cy="320040"/>
+          </a:xfrm>
+          <a:prstGeom prst="rect">
+            <a:avLst/>
+          </a:prstGeom>
+          <a:noFill/>
+        </p:spPr>
+        <p:txBody>
+          <a:bodyPr wrap="square">
+            <a:spAutoFit/>
+          </a:bodyPr>
+          <a:lstStyle/>
+          <a:p>
+            <a:pPr algn="l"/>
+            <a:r>
+              <a:rPr sz="1100" b="0">
+                <a:solidFill>
+                  <a:srgbClr val="CCD2DF"/>
+                </a:solidFill>
+                <a:latin typeface="Calibri"/>
+              </a:rPr>
+              <a:t>7 live scenarios, no login. Any investor can experience a full crisis response in 12 minutes — during this meeting.</a:t>
+            </a:r>
+          </a:p>
+        </p:txBody>
+      </p:sp>
+      <p:sp>
+        <p:nvSpPr>
+          <p:cNvPr id="6" name="Rectangle 5"/>
+          <p:cNvSpPr/>
+          <p:nvPr/>
+        </p:nvSpPr>
+        <p:spPr>
+          <a:xfrm>
+            <a:off x="502920" y="1536192"/>
+            <a:ext cx="1280160" cy="19050"/>
+          </a:xfrm>
+          <a:prstGeom prst="rect">
+            <a:avLst/>
+          </a:prstGeom>
+          <a:solidFill>
+            <a:srgbClr val="C9A84C"/>
+          </a:solidFill>
+          <a:ln>
+            <a:noFill/>
+          </a:ln>
+        </p:spPr>
+        <p:style>
+          <a:lnRef idx="1">
+            <a:schemeClr val="accent1"/>
+          </a:lnRef>
+          <a:fillRef idx="3">
+            <a:schemeClr val="accent1"/>
+          </a:fillRef>
+          <a:effectRef idx="2">
+            <a:schemeClr val="accent1"/>
+          </a:effectRef>
+          <a:fontRef idx="minor">
+            <a:schemeClr val="lt1"/>
+          </a:fontRef>
+        </p:style>
+        <p:txBody>
+          <a:bodyPr rtlCol="0" anchor="ctr"/>
+          <a:lstStyle/>
+          <a:p>
+            <a:pPr algn="ctr"/>
+          </a:p>
+        </p:txBody>
+      </p:sp>
+      <p:sp>
+        <p:nvSpPr>
+          <p:cNvPr id="7" name="Rectangle 6"/>
+          <p:cNvSpPr/>
+          <p:nvPr/>
+        </p:nvSpPr>
+        <p:spPr>
+          <a:xfrm>
+            <a:off x="502920" y="1755648"/>
+            <a:ext cx="5532120" cy="4709160"/>
+          </a:xfrm>
+          <a:prstGeom prst="rect">
+            <a:avLst/>
+          </a:prstGeom>
+          <a:solidFill>
+            <a:srgbClr val="10173A"/>
+          </a:solidFill>
+          <a:ln w="9525">
+            <a:solidFill>
+              <a:srgbClr val="1E2858"/>
+            </a:solidFill>
+          </a:ln>
+        </p:spPr>
+        <p:style>
+          <a:lnRef idx="1">
+            <a:schemeClr val="accent1"/>
+          </a:lnRef>
+          <a:fillRef idx="3">
+            <a:schemeClr val="accent1"/>
+          </a:fillRef>
+          <a:effectRef idx="2">
+            <a:schemeClr val="accent1"/>
+          </a:effectRef>
+          <a:fontRef idx="minor">
+            <a:schemeClr val="lt1"/>
+          </a:fontRef>
+        </p:style>
+        <p:txBody>
+          <a:bodyPr rtlCol="0" anchor="ctr"/>
+          <a:lstStyle/>
+          <a:p>
+            <a:pPr algn="ctr"/>
+          </a:p>
+        </p:txBody>
+      </p:sp>
+      <p:sp>
+        <p:nvSpPr>
+          <p:cNvPr id="8" name="Rectangle 7"/>
+          <p:cNvSpPr/>
+          <p:nvPr/>
+        </p:nvSpPr>
+        <p:spPr>
+          <a:xfrm>
+            <a:off x="502920" y="1755648"/>
+            <a:ext cx="5532120" cy="31750"/>
+          </a:xfrm>
+          <a:prstGeom prst="rect">
+            <a:avLst/>
+          </a:prstGeom>
+          <a:solidFill>
+            <a:srgbClr val="2B8A6E"/>
+          </a:solidFill>
+          <a:ln>
+            <a:noFill/>
+          </a:ln>
+        </p:spPr>
+        <p:style>
+          <a:lnRef idx="1">
+            <a:schemeClr val="accent1"/>
+          </a:lnRef>
+          <a:fillRef idx="3">
+            <a:schemeClr val="accent1"/>
+          </a:fillRef>
+          <a:effectRef idx="2">
+            <a:schemeClr val="accent1"/>
+          </a:effectRef>
+          <a:fontRef idx="minor">
+            <a:schemeClr val="lt1"/>
+          </a:fontRef>
+        </p:style>
+        <p:txBody>
+          <a:bodyPr rtlCol="0" anchor="ctr"/>
+          <a:lstStyle/>
+          <a:p>
+            <a:pPr algn="ctr"/>
+          </a:p>
+        </p:txBody>
+      </p:sp>
+      <p:pic>
+        <p:nvPicPr>
+          <p:cNvPr id="9" name="Picture 8" descr="hq_12min_scenarios.jpg"/>
+          <p:cNvPicPr>
+            <a:picLocks noChangeAspect="1"/>
+          </p:cNvPicPr>
+          <p:nvPr/>
+        </p:nvPicPr>
+        <p:blipFill>
+          <a:blip r:embed="rId2"/>
+          <a:stretch>
+            <a:fillRect/>
+          </a:stretch>
+        </p:blipFill>
+        <p:spPr>
+          <a:xfrm>
+            <a:off x="557784" y="1847088"/>
+            <a:ext cx="5422392" cy="3730752"/>
+          </a:xfrm>
+          <a:prstGeom prst="rect">
+            <a:avLst/>
+          </a:prstGeom>
+        </p:spPr>
+      </p:pic>
+      <p:sp>
+        <p:nvSpPr>
+          <p:cNvPr id="10" name="TextBox 9"/>
+          <p:cNvSpPr txBox="1"/>
+          <p:nvPr/>
+        </p:nvSpPr>
+        <p:spPr>
+          <a:xfrm>
+            <a:off x="640080" y="5650992"/>
+            <a:ext cx="5257800" cy="292608"/>
+          </a:xfrm>
+          <a:prstGeom prst="rect">
+            <a:avLst/>
+          </a:prstGeom>
+          <a:noFill/>
+        </p:spPr>
+        <p:txBody>
+          <a:bodyPr wrap="square">
+            <a:spAutoFit/>
+          </a:bodyPr>
+          <a:lstStyle/>
+          <a:p>
+            <a:pPr algn="l"/>
+            <a:r>
+              <a:rPr sz="1000" b="1">
+                <a:solidFill>
+                  <a:srgbClr val="FFFFFF"/>
+                </a:solidFill>
+                <a:latin typeface="Calibri"/>
+              </a:rPr>
+              <a:t>12-MINUTE TEST DRIVE — 7 LIVE SCENARIOS</a:t>
+            </a:r>
+          </a:p>
+        </p:txBody>
+      </p:sp>
+      <p:sp>
+        <p:nvSpPr>
+          <p:cNvPr id="11" name="TextBox 10"/>
+          <p:cNvSpPr txBox="1"/>
+          <p:nvPr/>
+        </p:nvSpPr>
+        <p:spPr>
+          <a:xfrm>
+            <a:off x="640080" y="5907024"/>
+            <a:ext cx="5257800" cy="402336"/>
+          </a:xfrm>
+          <a:prstGeom prst="rect">
+            <a:avLst/>
+          </a:prstGeom>
+          <a:noFill/>
+        </p:spPr>
+        <p:txBody>
+          <a:bodyPr wrap="square">
+            <a:spAutoFit/>
+          </a:bodyPr>
+          <a:lstStyle/>
+          <a:p>
+            <a:pPr algn="l"/>
+            <a:r>
+              <a:rPr sz="850" b="0">
+                <a:solidFill>
+                  <a:srgbClr val="CCD2DF"/>
+                </a:solidFill>
+                <a:latin typeface="Calibri"/>
+              </a:rPr>
+              <a:t>Public access. No login. Activist Investor, Ransomware, Supply Chain, M&amp;A — full signal → war room → debrief cycle. Run it now at /12-minute-experience.</a:t>
+            </a:r>
+          </a:p>
+        </p:txBody>
+      </p:sp>
+      <p:sp>
+        <p:nvSpPr>
+          <p:cNvPr id="12" name="Rectangle 11"/>
+          <p:cNvSpPr/>
+          <p:nvPr/>
+        </p:nvSpPr>
+        <p:spPr>
+          <a:xfrm>
+            <a:off x="6199632" y="1755648"/>
+            <a:ext cx="5532120" cy="4709160"/>
+          </a:xfrm>
+          <a:prstGeom prst="rect">
+            <a:avLst/>
+          </a:prstGeom>
+          <a:solidFill>
+            <a:srgbClr val="10173A"/>
+          </a:solidFill>
+          <a:ln w="9525">
+            <a:solidFill>
+              <a:srgbClr val="1E2858"/>
+            </a:solidFill>
+          </a:ln>
+        </p:spPr>
+        <p:style>
+          <a:lnRef idx="1">
+            <a:schemeClr val="accent1"/>
+          </a:lnRef>
+          <a:fillRef idx="3">
+            <a:schemeClr val="accent1"/>
+          </a:fillRef>
+          <a:effectRef idx="2">
+            <a:schemeClr val="accent1"/>
+          </a:effectRef>
+          <a:fontRef idx="minor">
+            <a:schemeClr val="lt1"/>
+          </a:fontRef>
+        </p:style>
+        <p:txBody>
+          <a:bodyPr rtlCol="0" anchor="ctr"/>
+          <a:lstStyle/>
+          <a:p>
+            <a:pPr algn="ctr"/>
+          </a:p>
+        </p:txBody>
+      </p:sp>
+      <p:sp>
+        <p:nvSpPr>
+          <p:cNvPr id="13" name="Rectangle 12"/>
+          <p:cNvSpPr/>
+          <p:nvPr/>
+        </p:nvSpPr>
+        <p:spPr>
+          <a:xfrm>
+            <a:off x="6199632" y="1755648"/>
+            <a:ext cx="5532120" cy="31750"/>
+          </a:xfrm>
+          <a:prstGeom prst="rect">
+            <a:avLst/>
+          </a:prstGeom>
+          <a:solidFill>
+            <a:srgbClr val="C9A84C"/>
+          </a:solidFill>
+          <a:ln>
+            <a:noFill/>
+          </a:ln>
+        </p:spPr>
+        <p:style>
+          <a:lnRef idx="1">
+            <a:schemeClr val="accent1"/>
+          </a:lnRef>
+          <a:fillRef idx="3">
+            <a:schemeClr val="accent1"/>
+          </a:fillRef>
+          <a:effectRef idx="2">
+            <a:schemeClr val="accent1"/>
+          </a:effectRef>
+          <a:fontRef idx="minor">
+            <a:schemeClr val="lt1"/>
+          </a:fontRef>
+        </p:style>
+        <p:txBody>
+          <a:bodyPr rtlCol="0" anchor="ctr"/>
+          <a:lstStyle/>
+          <a:p>
+            <a:pPr algn="ctr"/>
+          </a:p>
+        </p:txBody>
+      </p:sp>
+      <p:pic>
+        <p:nvPicPr>
+          <p:cNvPr id="14" name="Picture 13" descr="deck_protocol_library.jpg"/>
+          <p:cNvPicPr>
+            <a:picLocks noChangeAspect="1"/>
+          </p:cNvPicPr>
+          <p:nvPr/>
+        </p:nvPicPr>
+        <p:blipFill>
+          <a:blip r:embed="rId3"/>
+          <a:stretch>
+            <a:fillRect/>
+          </a:stretch>
+        </p:blipFill>
+        <p:spPr>
+          <a:xfrm>
+            <a:off x="6254496" y="1847088"/>
+            <a:ext cx="5422392" cy="3730752"/>
+          </a:xfrm>
+          <a:prstGeom prst="rect">
+            <a:avLst/>
+          </a:prstGeom>
+        </p:spPr>
+      </p:pic>
+      <p:sp>
+        <p:nvSpPr>
+          <p:cNvPr id="15" name="TextBox 14"/>
+          <p:cNvSpPr txBox="1"/>
+          <p:nvPr/>
+        </p:nvSpPr>
+        <p:spPr>
+          <a:xfrm>
+            <a:off x="6336792" y="5650992"/>
+            <a:ext cx="5257800" cy="292608"/>
+          </a:xfrm>
+          <a:prstGeom prst="rect">
+            <a:avLst/>
+          </a:prstGeom>
+          <a:noFill/>
+        </p:spPr>
+        <p:txBody>
+          <a:bodyPr wrap="square">
+            <a:spAutoFit/>
+          </a:bodyPr>
+          <a:lstStyle/>
+          <a:p>
+            <a:pPr algn="l"/>
+            <a:r>
+              <a:rPr sz="1000" b="1">
+                <a:solidFill>
+                  <a:srgbClr val="FFFFFF"/>
+                </a:solidFill>
+                <a:latin typeface="Calibri"/>
+              </a:rPr>
+              <a:t>170 READINESS PROTOCOLS — PRE-STAGED DEPTH</a:t>
+            </a:r>
+          </a:p>
+        </p:txBody>
+      </p:sp>
+      <p:sp>
+        <p:nvSpPr>
+          <p:cNvPr id="16" name="TextBox 15"/>
+          <p:cNvSpPr txBox="1"/>
+          <p:nvPr/>
+        </p:nvSpPr>
+        <p:spPr>
+          <a:xfrm>
+            <a:off x="6336792" y="5907024"/>
+            <a:ext cx="5257800" cy="402336"/>
+          </a:xfrm>
+          <a:prstGeom prst="rect">
+            <a:avLst/>
+          </a:prstGeom>
+          <a:noFill/>
+        </p:spPr>
+        <p:txBody>
+          <a:bodyPr wrap="square">
+            <a:spAutoFit/>
+          </a:bodyPr>
+          <a:lstStyle/>
+          <a:p>
+            <a:pPr algn="l"/>
+            <a:r>
+              <a:rPr sz="850" b="0">
+                <a:solidFill>
+                  <a:srgbClr val="CCD2DF"/>
+                </a:solidFill>
+                <a:latin typeface="Calibri"/>
+              </a:rPr>
+              <a:t>Every protocol mapped across GROWTH &amp; POSITIONING, RISK &amp; RESILIENCE, and TRANSFORMATION. 12 Compound Protocol Engines for simultaneous multi-threat response.</a:t>
+            </a:r>
+          </a:p>
+        </p:txBody>
+      </p:sp>
+      <p:sp>
+        <p:nvSpPr>
+          <p:cNvPr id="17" name="TextBox 16"/>
+          <p:cNvSpPr txBox="1"/>
+          <p:nvPr/>
+        </p:nvSpPr>
+        <p:spPr>
+          <a:xfrm>
+            <a:off x="502920" y="6510528"/>
+            <a:ext cx="10972800" cy="256032"/>
+          </a:xfrm>
+          <a:prstGeom prst="rect">
+            <a:avLst/>
+          </a:prstGeom>
+          <a:noFill/>
+        </p:spPr>
+        <p:txBody>
+          <a:bodyPr wrap="square">
+            <a:spAutoFit/>
+          </a:bodyPr>
+          <a:lstStyle/>
+          <a:p>
+            <a:pPr algn="ctr"/>
+            <a:r>
+              <a:rPr sz="800" b="0">
+                <a:solidFill>
+                  <a:srgbClr val="C9A84C"/>
+                </a:solidFill>
+                <a:latin typeface="Calibri"/>
+              </a:rPr>
+              <a:t>Live product — accessible now at vaughnmartin.com  ·  No login required for the 12-Minute Test Drive</a:t>
             </a:r>
           </a:p>
         </p:txBody>

</xml_diff>

<commit_message>
Update presentation to finalize slides and resolve visual inconsistencies
Update presentation metadata and file for final release, addressing slide content, color schemes, and background bleed for a polished look.

Replit-Commit-Author: Agent
Replit-Commit-Session-Id: 85f09f3c-352d-446d-b98e-3f307c26fc5a
Replit-Commit-Checkpoint-Type: full_checkpoint
Replit-Commit-Event-Id: b5f1acb6-5137-415d-b8da-c61d669adb9d
Replit-Commit-Screenshot-Url: https://storage.googleapis.com/screenshot-production-us-central1/3bd53afc-ff4f-401b-9e3d-b367791ef629/85f09f3c-352d-446d-b98e-3f307c26fc5a/zIh07K6
Replit-Helium-Checkpoint-Created: true
</commit_message>
<xml_diff>
--- a/attached_assets/VaughnMartin-4min-Pitch.pptx
+++ b/attached_assets/VaughnMartin-4min-Pitch.pptx
@@ -7475,6 +7475,162 @@
           </a:p>
         </p:txBody>
       </p:sp>
+      <p:sp>
+        <p:nvSpPr>
+          <p:cNvPr id="32" name="Rectangle 31"/>
+          <p:cNvSpPr/>
+          <p:nvPr/>
+        </p:nvSpPr>
+        <p:spPr>
+          <a:xfrm>
+            <a:off x="502920" y="4773168"/>
+            <a:ext cx="11183112" cy="1298448"/>
+          </a:xfrm>
+          <a:prstGeom prst="rect">
+            <a:avLst/>
+          </a:prstGeom>
+          <a:solidFill>
+            <a:srgbClr val="10173A"/>
+          </a:solidFill>
+          <a:ln w="6350">
+            <a:solidFill>
+              <a:srgbClr val="1E2858"/>
+            </a:solidFill>
+          </a:ln>
+        </p:spPr>
+        <p:style>
+          <a:lnRef idx="1">
+            <a:schemeClr val="accent1"/>
+          </a:lnRef>
+          <a:fillRef idx="3">
+            <a:schemeClr val="accent1"/>
+          </a:fillRef>
+          <a:effectRef idx="2">
+            <a:schemeClr val="accent1"/>
+          </a:effectRef>
+          <a:fontRef idx="minor">
+            <a:schemeClr val="lt1"/>
+          </a:fontRef>
+        </p:style>
+        <p:txBody>
+          <a:bodyPr rtlCol="0" anchor="ctr"/>
+          <a:lstStyle/>
+          <a:p>
+            <a:pPr algn="ctr"/>
+          </a:p>
+        </p:txBody>
+      </p:sp>
+      <p:sp>
+        <p:nvSpPr>
+          <p:cNvPr id="33" name="Rectangle 32"/>
+          <p:cNvSpPr/>
+          <p:nvPr/>
+        </p:nvSpPr>
+        <p:spPr>
+          <a:xfrm>
+            <a:off x="502920" y="4773168"/>
+            <a:ext cx="38100" cy="1298448"/>
+          </a:xfrm>
+          <a:prstGeom prst="rect">
+            <a:avLst/>
+          </a:prstGeom>
+          <a:solidFill>
+            <a:srgbClr val="C9A84C"/>
+          </a:solidFill>
+          <a:ln>
+            <a:noFill/>
+          </a:ln>
+        </p:spPr>
+        <p:style>
+          <a:lnRef idx="1">
+            <a:schemeClr val="accent1"/>
+          </a:lnRef>
+          <a:fillRef idx="3">
+            <a:schemeClr val="accent1"/>
+          </a:fillRef>
+          <a:effectRef idx="2">
+            <a:schemeClr val="accent1"/>
+          </a:effectRef>
+          <a:fontRef idx="minor">
+            <a:schemeClr val="lt1"/>
+          </a:fontRef>
+        </p:style>
+        <p:txBody>
+          <a:bodyPr rtlCol="0" anchor="ctr"/>
+          <a:lstStyle/>
+          <a:p>
+            <a:pPr algn="ctr"/>
+          </a:p>
+        </p:txBody>
+      </p:sp>
+      <p:sp>
+        <p:nvSpPr>
+          <p:cNvPr id="34" name="TextBox 33"/>
+          <p:cNvSpPr txBox="1"/>
+          <p:nvPr/>
+        </p:nvSpPr>
+        <p:spPr>
+          <a:xfrm>
+            <a:off x="655320" y="4901184"/>
+            <a:ext cx="10878312" cy="256032"/>
+          </a:xfrm>
+          <a:prstGeom prst="rect">
+            <a:avLst/>
+          </a:prstGeom>
+          <a:noFill/>
+        </p:spPr>
+        <p:txBody>
+          <a:bodyPr wrap="none">
+            <a:spAutoFit/>
+          </a:bodyPr>
+          <a:lstStyle/>
+          <a:p>
+            <a:r>
+              <a:rPr sz="800" b="1">
+                <a:solidFill>
+                  <a:srgbClr val="C9A84C"/>
+                </a:solidFill>
+                <a:latin typeface="Calibri"/>
+              </a:rPr>
+              <a:t>ACCESS CONTROL</a:t>
+            </a:r>
+          </a:p>
+        </p:txBody>
+      </p:sp>
+      <p:sp>
+        <p:nvSpPr>
+          <p:cNvPr id="35" name="TextBox 34"/>
+          <p:cNvSpPr txBox="1"/>
+          <p:nvPr/>
+        </p:nvSpPr>
+        <p:spPr>
+          <a:xfrm>
+            <a:off x="655320" y="5138928"/>
+            <a:ext cx="10878312" cy="749808"/>
+          </a:xfrm>
+          <a:prstGeom prst="rect">
+            <a:avLst/>
+          </a:prstGeom>
+          <a:noFill/>
+        </p:spPr>
+        <p:txBody>
+          <a:bodyPr wrap="square">
+            <a:spAutoFit/>
+          </a:bodyPr>
+          <a:lstStyle/>
+          <a:p>
+            <a:r>
+              <a:rPr sz="950">
+                <a:solidFill>
+                  <a:srgbClr val="CCD2DF"/>
+                </a:solidFill>
+                <a:latin typeface="Calibri"/>
+              </a:rPr>
+              <a:t>Role-Based Access Control enforced at every route — platform admin, executive, and operator roles with fail-closed error handling. Email allowlist gates all logins; open by default, restrictive once any address is added. No Readiness Protocol activates without executive sign-off — every action requires a named human authorization. Audit log captures every decision, activation, and ownership acknowledgment with timestamped attribution.</a:t>
+            </a:r>
+          </a:p>
+        </p:txBody>
+      </p:sp>
     </p:spTree>
   </p:cSld>
   <p:clrMapOvr>
@@ -7752,7 +7908,7 @@
             <a:avLst/>
           </a:prstGeom>
           <a:solidFill>
-            <a:srgbClr val="2B8A6E"/>
+            <a:srgbClr val="C9A84C"/>
           </a:solidFill>
           <a:ln>
             <a:noFill/>
@@ -8368,7 +8524,7 @@
             <a:avLst/>
           </a:prstGeom>
           <a:solidFill>
-            <a:srgbClr val="2B8A6E"/>
+            <a:srgbClr val="C9A84C"/>
           </a:solidFill>
           <a:ln>
             <a:noFill/>
@@ -8505,7 +8661,7 @@
             <a:avLst/>
           </a:prstGeom>
           <a:solidFill>
-            <a:srgbClr val="10173A"/>
+            <a:srgbClr val="0A0F2E"/>
           </a:solidFill>
           <a:ln w="9525">
             <a:solidFill>

</xml_diff>

<commit_message>
Ensure consistent background texture and color across all presentation slides
Update presentation file to apply a consistent background image and color scheme across all slides, including the appendix.

Replit-Commit-Author: Agent
Replit-Commit-Session-Id: 85f09f3c-352d-446d-b98e-3f307c26fc5a
Replit-Commit-Checkpoint-Type: full_checkpoint
Replit-Commit-Event-Id: 6af56bec-f2d4-4551-b16d-68fec4134091
Replit-Commit-Screenshot-Url: https://storage.googleapis.com/screenshot-production-us-central1/3bd53afc-ff4f-401b-9e3d-b367791ef629/85f09f3c-352d-446d-b98e-3f307c26fc5a/zIh07K6
Replit-Helium-Checkpoint-Created: true
</commit_message>
<xml_diff>
--- a/attached_assets/VaughnMartin-4min-Pitch.pptx
+++ b/attached_assets/VaughnMartin-4min-Pitch.pptx
@@ -6314,6 +6314,30 @@
         <p:nvPr/>
       </p:nvGrpSpPr>
       <p:grpSpPr/>
+      <p:pic>
+        <p:nvPicPr>
+          <p:cNvPr id="36" name="Picture 35" descr="image.jpg"/>
+          <p:cNvPicPr>
+            <a:picLocks noChangeAspect="1"/>
+          </p:cNvPicPr>
+          <p:nvPr/>
+        </p:nvPicPr>
+        <p:blipFill>
+          <a:blip r:embed="rId2"/>
+          <a:stretch>
+            <a:fillRect/>
+          </a:stretch>
+        </p:blipFill>
+        <p:spPr>
+          <a:xfrm>
+            <a:off x="0" y="0"/>
+            <a:ext cx="12188952" cy="6858000"/>
+          </a:xfrm>
+          <a:prstGeom prst="rect">
+            <a:avLst/>
+          </a:prstGeom>
+        </p:spPr>
+      </p:pic>
       <p:sp>
         <p:nvSpPr>
           <p:cNvPr id="2" name="Rectangle 1"/>
@@ -7657,6 +7681,30 @@
         <p:nvPr/>
       </p:nvGrpSpPr>
       <p:grpSpPr/>
+      <p:pic>
+        <p:nvPicPr>
+          <p:cNvPr id="18" name="Picture 17" descr="image.jpg"/>
+          <p:cNvPicPr>
+            <a:picLocks noChangeAspect="1"/>
+          </p:cNvPicPr>
+          <p:nvPr/>
+        </p:nvPicPr>
+        <p:blipFill>
+          <a:blip r:embed="rId4"/>
+          <a:stretch>
+            <a:fillRect/>
+          </a:stretch>
+        </p:blipFill>
+        <p:spPr>
+          <a:xfrm>
+            <a:off x="0" y="0"/>
+            <a:ext cx="12188952" cy="6858000"/>
+          </a:xfrm>
+          <a:prstGeom prst="rect">
+            <a:avLst/>
+          </a:prstGeom>
+        </p:spPr>
+      </p:pic>
       <p:sp>
         <p:nvSpPr>
           <p:cNvPr id="2" name="Rectangle 1"/>
@@ -8273,6 +8321,30 @@
         <p:nvPr/>
       </p:nvGrpSpPr>
       <p:grpSpPr/>
+      <p:pic>
+        <p:nvPicPr>
+          <p:cNvPr id="18" name="Picture 17" descr="image.jpg"/>
+          <p:cNvPicPr>
+            <a:picLocks noChangeAspect="1"/>
+          </p:cNvPicPr>
+          <p:nvPr/>
+        </p:nvPicPr>
+        <p:blipFill>
+          <a:blip r:embed="rId4"/>
+          <a:stretch>
+            <a:fillRect/>
+          </a:stretch>
+        </p:blipFill>
+        <p:spPr>
+          <a:xfrm>
+            <a:off x="0" y="0"/>
+            <a:ext cx="12188952" cy="6858000"/>
+          </a:xfrm>
+          <a:prstGeom prst="rect">
+            <a:avLst/>
+          </a:prstGeom>
+        </p:spPr>
+      </p:pic>
       <p:sp>
         <p:nvSpPr>
           <p:cNvPr id="2" name="Rectangle 1"/>

</xml_diff>

<commit_message>
Restore market sizing sources to the presentation deck
Restore market sizing and other key data sources to the presentation deck, updating slide metadata.

Replit-Commit-Author: Agent
Replit-Commit-Session-Id: 85f09f3c-352d-446d-b98e-3f307c26fc5a
Replit-Commit-Checkpoint-Type: full_checkpoint
Replit-Commit-Event-Id: 3ff90316-d33e-4c9b-a528-f8e9ae3bd96c
Replit-Commit-Screenshot-Url: https://storage.googleapis.com/screenshot-production-us-central1/3bd53afc-ff4f-401b-9e3d-b367791ef629/85f09f3c-352d-446d-b98e-3f307c26fc5a/zIh07K6
Replit-Helium-Checkpoint-Created: true
</commit_message>
<xml_diff>
--- a/attached_assets/VaughnMartin-4min-Pitch.pptx
+++ b/attached_assets/VaughnMartin-4min-Pitch.pptx
@@ -18,6 +18,7 @@
     <p:sldId id="266" r:id="rId18"/>
     <p:sldId id="267" r:id="rId19"/>
     <p:sldId id="268" r:id="rId20"/>
+    <p:sldId id="269" r:id="rId21"/>
   </p:sldIdLst>
   <p:sldSz cx="12188952" cy="6858000" type="screen4x3"/>
   <p:notesSz cx="6858000" cy="9144000"/>
@@ -8943,6 +8944,960 @@
 </p:sld>
 </file>
 
+<file path=ppt/slides/slide14.xml><?xml version="1.0" encoding="utf-8"?>
+<p:sld xmlns:a="http://schemas.openxmlformats.org/drawingml/2006/main" xmlns:p="http://schemas.openxmlformats.org/presentationml/2006/main" xmlns:r="http://schemas.openxmlformats.org/officeDocument/2006/relationships">
+  <p:cSld>
+    <p:bg>
+      <p:bgPr>
+        <a:solidFill>
+          <a:srgbClr val="0A0F2E"/>
+        </a:solidFill>
+        <a:effectLst/>
+      </p:bgPr>
+    </p:bg>
+    <p:spTree>
+      <p:nvGrpSpPr>
+        <p:cNvPr id="1" name=""/>
+        <p:cNvGrpSpPr/>
+        <p:nvPr/>
+      </p:nvGrpSpPr>
+      <p:grpSpPr/>
+      <p:pic>
+        <p:nvPicPr>
+          <p:cNvPr id="2" name="Picture 1" descr="image.jpg"/>
+          <p:cNvPicPr>
+            <a:picLocks noChangeAspect="1"/>
+          </p:cNvPicPr>
+          <p:nvPr/>
+        </p:nvPicPr>
+        <p:blipFill>
+          <a:blip r:embed="rId2"/>
+          <a:stretch>
+            <a:fillRect/>
+          </a:stretch>
+        </p:blipFill>
+        <p:spPr>
+          <a:xfrm>
+            <a:off x="0" y="0"/>
+            <a:ext cx="12188952" cy="6858000"/>
+          </a:xfrm>
+          <a:prstGeom prst="rect">
+            <a:avLst/>
+          </a:prstGeom>
+        </p:spPr>
+      </p:pic>
+      <p:sp>
+        <p:nvSpPr>
+          <p:cNvPr id="3" name="Rectangle 2"/>
+          <p:cNvSpPr/>
+          <p:nvPr/>
+        </p:nvSpPr>
+        <p:spPr>
+          <a:xfrm>
+            <a:off x="0" y="502920"/>
+            <a:ext cx="12188952" cy="25400"/>
+          </a:xfrm>
+          <a:prstGeom prst="rect">
+            <a:avLst/>
+          </a:prstGeom>
+          <a:solidFill>
+            <a:srgbClr val="C9A84C"/>
+          </a:solidFill>
+          <a:ln>
+            <a:noFill/>
+          </a:ln>
+        </p:spPr>
+        <p:style>
+          <a:lnRef idx="1">
+            <a:schemeClr val="accent1"/>
+          </a:lnRef>
+          <a:fillRef idx="3">
+            <a:schemeClr val="accent1"/>
+          </a:fillRef>
+          <a:effectRef idx="2">
+            <a:schemeClr val="accent1"/>
+          </a:effectRef>
+          <a:fontRef idx="minor">
+            <a:schemeClr val="lt1"/>
+          </a:fontRef>
+        </p:style>
+        <p:txBody>
+          <a:bodyPr rtlCol="0" anchor="ctr"/>
+          <a:lstStyle/>
+          <a:p>
+            <a:pPr algn="ctr"/>
+          </a:p>
+        </p:txBody>
+      </p:sp>
+      <p:sp>
+        <p:nvSpPr>
+          <p:cNvPr id="4" name="TextBox 3"/>
+          <p:cNvSpPr txBox="1"/>
+          <p:nvPr/>
+        </p:nvSpPr>
+        <p:spPr>
+          <a:xfrm>
+            <a:off x="502920" y="201168"/>
+            <a:ext cx="9144000" cy="274320"/>
+          </a:xfrm>
+          <a:prstGeom prst="rect">
+            <a:avLst/>
+          </a:prstGeom>
+          <a:noFill/>
+        </p:spPr>
+        <p:txBody>
+          <a:bodyPr wrap="square">
+            <a:spAutoFit/>
+          </a:bodyPr>
+          <a:lstStyle/>
+          <a:p>
+            <a:pPr algn="l"/>
+            <a:r>
+              <a:rPr sz="800" b="1">
+                <a:solidFill>
+                  <a:srgbClr val="C9A84C"/>
+                </a:solidFill>
+                <a:latin typeface="Calibri"/>
+              </a:rPr>
+              <a:t>APPENDIX  ·  SOURCES &amp; REFERENCES</a:t>
+            </a:r>
+          </a:p>
+        </p:txBody>
+      </p:sp>
+      <p:sp>
+        <p:nvSpPr>
+          <p:cNvPr id="5" name="TextBox 4"/>
+          <p:cNvSpPr txBox="1"/>
+          <p:nvPr/>
+        </p:nvSpPr>
+        <p:spPr>
+          <a:xfrm>
+            <a:off x="502920" y="594360"/>
+            <a:ext cx="10972800" cy="502920"/>
+          </a:xfrm>
+          <a:prstGeom prst="rect">
+            <a:avLst/>
+          </a:prstGeom>
+          <a:noFill/>
+        </p:spPr>
+        <p:txBody>
+          <a:bodyPr wrap="square">
+            <a:spAutoFit/>
+          </a:bodyPr>
+          <a:lstStyle/>
+          <a:p>
+            <a:pPr algn="l"/>
+            <a:r>
+              <a:rPr sz="2600" b="1">
+                <a:solidFill>
+                  <a:srgbClr val="FFFFFF"/>
+                </a:solidFill>
+                <a:latin typeface="Georgia"/>
+              </a:rPr>
+              <a:t>Sources &amp; References</a:t>
+            </a:r>
+          </a:p>
+        </p:txBody>
+      </p:sp>
+      <p:sp>
+        <p:nvSpPr>
+          <p:cNvPr id="6" name="TextBox 5"/>
+          <p:cNvSpPr txBox="1"/>
+          <p:nvPr/>
+        </p:nvSpPr>
+        <p:spPr>
+          <a:xfrm>
+            <a:off x="502920" y="1097280"/>
+            <a:ext cx="10058400" cy="274320"/>
+          </a:xfrm>
+          <a:prstGeom prst="rect">
+            <a:avLst/>
+          </a:prstGeom>
+          <a:noFill/>
+        </p:spPr>
+        <p:txBody>
+          <a:bodyPr wrap="square">
+            <a:spAutoFit/>
+          </a:bodyPr>
+          <a:lstStyle/>
+          <a:p>
+            <a:pPr algn="l"/>
+            <a:r>
+              <a:rPr sz="900" b="0">
+                <a:solidFill>
+                  <a:srgbClr val="CCD2DF"/>
+                </a:solidFill>
+                <a:latin typeface="Calibri"/>
+              </a:rPr>
+              <a:t>VaughnMartin Readiness OS  ·  Investor Pitch  ·  May 2026  ·  vaughnmartin.com</a:t>
+            </a:r>
+          </a:p>
+        </p:txBody>
+      </p:sp>
+      <p:sp>
+        <p:nvSpPr>
+          <p:cNvPr id="7" name="Rectangle 6"/>
+          <p:cNvSpPr/>
+          <p:nvPr/>
+        </p:nvSpPr>
+        <p:spPr>
+          <a:xfrm>
+            <a:off x="502920" y="1426464"/>
+            <a:ext cx="1097280" cy="19050"/>
+          </a:xfrm>
+          <a:prstGeom prst="rect">
+            <a:avLst/>
+          </a:prstGeom>
+          <a:solidFill>
+            <a:srgbClr val="C9A84C"/>
+          </a:solidFill>
+          <a:ln>
+            <a:noFill/>
+          </a:ln>
+        </p:spPr>
+        <p:style>
+          <a:lnRef idx="1">
+            <a:schemeClr val="accent1"/>
+          </a:lnRef>
+          <a:fillRef idx="3">
+            <a:schemeClr val="accent1"/>
+          </a:fillRef>
+          <a:effectRef idx="2">
+            <a:schemeClr val="accent1"/>
+          </a:effectRef>
+          <a:fontRef idx="minor">
+            <a:schemeClr val="lt1"/>
+          </a:fontRef>
+        </p:style>
+        <p:txBody>
+          <a:bodyPr rtlCol="0" anchor="ctr"/>
+          <a:lstStyle/>
+          <a:p>
+            <a:pPr algn="ctr"/>
+          </a:p>
+        </p:txBody>
+      </p:sp>
+      <p:sp>
+        <p:nvSpPr>
+          <p:cNvPr id="8" name="Rectangle 7"/>
+          <p:cNvSpPr/>
+          <p:nvPr/>
+        </p:nvSpPr>
+        <p:spPr>
+          <a:xfrm>
+            <a:off x="502920" y="1572768"/>
+            <a:ext cx="31750" cy="699008"/>
+          </a:xfrm>
+          <a:prstGeom prst="rect">
+            <a:avLst/>
+          </a:prstGeom>
+          <a:solidFill>
+            <a:srgbClr val="2B8A6E"/>
+          </a:solidFill>
+          <a:ln>
+            <a:noFill/>
+          </a:ln>
+        </p:spPr>
+        <p:style>
+          <a:lnRef idx="1">
+            <a:schemeClr val="accent1"/>
+          </a:lnRef>
+          <a:fillRef idx="3">
+            <a:schemeClr val="accent1"/>
+          </a:fillRef>
+          <a:effectRef idx="2">
+            <a:schemeClr val="accent1"/>
+          </a:effectRef>
+          <a:fontRef idx="minor">
+            <a:schemeClr val="lt1"/>
+          </a:fontRef>
+        </p:style>
+        <p:txBody>
+          <a:bodyPr rtlCol="0" anchor="ctr"/>
+          <a:lstStyle/>
+          <a:p>
+            <a:pPr algn="ctr"/>
+          </a:p>
+        </p:txBody>
+      </p:sp>
+      <p:sp>
+        <p:nvSpPr>
+          <p:cNvPr id="9" name="TextBox 8"/>
+          <p:cNvSpPr txBox="1"/>
+          <p:nvPr/>
+        </p:nvSpPr>
+        <p:spPr>
+          <a:xfrm>
+            <a:off x="685800" y="1609344"/>
+            <a:ext cx="10789920" cy="219456"/>
+          </a:xfrm>
+          <a:prstGeom prst="rect">
+            <a:avLst/>
+          </a:prstGeom>
+          <a:noFill/>
+        </p:spPr>
+        <p:txBody>
+          <a:bodyPr wrap="square">
+            <a:spAutoFit/>
+          </a:bodyPr>
+          <a:lstStyle/>
+          <a:p>
+            <a:pPr algn="l"/>
+            <a:r>
+              <a:rPr sz="800" b="1">
+                <a:solidFill>
+                  <a:srgbClr val="C9A84C"/>
+                </a:solidFill>
+                <a:latin typeface="Calibri"/>
+              </a:rPr>
+              <a:t>Slides 1, 4  ·  30-Day Mobilization Baseline &amp; 3,600× Calculation</a:t>
+            </a:r>
+          </a:p>
+        </p:txBody>
+      </p:sp>
+      <p:sp>
+        <p:nvSpPr>
+          <p:cNvPr id="10" name="TextBox 9"/>
+          <p:cNvSpPr txBox="1"/>
+          <p:nvPr/>
+        </p:nvSpPr>
+        <p:spPr>
+          <a:xfrm>
+            <a:off x="685800" y="1819656"/>
+            <a:ext cx="10789920" cy="457200"/>
+          </a:xfrm>
+          <a:prstGeom prst="rect">
+            <a:avLst/>
+          </a:prstGeom>
+          <a:noFill/>
+        </p:spPr>
+        <p:txBody>
+          <a:bodyPr wrap="square">
+            <a:spAutoFit/>
+          </a:bodyPr>
+          <a:lstStyle/>
+          <a:p>
+            <a:pPr algn="l"/>
+            <a:r>
+              <a:rPr sz="850" b="0">
+                <a:solidFill>
+                  <a:srgbClr val="CCD2DF"/>
+                </a:solidFill>
+                <a:latin typeface="Calibri"/>
+              </a:rPr>
+              <a:t>VaughnMartin operational research — 20+ years direct experience across Ford, Toyota, Lockheed Martin, Charles Schwab, and Boyd Gaming. McKinsey Organizational Agility Research (2025). Calculation: 30 days × 24 hrs × 60 min = 43,200 min ÷ 12 min = 3,600×. Baseline is average Fortune 1000 cross-functional mobilization cycle.</a:t>
+            </a:r>
+          </a:p>
+        </p:txBody>
+      </p:sp>
+      <p:sp>
+        <p:nvSpPr>
+          <p:cNvPr id="11" name="Rectangle 10"/>
+          <p:cNvSpPr/>
+          <p:nvPr/>
+        </p:nvSpPr>
+        <p:spPr>
+          <a:xfrm>
+            <a:off x="502920" y="2322576"/>
+            <a:ext cx="31750" cy="699008"/>
+          </a:xfrm>
+          <a:prstGeom prst="rect">
+            <a:avLst/>
+          </a:prstGeom>
+          <a:solidFill>
+            <a:srgbClr val="2B8A6E"/>
+          </a:solidFill>
+          <a:ln>
+            <a:noFill/>
+          </a:ln>
+        </p:spPr>
+        <p:style>
+          <a:lnRef idx="1">
+            <a:schemeClr val="accent1"/>
+          </a:lnRef>
+          <a:fillRef idx="3">
+            <a:schemeClr val="accent1"/>
+          </a:fillRef>
+          <a:effectRef idx="2">
+            <a:schemeClr val="accent1"/>
+          </a:effectRef>
+          <a:fontRef idx="minor">
+            <a:schemeClr val="lt1"/>
+          </a:fontRef>
+        </p:style>
+        <p:txBody>
+          <a:bodyPr rtlCol="0" anchor="ctr"/>
+          <a:lstStyle/>
+          <a:p>
+            <a:pPr algn="ctr"/>
+          </a:p>
+        </p:txBody>
+      </p:sp>
+      <p:sp>
+        <p:nvSpPr>
+          <p:cNvPr id="12" name="TextBox 11"/>
+          <p:cNvSpPr txBox="1"/>
+          <p:nvPr/>
+        </p:nvSpPr>
+        <p:spPr>
+          <a:xfrm>
+            <a:off x="685800" y="2359152"/>
+            <a:ext cx="10789920" cy="219456"/>
+          </a:xfrm>
+          <a:prstGeom prst="rect">
+            <a:avLst/>
+          </a:prstGeom>
+          <a:noFill/>
+        </p:spPr>
+        <p:txBody>
+          <a:bodyPr wrap="square">
+            <a:spAutoFit/>
+          </a:bodyPr>
+          <a:lstStyle/>
+          <a:p>
+            <a:pPr algn="l"/>
+            <a:r>
+              <a:rPr sz="800" b="1">
+                <a:solidFill>
+                  <a:srgbClr val="C9A84C"/>
+                </a:solidFill>
+                <a:latin typeface="Calibri"/>
+              </a:rPr>
+              <a:t>Slide 7  ·  $42B TAM / $4.8B SAM / $180M SOM</a:t>
+            </a:r>
+          </a:p>
+        </p:txBody>
+      </p:sp>
+      <p:sp>
+        <p:nvSpPr>
+          <p:cNvPr id="13" name="TextBox 12"/>
+          <p:cNvSpPr txBox="1"/>
+          <p:nvPr/>
+        </p:nvSpPr>
+        <p:spPr>
+          <a:xfrm>
+            <a:off x="685800" y="2569464"/>
+            <a:ext cx="10789920" cy="457200"/>
+          </a:xfrm>
+          <a:prstGeom prst="rect">
+            <a:avLst/>
+          </a:prstGeom>
+          <a:noFill/>
+        </p:spPr>
+        <p:txBody>
+          <a:bodyPr wrap="square">
+            <a:spAutoFit/>
+          </a:bodyPr>
+          <a:lstStyle/>
+          <a:p>
+            <a:pPr algn="l"/>
+            <a:r>
+              <a:rPr sz="850" b="0">
+                <a:solidFill>
+                  <a:srgbClr val="CCD2DF"/>
+                </a:solidFill>
+                <a:latin typeface="Calibri"/>
+              </a:rPr>
+              <a:t>Gartner Strategic Portfolio Management 2025 (SPM + GRC + EPMO combined categories). McKinsey 2025 coordination cost research. WEF × Accenture Strategic Readiness Report, March 2026. SAM: ~25K target accounts × $200K avg ACV. SOM: 600 customers × $300K avg ACV by Year 5.</a:t>
+            </a:r>
+          </a:p>
+        </p:txBody>
+      </p:sp>
+      <p:sp>
+        <p:nvSpPr>
+          <p:cNvPr id="14" name="Rectangle 13"/>
+          <p:cNvSpPr/>
+          <p:nvPr/>
+        </p:nvSpPr>
+        <p:spPr>
+          <a:xfrm>
+            <a:off x="502920" y="3072384"/>
+            <a:ext cx="31750" cy="699008"/>
+          </a:xfrm>
+          <a:prstGeom prst="rect">
+            <a:avLst/>
+          </a:prstGeom>
+          <a:solidFill>
+            <a:srgbClr val="2B8A6E"/>
+          </a:solidFill>
+          <a:ln>
+            <a:noFill/>
+          </a:ln>
+        </p:spPr>
+        <p:style>
+          <a:lnRef idx="1">
+            <a:schemeClr val="accent1"/>
+          </a:lnRef>
+          <a:fillRef idx="3">
+            <a:schemeClr val="accent1"/>
+          </a:fillRef>
+          <a:effectRef idx="2">
+            <a:schemeClr val="accent1"/>
+          </a:effectRef>
+          <a:fontRef idx="minor">
+            <a:schemeClr val="lt1"/>
+          </a:fontRef>
+        </p:style>
+        <p:txBody>
+          <a:bodyPr rtlCol="0" anchor="ctr"/>
+          <a:lstStyle/>
+          <a:p>
+            <a:pPr algn="ctr"/>
+          </a:p>
+        </p:txBody>
+      </p:sp>
+      <p:sp>
+        <p:nvSpPr>
+          <p:cNvPr id="15" name="TextBox 14"/>
+          <p:cNvSpPr txBox="1"/>
+          <p:nvPr/>
+        </p:nvSpPr>
+        <p:spPr>
+          <a:xfrm>
+            <a:off x="685800" y="3108960"/>
+            <a:ext cx="10789920" cy="219456"/>
+          </a:xfrm>
+          <a:prstGeom prst="rect">
+            <a:avLst/>
+          </a:prstGeom>
+          <a:noFill/>
+        </p:spPr>
+        <p:txBody>
+          <a:bodyPr wrap="square">
+            <a:spAutoFit/>
+          </a:bodyPr>
+          <a:lstStyle/>
+          <a:p>
+            <a:pPr algn="l"/>
+            <a:r>
+              <a:rPr sz="800" b="1">
+                <a:solidFill>
+                  <a:srgbClr val="C9A84C"/>
+                </a:solidFill>
+                <a:latin typeface="Calibri"/>
+              </a:rPr>
+              <a:t>Slide 6  ·  67% Execution Improvement</a:t>
+            </a:r>
+          </a:p>
+        </p:txBody>
+      </p:sp>
+      <p:sp>
+        <p:nvSpPr>
+          <p:cNvPr id="16" name="TextBox 15"/>
+          <p:cNvSpPr txBox="1"/>
+          <p:nvPr/>
+        </p:nvSpPr>
+        <p:spPr>
+          <a:xfrm>
+            <a:off x="685800" y="3319272"/>
+            <a:ext cx="10789920" cy="457200"/>
+          </a:xfrm>
+          <a:prstGeom prst="rect">
+            <a:avLst/>
+          </a:prstGeom>
+          <a:noFill/>
+        </p:spPr>
+        <p:txBody>
+          <a:bodyPr wrap="square">
+            <a:spAutoFit/>
+          </a:bodyPr>
+          <a:lstStyle/>
+          <a:p>
+            <a:pPr algn="l"/>
+            <a:r>
+              <a:rPr sz="850" b="0">
+                <a:solidFill>
+                  <a:srgbClr val="CCD2DF"/>
+                </a:solidFill>
+                <a:latin typeface="Calibri"/>
+              </a:rPr>
+              <a:t>VaughnMartin simulation-validated performance modeling based on platform activation cycle data. Labeled "simulation-validated" on slide. Baseline: enterprise crisis response timelines across GROWTH &amp; POSITIONING, RISK &amp; RESILIENCE, and TRANSFORMATION domain scenarios.</a:t>
+            </a:r>
+          </a:p>
+        </p:txBody>
+      </p:sp>
+      <p:sp>
+        <p:nvSpPr>
+          <p:cNvPr id="17" name="Rectangle 16"/>
+          <p:cNvSpPr/>
+          <p:nvPr/>
+        </p:nvSpPr>
+        <p:spPr>
+          <a:xfrm>
+            <a:off x="502920" y="3822192"/>
+            <a:ext cx="31750" cy="699008"/>
+          </a:xfrm>
+          <a:prstGeom prst="rect">
+            <a:avLst/>
+          </a:prstGeom>
+          <a:solidFill>
+            <a:srgbClr val="2B8A6E"/>
+          </a:solidFill>
+          <a:ln>
+            <a:noFill/>
+          </a:ln>
+        </p:spPr>
+        <p:style>
+          <a:lnRef idx="1">
+            <a:schemeClr val="accent1"/>
+          </a:lnRef>
+          <a:fillRef idx="3">
+            <a:schemeClr val="accent1"/>
+          </a:fillRef>
+          <a:effectRef idx="2">
+            <a:schemeClr val="accent1"/>
+          </a:effectRef>
+          <a:fontRef idx="minor">
+            <a:schemeClr val="lt1"/>
+          </a:fontRef>
+        </p:style>
+        <p:txBody>
+          <a:bodyPr rtlCol="0" anchor="ctr"/>
+          <a:lstStyle/>
+          <a:p>
+            <a:pPr algn="ctr"/>
+          </a:p>
+        </p:txBody>
+      </p:sp>
+      <p:sp>
+        <p:nvSpPr>
+          <p:cNvPr id="18" name="TextBox 17"/>
+          <p:cNvSpPr txBox="1"/>
+          <p:nvPr/>
+        </p:nvSpPr>
+        <p:spPr>
+          <a:xfrm>
+            <a:off x="685800" y="3858768"/>
+            <a:ext cx="10789920" cy="219456"/>
+          </a:xfrm>
+          <a:prstGeom prst="rect">
+            <a:avLst/>
+          </a:prstGeom>
+          <a:noFill/>
+        </p:spPr>
+        <p:txBody>
+          <a:bodyPr wrap="square">
+            <a:spAutoFit/>
+          </a:bodyPr>
+          <a:lstStyle/>
+          <a:p>
+            <a:pPr algn="l"/>
+            <a:r>
+              <a:rPr sz="800" b="1">
+                <a:solidFill>
+                  <a:srgbClr val="C9A84C"/>
+                </a:solidFill>
+                <a:latin typeface="Calibri"/>
+              </a:rPr>
+              <a:t>Slide 8  ·  Platform Metrics</a:t>
+            </a:r>
+          </a:p>
+        </p:txBody>
+      </p:sp>
+      <p:sp>
+        <p:nvSpPr>
+          <p:cNvPr id="19" name="TextBox 18"/>
+          <p:cNvSpPr txBox="1"/>
+          <p:nvPr/>
+        </p:nvSpPr>
+        <p:spPr>
+          <a:xfrm>
+            <a:off x="685800" y="4069080"/>
+            <a:ext cx="10789920" cy="457200"/>
+          </a:xfrm>
+          <a:prstGeom prst="rect">
+            <a:avLst/>
+          </a:prstGeom>
+          <a:noFill/>
+        </p:spPr>
+        <p:txBody>
+          <a:bodyPr wrap="square">
+            <a:spAutoFit/>
+          </a:bodyPr>
+          <a:lstStyle/>
+          <a:p>
+            <a:pPr algn="l"/>
+            <a:r>
+              <a:rPr sz="850" b="0">
+                <a:solidFill>
+                  <a:srgbClr val="CCD2DF"/>
+                </a:solidFill>
+                <a:latin typeface="Calibri"/>
+              </a:rPr>
+              <a:t>VaughnMartin Readiness OS production system, May 2026. All platform layers live in production. 221 strategic triggers. 170 Readiness Protocols. 12 Compound Protocol Engines. 8 live signal sources on 15-minute monitoring cycles. Verifiable at vaughnmartin.com</a:t>
+            </a:r>
+          </a:p>
+        </p:txBody>
+      </p:sp>
+      <p:sp>
+        <p:nvSpPr>
+          <p:cNvPr id="20" name="Rectangle 19"/>
+          <p:cNvSpPr/>
+          <p:nvPr/>
+        </p:nvSpPr>
+        <p:spPr>
+          <a:xfrm>
+            <a:off x="502920" y="4572000"/>
+            <a:ext cx="31750" cy="699008"/>
+          </a:xfrm>
+          <a:prstGeom prst="rect">
+            <a:avLst/>
+          </a:prstGeom>
+          <a:solidFill>
+            <a:srgbClr val="2B8A6E"/>
+          </a:solidFill>
+          <a:ln>
+            <a:noFill/>
+          </a:ln>
+        </p:spPr>
+        <p:style>
+          <a:lnRef idx="1">
+            <a:schemeClr val="accent1"/>
+          </a:lnRef>
+          <a:fillRef idx="3">
+            <a:schemeClr val="accent1"/>
+          </a:fillRef>
+          <a:effectRef idx="2">
+            <a:schemeClr val="accent1"/>
+          </a:effectRef>
+          <a:fontRef idx="minor">
+            <a:schemeClr val="lt1"/>
+          </a:fontRef>
+        </p:style>
+        <p:txBody>
+          <a:bodyPr rtlCol="0" anchor="ctr"/>
+          <a:lstStyle/>
+          <a:p>
+            <a:pPr algn="ctr"/>
+          </a:p>
+        </p:txBody>
+      </p:sp>
+      <p:sp>
+        <p:nvSpPr>
+          <p:cNvPr id="21" name="TextBox 20"/>
+          <p:cNvSpPr txBox="1"/>
+          <p:nvPr/>
+        </p:nvSpPr>
+        <p:spPr>
+          <a:xfrm>
+            <a:off x="685800" y="4608576"/>
+            <a:ext cx="10789920" cy="219456"/>
+          </a:xfrm>
+          <a:prstGeom prst="rect">
+            <a:avLst/>
+          </a:prstGeom>
+          <a:noFill/>
+        </p:spPr>
+        <p:txBody>
+          <a:bodyPr wrap="square">
+            <a:spAutoFit/>
+          </a:bodyPr>
+          <a:lstStyle/>
+          <a:p>
+            <a:pPr algn="l"/>
+            <a:r>
+              <a:rPr sz="800" b="1">
+                <a:solidFill>
+                  <a:srgbClr val="C9A84C"/>
+                </a:solidFill>
+                <a:latin typeface="Calibri"/>
+              </a:rPr>
+              <a:t>Slide 8  ·  Business Model &amp; Unit Economics</a:t>
+            </a:r>
+          </a:p>
+        </p:txBody>
+      </p:sp>
+      <p:sp>
+        <p:nvSpPr>
+          <p:cNvPr id="22" name="TextBox 21"/>
+          <p:cNvSpPr txBox="1"/>
+          <p:nvPr/>
+        </p:nvSpPr>
+        <p:spPr>
+          <a:xfrm>
+            <a:off x="685800" y="4818888"/>
+            <a:ext cx="10789920" cy="457200"/>
+          </a:xfrm>
+          <a:prstGeom prst="rect">
+            <a:avLst/>
+          </a:prstGeom>
+          <a:noFill/>
+        </p:spPr>
+        <p:txBody>
+          <a:bodyPr wrap="square">
+            <a:spAutoFit/>
+          </a:bodyPr>
+          <a:lstStyle/>
+          <a:p>
+            <a:pPr algn="l"/>
+            <a:r>
+              <a:rPr sz="850" b="0">
+                <a:solidFill>
+                  <a:srgbClr val="CCD2DF"/>
+                </a:solidFill>
+                <a:latin typeface="Calibri"/>
+              </a:rPr>
+              <a:t>VaughnMartin internal pricing model. $120K Average ACV based on Founding Partner tier mid-point. 92% Target Gross Margin based on SaaS infrastructure cost modeling at scale. &lt;6 Month Payback Period derived from enterprise crisis cost avoidance vs. annual platform fee. 2–4 Weeks First Results based on onboarding timeline: Week 1 setup, Weeks 2–4 live protocols.</a:t>
+            </a:r>
+          </a:p>
+        </p:txBody>
+      </p:sp>
+      <p:sp>
+        <p:nvSpPr>
+          <p:cNvPr id="23" name="Rectangle 22"/>
+          <p:cNvSpPr/>
+          <p:nvPr/>
+        </p:nvSpPr>
+        <p:spPr>
+          <a:xfrm>
+            <a:off x="502920" y="5321808"/>
+            <a:ext cx="31750" cy="699008"/>
+          </a:xfrm>
+          <a:prstGeom prst="rect">
+            <a:avLst/>
+          </a:prstGeom>
+          <a:solidFill>
+            <a:srgbClr val="C9A84C"/>
+          </a:solidFill>
+          <a:ln>
+            <a:noFill/>
+          </a:ln>
+        </p:spPr>
+        <p:style>
+          <a:lnRef idx="1">
+            <a:schemeClr val="accent1"/>
+          </a:lnRef>
+          <a:fillRef idx="3">
+            <a:schemeClr val="accent1"/>
+          </a:fillRef>
+          <a:effectRef idx="2">
+            <a:schemeClr val="accent1"/>
+          </a:effectRef>
+          <a:fontRef idx="minor">
+            <a:schemeClr val="lt1"/>
+          </a:fontRef>
+        </p:style>
+        <p:txBody>
+          <a:bodyPr rtlCol="0" anchor="ctr"/>
+          <a:lstStyle/>
+          <a:p>
+            <a:pPr algn="ctr"/>
+          </a:p>
+        </p:txBody>
+      </p:sp>
+      <p:sp>
+        <p:nvSpPr>
+          <p:cNvPr id="24" name="TextBox 23"/>
+          <p:cNvSpPr txBox="1"/>
+          <p:nvPr/>
+        </p:nvSpPr>
+        <p:spPr>
+          <a:xfrm>
+            <a:off x="685800" y="5358384"/>
+            <a:ext cx="10789920" cy="219456"/>
+          </a:xfrm>
+          <a:prstGeom prst="rect">
+            <a:avLst/>
+          </a:prstGeom>
+          <a:noFill/>
+        </p:spPr>
+        <p:txBody>
+          <a:bodyPr wrap="square">
+            <a:spAutoFit/>
+          </a:bodyPr>
+          <a:lstStyle/>
+          <a:p>
+            <a:pPr algn="l"/>
+            <a:r>
+              <a:rPr sz="800" b="1">
+                <a:solidFill>
+                  <a:srgbClr val="FFFFFF"/>
+                </a:solidFill>
+                <a:latin typeface="Calibri"/>
+              </a:rPr>
+              <a:t>All platform metrics verifiable  ·  Financial projections are forward-looking estimates</a:t>
+            </a:r>
+          </a:p>
+        </p:txBody>
+      </p:sp>
+      <p:sp>
+        <p:nvSpPr>
+          <p:cNvPr id="25" name="TextBox 24"/>
+          <p:cNvSpPr txBox="1"/>
+          <p:nvPr/>
+        </p:nvSpPr>
+        <p:spPr>
+          <a:xfrm>
+            <a:off x="685800" y="5568696"/>
+            <a:ext cx="10789920" cy="457200"/>
+          </a:xfrm>
+          <a:prstGeom prst="rect">
+            <a:avLst/>
+          </a:prstGeom>
+          <a:noFill/>
+        </p:spPr>
+        <p:txBody>
+          <a:bodyPr wrap="square">
+            <a:spAutoFit/>
+          </a:bodyPr>
+          <a:lstStyle/>
+          <a:p>
+            <a:pPr algn="l"/>
+            <a:r>
+              <a:rPr sz="850" b="0">
+                <a:solidFill>
+                  <a:srgbClr val="CCD2DF"/>
+                </a:solidFill>
+                <a:latin typeface="Calibri"/>
+              </a:rPr>
+              <a:t>Live product accessible at vaughnmartin.com — no login required for the 12-Minute Test Drive. All slide metrics are either proprietary platform counts, mathematically derived, or labeled as targets/models. Confidential — For Qualified Investor Use Only.</a:t>
+            </a:r>
+          </a:p>
+        </p:txBody>
+      </p:sp>
+      <p:sp>
+        <p:nvSpPr>
+          <p:cNvPr id="26" name="TextBox 25"/>
+          <p:cNvSpPr txBox="1"/>
+          <p:nvPr/>
+        </p:nvSpPr>
+        <p:spPr>
+          <a:xfrm>
+            <a:off x="502920" y="6510528"/>
+            <a:ext cx="11155680" cy="256032"/>
+          </a:xfrm>
+          <a:prstGeom prst="rect">
+            <a:avLst/>
+          </a:prstGeom>
+          <a:noFill/>
+        </p:spPr>
+        <p:txBody>
+          <a:bodyPr wrap="square">
+            <a:spAutoFit/>
+          </a:bodyPr>
+          <a:lstStyle/>
+          <a:p>
+            <a:pPr algn="ctr"/>
+            <a:r>
+              <a:rPr sz="750" b="0">
+                <a:solidFill>
+                  <a:srgbClr val="C9A84C"/>
+                </a:solidFill>
+                <a:latin typeface="Calibri"/>
+              </a:rPr>
+              <a:t>VaughnMartin Readiness OS  ·  Confidential — For Qualified Investor Use Only  ·  vaughnmartin.com</a:t>
+            </a:r>
+          </a:p>
+        </p:txBody>
+      </p:sp>
+    </p:spTree>
+  </p:cSld>
+  <p:clrMapOvr>
+    <a:masterClrMapping/>
+  </p:clrMapOvr>
+</p:sld>
+</file>
+
 <file path=ppt/slides/slide2.xml><?xml version="1.0" encoding="utf-8"?>
 <p:sld xmlns:a="http://schemas.openxmlformats.org/drawingml/2006/main" xmlns:p="http://schemas.openxmlformats.org/presentationml/2006/main" xmlns:r="http://schemas.openxmlformats.org/officeDocument/2006/relationships">
   <p:cSld>
@@ -16885,6 +17840,76 @@
                 <a:latin typeface="Calibri"/>
               </a:rPr>
               <a:t>"Your Microsoft investment is already in place. Readiness OS is the operating model layer that makes it execute at enterprise speed."</a:t>
+            </a:r>
+          </a:p>
+        </p:txBody>
+      </p:sp>
+      <p:sp>
+        <p:nvSpPr>
+          <p:cNvPr id="34" name="TextBox 33"/>
+          <p:cNvSpPr txBox="1"/>
+          <p:nvPr/>
+        </p:nvSpPr>
+        <p:spPr>
+          <a:xfrm>
+            <a:off x="502920" y="3246120"/>
+            <a:ext cx="3200400" cy="256032"/>
+          </a:xfrm>
+          <a:prstGeom prst="rect">
+            <a:avLst/>
+          </a:prstGeom>
+          <a:noFill/>
+        </p:spPr>
+        <p:txBody>
+          <a:bodyPr wrap="square">
+            <a:spAutoFit/>
+          </a:bodyPr>
+          <a:lstStyle/>
+          <a:p>
+            <a:pPr algn="l"/>
+            <a:r>
+              <a:rPr sz="750" b="0">
+                <a:solidFill>
+                  <a:srgbClr val="8899BB"/>
+                </a:solidFill>
+                <a:latin typeface="Calibri"/>
+              </a:rPr>
+              <a:t>Gartner SPM + GRC + EPMO categories</a:t>
+            </a:r>
+          </a:p>
+        </p:txBody>
+      </p:sp>
+      <p:sp>
+        <p:nvSpPr>
+          <p:cNvPr id="35" name="TextBox 34"/>
+          <p:cNvSpPr txBox="1"/>
+          <p:nvPr/>
+        </p:nvSpPr>
+        <p:spPr>
+          <a:xfrm>
+            <a:off x="502920" y="6144768"/>
+            <a:ext cx="11155680" cy="237744"/>
+          </a:xfrm>
+          <a:prstGeom prst="rect">
+            <a:avLst/>
+          </a:prstGeom>
+          <a:noFill/>
+        </p:spPr>
+        <p:txBody>
+          <a:bodyPr wrap="square">
+            <a:spAutoFit/>
+          </a:bodyPr>
+          <a:lstStyle/>
+          <a:p>
+            <a:pPr algn="l"/>
+            <a:r>
+              <a:rPr sz="750" b="0">
+                <a:solidFill>
+                  <a:srgbClr val="7788AA"/>
+                </a:solidFill>
+                <a:latin typeface="Calibri"/>
+              </a:rPr>
+              <a:t>Sources: Gartner Strategic Portfolio Management 2025  ·  McKinsey Organizational Agility Research 2025  ·  WEF × Accenture March 2026</a:t>
             </a:r>
           </a:p>
         </p:txBody>

</xml_diff>

<commit_message>
Update presentation slide to remove confusing elements
Adjust the sources slide to fix a visual overlap and clarify accessibility claims.

Replit-Commit-Author: Agent
Replit-Commit-Session-Id: 85f09f3c-352d-446d-b98e-3f307c26fc5a
Replit-Commit-Checkpoint-Type: full_checkpoint
Replit-Commit-Event-Id: c7feab01-0258-4d5b-ab6e-cd85794be05c
Replit-Commit-Screenshot-Url: https://storage.googleapis.com/screenshot-production-us-central1/3bd53afc-ff4f-401b-9e3d-b367791ef629/85f09f3c-352d-446d-b98e-3f307c26fc5a/zIh07K6
Replit-Helium-Checkpoint-Created: true
</commit_message>
<xml_diff>
--- a/attached_assets/VaughnMartin-4min-Pitch.pptx
+++ b/attached_assets/VaughnMartin-4min-Pitch.pptx
@@ -9136,14 +9136,579 @@
       </p:sp>
       <p:sp>
         <p:nvSpPr>
-          <p:cNvPr id="7" name="Rectangle 6"/>
+          <p:cNvPr id="8" name="Rectangle 7"/>
           <p:cNvSpPr/>
           <p:nvPr/>
         </p:nvSpPr>
         <p:spPr>
           <a:xfrm>
-            <a:off x="502920" y="1426464"/>
-            <a:ext cx="1097280" cy="19050"/>
+            <a:off x="502920" y="1572768"/>
+            <a:ext cx="31750" cy="699008"/>
+          </a:xfrm>
+          <a:prstGeom prst="rect">
+            <a:avLst/>
+          </a:prstGeom>
+          <a:solidFill>
+            <a:srgbClr val="2B8A6E"/>
+          </a:solidFill>
+          <a:ln>
+            <a:noFill/>
+          </a:ln>
+        </p:spPr>
+        <p:style>
+          <a:lnRef idx="1">
+            <a:schemeClr val="accent1"/>
+          </a:lnRef>
+          <a:fillRef idx="3">
+            <a:schemeClr val="accent1"/>
+          </a:fillRef>
+          <a:effectRef idx="2">
+            <a:schemeClr val="accent1"/>
+          </a:effectRef>
+          <a:fontRef idx="minor">
+            <a:schemeClr val="lt1"/>
+          </a:fontRef>
+        </p:style>
+        <p:txBody>
+          <a:bodyPr rtlCol="0" anchor="ctr"/>
+          <a:lstStyle/>
+          <a:p>
+            <a:pPr algn="ctr"/>
+          </a:p>
+        </p:txBody>
+      </p:sp>
+      <p:sp>
+        <p:nvSpPr>
+          <p:cNvPr id="9" name="TextBox 8"/>
+          <p:cNvSpPr txBox="1"/>
+          <p:nvPr/>
+        </p:nvSpPr>
+        <p:spPr>
+          <a:xfrm>
+            <a:off x="685800" y="1609344"/>
+            <a:ext cx="10789920" cy="219456"/>
+          </a:xfrm>
+          <a:prstGeom prst="rect">
+            <a:avLst/>
+          </a:prstGeom>
+          <a:noFill/>
+        </p:spPr>
+        <p:txBody>
+          <a:bodyPr wrap="square">
+            <a:spAutoFit/>
+          </a:bodyPr>
+          <a:lstStyle/>
+          <a:p>
+            <a:pPr algn="l"/>
+            <a:r>
+              <a:rPr sz="800" b="1">
+                <a:solidFill>
+                  <a:srgbClr val="C9A84C"/>
+                </a:solidFill>
+                <a:latin typeface="Calibri"/>
+              </a:rPr>
+              <a:t>Slides 1, 4  ·  30-Day Mobilization Baseline &amp; 3,600× Calculation</a:t>
+            </a:r>
+          </a:p>
+        </p:txBody>
+      </p:sp>
+      <p:sp>
+        <p:nvSpPr>
+          <p:cNvPr id="10" name="TextBox 9"/>
+          <p:cNvSpPr txBox="1"/>
+          <p:nvPr/>
+        </p:nvSpPr>
+        <p:spPr>
+          <a:xfrm>
+            <a:off x="685800" y="1819656"/>
+            <a:ext cx="10789920" cy="457200"/>
+          </a:xfrm>
+          <a:prstGeom prst="rect">
+            <a:avLst/>
+          </a:prstGeom>
+          <a:noFill/>
+        </p:spPr>
+        <p:txBody>
+          <a:bodyPr wrap="square">
+            <a:spAutoFit/>
+          </a:bodyPr>
+          <a:lstStyle/>
+          <a:p>
+            <a:pPr algn="l"/>
+            <a:r>
+              <a:rPr sz="850" b="0">
+                <a:solidFill>
+                  <a:srgbClr val="CCD2DF"/>
+                </a:solidFill>
+                <a:latin typeface="Calibri"/>
+              </a:rPr>
+              <a:t>VaughnMartin operational research — 20+ years direct experience across Ford, Toyota, Lockheed Martin, Charles Schwab, and Boyd Gaming. McKinsey Organizational Agility Research (2025). Calculation: 30 days × 24 hrs × 60 min = 43,200 min ÷ 12 min = 3,600×. Baseline is average Fortune 1000 cross-functional mobilization cycle.</a:t>
+            </a:r>
+          </a:p>
+        </p:txBody>
+      </p:sp>
+      <p:sp>
+        <p:nvSpPr>
+          <p:cNvPr id="11" name="Rectangle 10"/>
+          <p:cNvSpPr/>
+          <p:nvPr/>
+        </p:nvSpPr>
+        <p:spPr>
+          <a:xfrm>
+            <a:off x="502920" y="2322576"/>
+            <a:ext cx="31750" cy="699008"/>
+          </a:xfrm>
+          <a:prstGeom prst="rect">
+            <a:avLst/>
+          </a:prstGeom>
+          <a:solidFill>
+            <a:srgbClr val="2B8A6E"/>
+          </a:solidFill>
+          <a:ln>
+            <a:noFill/>
+          </a:ln>
+        </p:spPr>
+        <p:style>
+          <a:lnRef idx="1">
+            <a:schemeClr val="accent1"/>
+          </a:lnRef>
+          <a:fillRef idx="3">
+            <a:schemeClr val="accent1"/>
+          </a:fillRef>
+          <a:effectRef idx="2">
+            <a:schemeClr val="accent1"/>
+          </a:effectRef>
+          <a:fontRef idx="minor">
+            <a:schemeClr val="lt1"/>
+          </a:fontRef>
+        </p:style>
+        <p:txBody>
+          <a:bodyPr rtlCol="0" anchor="ctr"/>
+          <a:lstStyle/>
+          <a:p>
+            <a:pPr algn="ctr"/>
+          </a:p>
+        </p:txBody>
+      </p:sp>
+      <p:sp>
+        <p:nvSpPr>
+          <p:cNvPr id="12" name="TextBox 11"/>
+          <p:cNvSpPr txBox="1"/>
+          <p:nvPr/>
+        </p:nvSpPr>
+        <p:spPr>
+          <a:xfrm>
+            <a:off x="685800" y="2359152"/>
+            <a:ext cx="10789920" cy="219456"/>
+          </a:xfrm>
+          <a:prstGeom prst="rect">
+            <a:avLst/>
+          </a:prstGeom>
+          <a:noFill/>
+        </p:spPr>
+        <p:txBody>
+          <a:bodyPr wrap="square">
+            <a:spAutoFit/>
+          </a:bodyPr>
+          <a:lstStyle/>
+          <a:p>
+            <a:pPr algn="l"/>
+            <a:r>
+              <a:rPr sz="800" b="1">
+                <a:solidFill>
+                  <a:srgbClr val="C9A84C"/>
+                </a:solidFill>
+                <a:latin typeface="Calibri"/>
+              </a:rPr>
+              <a:t>Slide 7  ·  $42B TAM / $4.8B SAM / $180M SOM</a:t>
+            </a:r>
+          </a:p>
+        </p:txBody>
+      </p:sp>
+      <p:sp>
+        <p:nvSpPr>
+          <p:cNvPr id="13" name="TextBox 12"/>
+          <p:cNvSpPr txBox="1"/>
+          <p:nvPr/>
+        </p:nvSpPr>
+        <p:spPr>
+          <a:xfrm>
+            <a:off x="685800" y="2569464"/>
+            <a:ext cx="10789920" cy="457200"/>
+          </a:xfrm>
+          <a:prstGeom prst="rect">
+            <a:avLst/>
+          </a:prstGeom>
+          <a:noFill/>
+        </p:spPr>
+        <p:txBody>
+          <a:bodyPr wrap="square">
+            <a:spAutoFit/>
+          </a:bodyPr>
+          <a:lstStyle/>
+          <a:p>
+            <a:pPr algn="l"/>
+            <a:r>
+              <a:rPr sz="850" b="0">
+                <a:solidFill>
+                  <a:srgbClr val="CCD2DF"/>
+                </a:solidFill>
+                <a:latin typeface="Calibri"/>
+              </a:rPr>
+              <a:t>Gartner Strategic Portfolio Management 2025 (SPM + GRC + EPMO combined categories). McKinsey 2025 coordination cost research. WEF × Accenture Strategic Readiness Report, March 2026. SAM: ~25K target accounts × $200K avg ACV. SOM: 600 customers × $300K avg ACV by Year 5.</a:t>
+            </a:r>
+          </a:p>
+        </p:txBody>
+      </p:sp>
+      <p:sp>
+        <p:nvSpPr>
+          <p:cNvPr id="14" name="Rectangle 13"/>
+          <p:cNvSpPr/>
+          <p:nvPr/>
+        </p:nvSpPr>
+        <p:spPr>
+          <a:xfrm>
+            <a:off x="502920" y="3072384"/>
+            <a:ext cx="31750" cy="699008"/>
+          </a:xfrm>
+          <a:prstGeom prst="rect">
+            <a:avLst/>
+          </a:prstGeom>
+          <a:solidFill>
+            <a:srgbClr val="2B8A6E"/>
+          </a:solidFill>
+          <a:ln>
+            <a:noFill/>
+          </a:ln>
+        </p:spPr>
+        <p:style>
+          <a:lnRef idx="1">
+            <a:schemeClr val="accent1"/>
+          </a:lnRef>
+          <a:fillRef idx="3">
+            <a:schemeClr val="accent1"/>
+          </a:fillRef>
+          <a:effectRef idx="2">
+            <a:schemeClr val="accent1"/>
+          </a:effectRef>
+          <a:fontRef idx="minor">
+            <a:schemeClr val="lt1"/>
+          </a:fontRef>
+        </p:style>
+        <p:txBody>
+          <a:bodyPr rtlCol="0" anchor="ctr"/>
+          <a:lstStyle/>
+          <a:p>
+            <a:pPr algn="ctr"/>
+          </a:p>
+        </p:txBody>
+      </p:sp>
+      <p:sp>
+        <p:nvSpPr>
+          <p:cNvPr id="15" name="TextBox 14"/>
+          <p:cNvSpPr txBox="1"/>
+          <p:nvPr/>
+        </p:nvSpPr>
+        <p:spPr>
+          <a:xfrm>
+            <a:off x="685800" y="3108960"/>
+            <a:ext cx="10789920" cy="219456"/>
+          </a:xfrm>
+          <a:prstGeom prst="rect">
+            <a:avLst/>
+          </a:prstGeom>
+          <a:noFill/>
+        </p:spPr>
+        <p:txBody>
+          <a:bodyPr wrap="square">
+            <a:spAutoFit/>
+          </a:bodyPr>
+          <a:lstStyle/>
+          <a:p>
+            <a:pPr algn="l"/>
+            <a:r>
+              <a:rPr sz="800" b="1">
+                <a:solidFill>
+                  <a:srgbClr val="C9A84C"/>
+                </a:solidFill>
+                <a:latin typeface="Calibri"/>
+              </a:rPr>
+              <a:t>Slide 6  ·  67% Execution Improvement</a:t>
+            </a:r>
+          </a:p>
+        </p:txBody>
+      </p:sp>
+      <p:sp>
+        <p:nvSpPr>
+          <p:cNvPr id="16" name="TextBox 15"/>
+          <p:cNvSpPr txBox="1"/>
+          <p:nvPr/>
+        </p:nvSpPr>
+        <p:spPr>
+          <a:xfrm>
+            <a:off x="685800" y="3319272"/>
+            <a:ext cx="10789920" cy="457200"/>
+          </a:xfrm>
+          <a:prstGeom prst="rect">
+            <a:avLst/>
+          </a:prstGeom>
+          <a:noFill/>
+        </p:spPr>
+        <p:txBody>
+          <a:bodyPr wrap="square">
+            <a:spAutoFit/>
+          </a:bodyPr>
+          <a:lstStyle/>
+          <a:p>
+            <a:pPr algn="l"/>
+            <a:r>
+              <a:rPr sz="850" b="0">
+                <a:solidFill>
+                  <a:srgbClr val="CCD2DF"/>
+                </a:solidFill>
+                <a:latin typeface="Calibri"/>
+              </a:rPr>
+              <a:t>VaughnMartin simulation-validated performance modeling based on platform activation cycle data. Labeled "simulation-validated" on slide. Baseline: enterprise crisis response timelines across GROWTH &amp; POSITIONING, RISK &amp; RESILIENCE, and TRANSFORMATION domain scenarios.</a:t>
+            </a:r>
+          </a:p>
+        </p:txBody>
+      </p:sp>
+      <p:sp>
+        <p:nvSpPr>
+          <p:cNvPr id="17" name="Rectangle 16"/>
+          <p:cNvSpPr/>
+          <p:nvPr/>
+        </p:nvSpPr>
+        <p:spPr>
+          <a:xfrm>
+            <a:off x="502920" y="3822192"/>
+            <a:ext cx="31750" cy="699008"/>
+          </a:xfrm>
+          <a:prstGeom prst="rect">
+            <a:avLst/>
+          </a:prstGeom>
+          <a:solidFill>
+            <a:srgbClr val="2B8A6E"/>
+          </a:solidFill>
+          <a:ln>
+            <a:noFill/>
+          </a:ln>
+        </p:spPr>
+        <p:style>
+          <a:lnRef idx="1">
+            <a:schemeClr val="accent1"/>
+          </a:lnRef>
+          <a:fillRef idx="3">
+            <a:schemeClr val="accent1"/>
+          </a:fillRef>
+          <a:effectRef idx="2">
+            <a:schemeClr val="accent1"/>
+          </a:effectRef>
+          <a:fontRef idx="minor">
+            <a:schemeClr val="lt1"/>
+          </a:fontRef>
+        </p:style>
+        <p:txBody>
+          <a:bodyPr rtlCol="0" anchor="ctr"/>
+          <a:lstStyle/>
+          <a:p>
+            <a:pPr algn="ctr"/>
+          </a:p>
+        </p:txBody>
+      </p:sp>
+      <p:sp>
+        <p:nvSpPr>
+          <p:cNvPr id="18" name="TextBox 17"/>
+          <p:cNvSpPr txBox="1"/>
+          <p:nvPr/>
+        </p:nvSpPr>
+        <p:spPr>
+          <a:xfrm>
+            <a:off x="685800" y="3858768"/>
+            <a:ext cx="10789920" cy="219456"/>
+          </a:xfrm>
+          <a:prstGeom prst="rect">
+            <a:avLst/>
+          </a:prstGeom>
+          <a:noFill/>
+        </p:spPr>
+        <p:txBody>
+          <a:bodyPr wrap="square">
+            <a:spAutoFit/>
+          </a:bodyPr>
+          <a:lstStyle/>
+          <a:p>
+            <a:pPr algn="l"/>
+            <a:r>
+              <a:rPr sz="800" b="1">
+                <a:solidFill>
+                  <a:srgbClr val="C9A84C"/>
+                </a:solidFill>
+                <a:latin typeface="Calibri"/>
+              </a:rPr>
+              <a:t>Slide 8  ·  Platform Metrics</a:t>
+            </a:r>
+          </a:p>
+        </p:txBody>
+      </p:sp>
+      <p:sp>
+        <p:nvSpPr>
+          <p:cNvPr id="19" name="TextBox 18"/>
+          <p:cNvSpPr txBox="1"/>
+          <p:nvPr/>
+        </p:nvSpPr>
+        <p:spPr>
+          <a:xfrm>
+            <a:off x="685800" y="4069080"/>
+            <a:ext cx="10789920" cy="457200"/>
+          </a:xfrm>
+          <a:prstGeom prst="rect">
+            <a:avLst/>
+          </a:prstGeom>
+          <a:noFill/>
+        </p:spPr>
+        <p:txBody>
+          <a:bodyPr wrap="square">
+            <a:spAutoFit/>
+          </a:bodyPr>
+          <a:lstStyle/>
+          <a:p>
+            <a:pPr algn="l"/>
+            <a:r>
+              <a:rPr sz="850" b="0">
+                <a:solidFill>
+                  <a:srgbClr val="CCD2DF"/>
+                </a:solidFill>
+                <a:latin typeface="Calibri"/>
+              </a:rPr>
+              <a:t>VaughnMartin Readiness OS production system, May 2026. All platform layers live in production. 221 strategic triggers. 170 Readiness Protocols. 12 Compound Protocol Engines. 8 live signal sources on 15-minute monitoring cycles. Verifiable at vaughnmartin.com</a:t>
+            </a:r>
+          </a:p>
+        </p:txBody>
+      </p:sp>
+      <p:sp>
+        <p:nvSpPr>
+          <p:cNvPr id="20" name="Rectangle 19"/>
+          <p:cNvSpPr/>
+          <p:nvPr/>
+        </p:nvSpPr>
+        <p:spPr>
+          <a:xfrm>
+            <a:off x="502920" y="4572000"/>
+            <a:ext cx="31750" cy="699008"/>
+          </a:xfrm>
+          <a:prstGeom prst="rect">
+            <a:avLst/>
+          </a:prstGeom>
+          <a:solidFill>
+            <a:srgbClr val="2B8A6E"/>
+          </a:solidFill>
+          <a:ln>
+            <a:noFill/>
+          </a:ln>
+        </p:spPr>
+        <p:style>
+          <a:lnRef idx="1">
+            <a:schemeClr val="accent1"/>
+          </a:lnRef>
+          <a:fillRef idx="3">
+            <a:schemeClr val="accent1"/>
+          </a:fillRef>
+          <a:effectRef idx="2">
+            <a:schemeClr val="accent1"/>
+          </a:effectRef>
+          <a:fontRef idx="minor">
+            <a:schemeClr val="lt1"/>
+          </a:fontRef>
+        </p:style>
+        <p:txBody>
+          <a:bodyPr rtlCol="0" anchor="ctr"/>
+          <a:lstStyle/>
+          <a:p>
+            <a:pPr algn="ctr"/>
+          </a:p>
+        </p:txBody>
+      </p:sp>
+      <p:sp>
+        <p:nvSpPr>
+          <p:cNvPr id="21" name="TextBox 20"/>
+          <p:cNvSpPr txBox="1"/>
+          <p:nvPr/>
+        </p:nvSpPr>
+        <p:spPr>
+          <a:xfrm>
+            <a:off x="685800" y="4608576"/>
+            <a:ext cx="10789920" cy="219456"/>
+          </a:xfrm>
+          <a:prstGeom prst="rect">
+            <a:avLst/>
+          </a:prstGeom>
+          <a:noFill/>
+        </p:spPr>
+        <p:txBody>
+          <a:bodyPr wrap="square">
+            <a:spAutoFit/>
+          </a:bodyPr>
+          <a:lstStyle/>
+          <a:p>
+            <a:pPr algn="l"/>
+            <a:r>
+              <a:rPr sz="800" b="1">
+                <a:solidFill>
+                  <a:srgbClr val="C9A84C"/>
+                </a:solidFill>
+                <a:latin typeface="Calibri"/>
+              </a:rPr>
+              <a:t>Slide 8  ·  Business Model &amp; Unit Economics</a:t>
+            </a:r>
+          </a:p>
+        </p:txBody>
+      </p:sp>
+      <p:sp>
+        <p:nvSpPr>
+          <p:cNvPr id="22" name="TextBox 21"/>
+          <p:cNvSpPr txBox="1"/>
+          <p:nvPr/>
+        </p:nvSpPr>
+        <p:spPr>
+          <a:xfrm>
+            <a:off x="685800" y="4818888"/>
+            <a:ext cx="10789920" cy="457200"/>
+          </a:xfrm>
+          <a:prstGeom prst="rect">
+            <a:avLst/>
+          </a:prstGeom>
+          <a:noFill/>
+        </p:spPr>
+        <p:txBody>
+          <a:bodyPr wrap="square">
+            <a:spAutoFit/>
+          </a:bodyPr>
+          <a:lstStyle/>
+          <a:p>
+            <a:pPr algn="l"/>
+            <a:r>
+              <a:rPr sz="850" b="0">
+                <a:solidFill>
+                  <a:srgbClr val="CCD2DF"/>
+                </a:solidFill>
+                <a:latin typeface="Calibri"/>
+              </a:rPr>
+              <a:t>VaughnMartin internal pricing model. $120K Average ACV based on Founding Partner tier mid-point. 92% Target Gross Margin based on SaaS infrastructure cost modeling at scale. &lt;6 Month Payback Period derived from enterprise crisis cost avoidance vs. annual platform fee. 2–4 Weeks First Results based on onboarding timeline: Week 1 setup, Weeks 2–4 live protocols.</a:t>
+            </a:r>
+          </a:p>
+        </p:txBody>
+      </p:sp>
+      <p:sp>
+        <p:nvSpPr>
+          <p:cNvPr id="23" name="Rectangle 22"/>
+          <p:cNvSpPr/>
+          <p:nvPr/>
+        </p:nvSpPr>
+        <p:spPr>
+          <a:xfrm>
+            <a:off x="502920" y="5321808"/>
+            <a:ext cx="31750" cy="699008"/>
           </a:xfrm>
           <a:prstGeom prst="rect">
             <a:avLst/>
@@ -9179,614 +9744,6 @@
       </p:sp>
       <p:sp>
         <p:nvSpPr>
-          <p:cNvPr id="8" name="Rectangle 7"/>
-          <p:cNvSpPr/>
-          <p:nvPr/>
-        </p:nvSpPr>
-        <p:spPr>
-          <a:xfrm>
-            <a:off x="502920" y="1572768"/>
-            <a:ext cx="31750" cy="699008"/>
-          </a:xfrm>
-          <a:prstGeom prst="rect">
-            <a:avLst/>
-          </a:prstGeom>
-          <a:solidFill>
-            <a:srgbClr val="2B8A6E"/>
-          </a:solidFill>
-          <a:ln>
-            <a:noFill/>
-          </a:ln>
-        </p:spPr>
-        <p:style>
-          <a:lnRef idx="1">
-            <a:schemeClr val="accent1"/>
-          </a:lnRef>
-          <a:fillRef idx="3">
-            <a:schemeClr val="accent1"/>
-          </a:fillRef>
-          <a:effectRef idx="2">
-            <a:schemeClr val="accent1"/>
-          </a:effectRef>
-          <a:fontRef idx="minor">
-            <a:schemeClr val="lt1"/>
-          </a:fontRef>
-        </p:style>
-        <p:txBody>
-          <a:bodyPr rtlCol="0" anchor="ctr"/>
-          <a:lstStyle/>
-          <a:p>
-            <a:pPr algn="ctr"/>
-          </a:p>
-        </p:txBody>
-      </p:sp>
-      <p:sp>
-        <p:nvSpPr>
-          <p:cNvPr id="9" name="TextBox 8"/>
-          <p:cNvSpPr txBox="1"/>
-          <p:nvPr/>
-        </p:nvSpPr>
-        <p:spPr>
-          <a:xfrm>
-            <a:off x="685800" y="1609344"/>
-            <a:ext cx="10789920" cy="219456"/>
-          </a:xfrm>
-          <a:prstGeom prst="rect">
-            <a:avLst/>
-          </a:prstGeom>
-          <a:noFill/>
-        </p:spPr>
-        <p:txBody>
-          <a:bodyPr wrap="square">
-            <a:spAutoFit/>
-          </a:bodyPr>
-          <a:lstStyle/>
-          <a:p>
-            <a:pPr algn="l"/>
-            <a:r>
-              <a:rPr sz="800" b="1">
-                <a:solidFill>
-                  <a:srgbClr val="C9A84C"/>
-                </a:solidFill>
-                <a:latin typeface="Calibri"/>
-              </a:rPr>
-              <a:t>Slides 1, 4  ·  30-Day Mobilization Baseline &amp; 3,600× Calculation</a:t>
-            </a:r>
-          </a:p>
-        </p:txBody>
-      </p:sp>
-      <p:sp>
-        <p:nvSpPr>
-          <p:cNvPr id="10" name="TextBox 9"/>
-          <p:cNvSpPr txBox="1"/>
-          <p:nvPr/>
-        </p:nvSpPr>
-        <p:spPr>
-          <a:xfrm>
-            <a:off x="685800" y="1819656"/>
-            <a:ext cx="10789920" cy="457200"/>
-          </a:xfrm>
-          <a:prstGeom prst="rect">
-            <a:avLst/>
-          </a:prstGeom>
-          <a:noFill/>
-        </p:spPr>
-        <p:txBody>
-          <a:bodyPr wrap="square">
-            <a:spAutoFit/>
-          </a:bodyPr>
-          <a:lstStyle/>
-          <a:p>
-            <a:pPr algn="l"/>
-            <a:r>
-              <a:rPr sz="850" b="0">
-                <a:solidFill>
-                  <a:srgbClr val="CCD2DF"/>
-                </a:solidFill>
-                <a:latin typeface="Calibri"/>
-              </a:rPr>
-              <a:t>VaughnMartin operational research — 20+ years direct experience across Ford, Toyota, Lockheed Martin, Charles Schwab, and Boyd Gaming. McKinsey Organizational Agility Research (2025). Calculation: 30 days × 24 hrs × 60 min = 43,200 min ÷ 12 min = 3,600×. Baseline is average Fortune 1000 cross-functional mobilization cycle.</a:t>
-            </a:r>
-          </a:p>
-        </p:txBody>
-      </p:sp>
-      <p:sp>
-        <p:nvSpPr>
-          <p:cNvPr id="11" name="Rectangle 10"/>
-          <p:cNvSpPr/>
-          <p:nvPr/>
-        </p:nvSpPr>
-        <p:spPr>
-          <a:xfrm>
-            <a:off x="502920" y="2322576"/>
-            <a:ext cx="31750" cy="699008"/>
-          </a:xfrm>
-          <a:prstGeom prst="rect">
-            <a:avLst/>
-          </a:prstGeom>
-          <a:solidFill>
-            <a:srgbClr val="2B8A6E"/>
-          </a:solidFill>
-          <a:ln>
-            <a:noFill/>
-          </a:ln>
-        </p:spPr>
-        <p:style>
-          <a:lnRef idx="1">
-            <a:schemeClr val="accent1"/>
-          </a:lnRef>
-          <a:fillRef idx="3">
-            <a:schemeClr val="accent1"/>
-          </a:fillRef>
-          <a:effectRef idx="2">
-            <a:schemeClr val="accent1"/>
-          </a:effectRef>
-          <a:fontRef idx="minor">
-            <a:schemeClr val="lt1"/>
-          </a:fontRef>
-        </p:style>
-        <p:txBody>
-          <a:bodyPr rtlCol="0" anchor="ctr"/>
-          <a:lstStyle/>
-          <a:p>
-            <a:pPr algn="ctr"/>
-          </a:p>
-        </p:txBody>
-      </p:sp>
-      <p:sp>
-        <p:nvSpPr>
-          <p:cNvPr id="12" name="TextBox 11"/>
-          <p:cNvSpPr txBox="1"/>
-          <p:nvPr/>
-        </p:nvSpPr>
-        <p:spPr>
-          <a:xfrm>
-            <a:off x="685800" y="2359152"/>
-            <a:ext cx="10789920" cy="219456"/>
-          </a:xfrm>
-          <a:prstGeom prst="rect">
-            <a:avLst/>
-          </a:prstGeom>
-          <a:noFill/>
-        </p:spPr>
-        <p:txBody>
-          <a:bodyPr wrap="square">
-            <a:spAutoFit/>
-          </a:bodyPr>
-          <a:lstStyle/>
-          <a:p>
-            <a:pPr algn="l"/>
-            <a:r>
-              <a:rPr sz="800" b="1">
-                <a:solidFill>
-                  <a:srgbClr val="C9A84C"/>
-                </a:solidFill>
-                <a:latin typeface="Calibri"/>
-              </a:rPr>
-              <a:t>Slide 7  ·  $42B TAM / $4.8B SAM / $180M SOM</a:t>
-            </a:r>
-          </a:p>
-        </p:txBody>
-      </p:sp>
-      <p:sp>
-        <p:nvSpPr>
-          <p:cNvPr id="13" name="TextBox 12"/>
-          <p:cNvSpPr txBox="1"/>
-          <p:nvPr/>
-        </p:nvSpPr>
-        <p:spPr>
-          <a:xfrm>
-            <a:off x="685800" y="2569464"/>
-            <a:ext cx="10789920" cy="457200"/>
-          </a:xfrm>
-          <a:prstGeom prst="rect">
-            <a:avLst/>
-          </a:prstGeom>
-          <a:noFill/>
-        </p:spPr>
-        <p:txBody>
-          <a:bodyPr wrap="square">
-            <a:spAutoFit/>
-          </a:bodyPr>
-          <a:lstStyle/>
-          <a:p>
-            <a:pPr algn="l"/>
-            <a:r>
-              <a:rPr sz="850" b="0">
-                <a:solidFill>
-                  <a:srgbClr val="CCD2DF"/>
-                </a:solidFill>
-                <a:latin typeface="Calibri"/>
-              </a:rPr>
-              <a:t>Gartner Strategic Portfolio Management 2025 (SPM + GRC + EPMO combined categories). McKinsey 2025 coordination cost research. WEF × Accenture Strategic Readiness Report, March 2026. SAM: ~25K target accounts × $200K avg ACV. SOM: 600 customers × $300K avg ACV by Year 5.</a:t>
-            </a:r>
-          </a:p>
-        </p:txBody>
-      </p:sp>
-      <p:sp>
-        <p:nvSpPr>
-          <p:cNvPr id="14" name="Rectangle 13"/>
-          <p:cNvSpPr/>
-          <p:nvPr/>
-        </p:nvSpPr>
-        <p:spPr>
-          <a:xfrm>
-            <a:off x="502920" y="3072384"/>
-            <a:ext cx="31750" cy="699008"/>
-          </a:xfrm>
-          <a:prstGeom prst="rect">
-            <a:avLst/>
-          </a:prstGeom>
-          <a:solidFill>
-            <a:srgbClr val="2B8A6E"/>
-          </a:solidFill>
-          <a:ln>
-            <a:noFill/>
-          </a:ln>
-        </p:spPr>
-        <p:style>
-          <a:lnRef idx="1">
-            <a:schemeClr val="accent1"/>
-          </a:lnRef>
-          <a:fillRef idx="3">
-            <a:schemeClr val="accent1"/>
-          </a:fillRef>
-          <a:effectRef idx="2">
-            <a:schemeClr val="accent1"/>
-          </a:effectRef>
-          <a:fontRef idx="minor">
-            <a:schemeClr val="lt1"/>
-          </a:fontRef>
-        </p:style>
-        <p:txBody>
-          <a:bodyPr rtlCol="0" anchor="ctr"/>
-          <a:lstStyle/>
-          <a:p>
-            <a:pPr algn="ctr"/>
-          </a:p>
-        </p:txBody>
-      </p:sp>
-      <p:sp>
-        <p:nvSpPr>
-          <p:cNvPr id="15" name="TextBox 14"/>
-          <p:cNvSpPr txBox="1"/>
-          <p:nvPr/>
-        </p:nvSpPr>
-        <p:spPr>
-          <a:xfrm>
-            <a:off x="685800" y="3108960"/>
-            <a:ext cx="10789920" cy="219456"/>
-          </a:xfrm>
-          <a:prstGeom prst="rect">
-            <a:avLst/>
-          </a:prstGeom>
-          <a:noFill/>
-        </p:spPr>
-        <p:txBody>
-          <a:bodyPr wrap="square">
-            <a:spAutoFit/>
-          </a:bodyPr>
-          <a:lstStyle/>
-          <a:p>
-            <a:pPr algn="l"/>
-            <a:r>
-              <a:rPr sz="800" b="1">
-                <a:solidFill>
-                  <a:srgbClr val="C9A84C"/>
-                </a:solidFill>
-                <a:latin typeface="Calibri"/>
-              </a:rPr>
-              <a:t>Slide 6  ·  67% Execution Improvement</a:t>
-            </a:r>
-          </a:p>
-        </p:txBody>
-      </p:sp>
-      <p:sp>
-        <p:nvSpPr>
-          <p:cNvPr id="16" name="TextBox 15"/>
-          <p:cNvSpPr txBox="1"/>
-          <p:nvPr/>
-        </p:nvSpPr>
-        <p:spPr>
-          <a:xfrm>
-            <a:off x="685800" y="3319272"/>
-            <a:ext cx="10789920" cy="457200"/>
-          </a:xfrm>
-          <a:prstGeom prst="rect">
-            <a:avLst/>
-          </a:prstGeom>
-          <a:noFill/>
-        </p:spPr>
-        <p:txBody>
-          <a:bodyPr wrap="square">
-            <a:spAutoFit/>
-          </a:bodyPr>
-          <a:lstStyle/>
-          <a:p>
-            <a:pPr algn="l"/>
-            <a:r>
-              <a:rPr sz="850" b="0">
-                <a:solidFill>
-                  <a:srgbClr val="CCD2DF"/>
-                </a:solidFill>
-                <a:latin typeface="Calibri"/>
-              </a:rPr>
-              <a:t>VaughnMartin simulation-validated performance modeling based on platform activation cycle data. Labeled "simulation-validated" on slide. Baseline: enterprise crisis response timelines across GROWTH &amp; POSITIONING, RISK &amp; RESILIENCE, and TRANSFORMATION domain scenarios.</a:t>
-            </a:r>
-          </a:p>
-        </p:txBody>
-      </p:sp>
-      <p:sp>
-        <p:nvSpPr>
-          <p:cNvPr id="17" name="Rectangle 16"/>
-          <p:cNvSpPr/>
-          <p:nvPr/>
-        </p:nvSpPr>
-        <p:spPr>
-          <a:xfrm>
-            <a:off x="502920" y="3822192"/>
-            <a:ext cx="31750" cy="699008"/>
-          </a:xfrm>
-          <a:prstGeom prst="rect">
-            <a:avLst/>
-          </a:prstGeom>
-          <a:solidFill>
-            <a:srgbClr val="2B8A6E"/>
-          </a:solidFill>
-          <a:ln>
-            <a:noFill/>
-          </a:ln>
-        </p:spPr>
-        <p:style>
-          <a:lnRef idx="1">
-            <a:schemeClr val="accent1"/>
-          </a:lnRef>
-          <a:fillRef idx="3">
-            <a:schemeClr val="accent1"/>
-          </a:fillRef>
-          <a:effectRef idx="2">
-            <a:schemeClr val="accent1"/>
-          </a:effectRef>
-          <a:fontRef idx="minor">
-            <a:schemeClr val="lt1"/>
-          </a:fontRef>
-        </p:style>
-        <p:txBody>
-          <a:bodyPr rtlCol="0" anchor="ctr"/>
-          <a:lstStyle/>
-          <a:p>
-            <a:pPr algn="ctr"/>
-          </a:p>
-        </p:txBody>
-      </p:sp>
-      <p:sp>
-        <p:nvSpPr>
-          <p:cNvPr id="18" name="TextBox 17"/>
-          <p:cNvSpPr txBox="1"/>
-          <p:nvPr/>
-        </p:nvSpPr>
-        <p:spPr>
-          <a:xfrm>
-            <a:off x="685800" y="3858768"/>
-            <a:ext cx="10789920" cy="219456"/>
-          </a:xfrm>
-          <a:prstGeom prst="rect">
-            <a:avLst/>
-          </a:prstGeom>
-          <a:noFill/>
-        </p:spPr>
-        <p:txBody>
-          <a:bodyPr wrap="square">
-            <a:spAutoFit/>
-          </a:bodyPr>
-          <a:lstStyle/>
-          <a:p>
-            <a:pPr algn="l"/>
-            <a:r>
-              <a:rPr sz="800" b="1">
-                <a:solidFill>
-                  <a:srgbClr val="C9A84C"/>
-                </a:solidFill>
-                <a:latin typeface="Calibri"/>
-              </a:rPr>
-              <a:t>Slide 8  ·  Platform Metrics</a:t>
-            </a:r>
-          </a:p>
-        </p:txBody>
-      </p:sp>
-      <p:sp>
-        <p:nvSpPr>
-          <p:cNvPr id="19" name="TextBox 18"/>
-          <p:cNvSpPr txBox="1"/>
-          <p:nvPr/>
-        </p:nvSpPr>
-        <p:spPr>
-          <a:xfrm>
-            <a:off x="685800" y="4069080"/>
-            <a:ext cx="10789920" cy="457200"/>
-          </a:xfrm>
-          <a:prstGeom prst="rect">
-            <a:avLst/>
-          </a:prstGeom>
-          <a:noFill/>
-        </p:spPr>
-        <p:txBody>
-          <a:bodyPr wrap="square">
-            <a:spAutoFit/>
-          </a:bodyPr>
-          <a:lstStyle/>
-          <a:p>
-            <a:pPr algn="l"/>
-            <a:r>
-              <a:rPr sz="850" b="0">
-                <a:solidFill>
-                  <a:srgbClr val="CCD2DF"/>
-                </a:solidFill>
-                <a:latin typeface="Calibri"/>
-              </a:rPr>
-              <a:t>VaughnMartin Readiness OS production system, May 2026. All platform layers live in production. 221 strategic triggers. 170 Readiness Protocols. 12 Compound Protocol Engines. 8 live signal sources on 15-minute monitoring cycles. Verifiable at vaughnmartin.com</a:t>
-            </a:r>
-          </a:p>
-        </p:txBody>
-      </p:sp>
-      <p:sp>
-        <p:nvSpPr>
-          <p:cNvPr id="20" name="Rectangle 19"/>
-          <p:cNvSpPr/>
-          <p:nvPr/>
-        </p:nvSpPr>
-        <p:spPr>
-          <a:xfrm>
-            <a:off x="502920" y="4572000"/>
-            <a:ext cx="31750" cy="699008"/>
-          </a:xfrm>
-          <a:prstGeom prst="rect">
-            <a:avLst/>
-          </a:prstGeom>
-          <a:solidFill>
-            <a:srgbClr val="2B8A6E"/>
-          </a:solidFill>
-          <a:ln>
-            <a:noFill/>
-          </a:ln>
-        </p:spPr>
-        <p:style>
-          <a:lnRef idx="1">
-            <a:schemeClr val="accent1"/>
-          </a:lnRef>
-          <a:fillRef idx="3">
-            <a:schemeClr val="accent1"/>
-          </a:fillRef>
-          <a:effectRef idx="2">
-            <a:schemeClr val="accent1"/>
-          </a:effectRef>
-          <a:fontRef idx="minor">
-            <a:schemeClr val="lt1"/>
-          </a:fontRef>
-        </p:style>
-        <p:txBody>
-          <a:bodyPr rtlCol="0" anchor="ctr"/>
-          <a:lstStyle/>
-          <a:p>
-            <a:pPr algn="ctr"/>
-          </a:p>
-        </p:txBody>
-      </p:sp>
-      <p:sp>
-        <p:nvSpPr>
-          <p:cNvPr id="21" name="TextBox 20"/>
-          <p:cNvSpPr txBox="1"/>
-          <p:nvPr/>
-        </p:nvSpPr>
-        <p:spPr>
-          <a:xfrm>
-            <a:off x="685800" y="4608576"/>
-            <a:ext cx="10789920" cy="219456"/>
-          </a:xfrm>
-          <a:prstGeom prst="rect">
-            <a:avLst/>
-          </a:prstGeom>
-          <a:noFill/>
-        </p:spPr>
-        <p:txBody>
-          <a:bodyPr wrap="square">
-            <a:spAutoFit/>
-          </a:bodyPr>
-          <a:lstStyle/>
-          <a:p>
-            <a:pPr algn="l"/>
-            <a:r>
-              <a:rPr sz="800" b="1">
-                <a:solidFill>
-                  <a:srgbClr val="C9A84C"/>
-                </a:solidFill>
-                <a:latin typeface="Calibri"/>
-              </a:rPr>
-              <a:t>Slide 8  ·  Business Model &amp; Unit Economics</a:t>
-            </a:r>
-          </a:p>
-        </p:txBody>
-      </p:sp>
-      <p:sp>
-        <p:nvSpPr>
-          <p:cNvPr id="22" name="TextBox 21"/>
-          <p:cNvSpPr txBox="1"/>
-          <p:nvPr/>
-        </p:nvSpPr>
-        <p:spPr>
-          <a:xfrm>
-            <a:off x="685800" y="4818888"/>
-            <a:ext cx="10789920" cy="457200"/>
-          </a:xfrm>
-          <a:prstGeom prst="rect">
-            <a:avLst/>
-          </a:prstGeom>
-          <a:noFill/>
-        </p:spPr>
-        <p:txBody>
-          <a:bodyPr wrap="square">
-            <a:spAutoFit/>
-          </a:bodyPr>
-          <a:lstStyle/>
-          <a:p>
-            <a:pPr algn="l"/>
-            <a:r>
-              <a:rPr sz="850" b="0">
-                <a:solidFill>
-                  <a:srgbClr val="CCD2DF"/>
-                </a:solidFill>
-                <a:latin typeface="Calibri"/>
-              </a:rPr>
-              <a:t>VaughnMartin internal pricing model. $120K Average ACV based on Founding Partner tier mid-point. 92% Target Gross Margin based on SaaS infrastructure cost modeling at scale. &lt;6 Month Payback Period derived from enterprise crisis cost avoidance vs. annual platform fee. 2–4 Weeks First Results based on onboarding timeline: Week 1 setup, Weeks 2–4 live protocols.</a:t>
-            </a:r>
-          </a:p>
-        </p:txBody>
-      </p:sp>
-      <p:sp>
-        <p:nvSpPr>
-          <p:cNvPr id="23" name="Rectangle 22"/>
-          <p:cNvSpPr/>
-          <p:nvPr/>
-        </p:nvSpPr>
-        <p:spPr>
-          <a:xfrm>
-            <a:off x="502920" y="5321808"/>
-            <a:ext cx="31750" cy="699008"/>
-          </a:xfrm>
-          <a:prstGeom prst="rect">
-            <a:avLst/>
-          </a:prstGeom>
-          <a:solidFill>
-            <a:srgbClr val="C9A84C"/>
-          </a:solidFill>
-          <a:ln>
-            <a:noFill/>
-          </a:ln>
-        </p:spPr>
-        <p:style>
-          <a:lnRef idx="1">
-            <a:schemeClr val="accent1"/>
-          </a:lnRef>
-          <a:fillRef idx="3">
-            <a:schemeClr val="accent1"/>
-          </a:fillRef>
-          <a:effectRef idx="2">
-            <a:schemeClr val="accent1"/>
-          </a:effectRef>
-          <a:fontRef idx="minor">
-            <a:schemeClr val="lt1"/>
-          </a:fontRef>
-        </p:style>
-        <p:txBody>
-          <a:bodyPr rtlCol="0" anchor="ctr"/>
-          <a:lstStyle/>
-          <a:p>
-            <a:pPr algn="ctr"/>
-          </a:p>
-        </p:txBody>
-      </p:sp>
-      <p:sp>
-        <p:nvSpPr>
           <p:cNvPr id="24" name="TextBox 23"/>
           <p:cNvSpPr txBox="1"/>
           <p:nvPr/>
@@ -9815,7 +9772,7 @@
                 </a:solidFill>
                 <a:latin typeface="Calibri"/>
               </a:rPr>
-              <a:t>All platform metrics verifiable  ·  Financial projections are forward-looking estimates</a:t>
+              <a:t>Access &amp; Verification  ·  Financial projections are forward-looking estimates  ·  Confidential</a:t>
             </a:r>
           </a:p>
         </p:txBody>
@@ -9850,7 +9807,7 @@
                 </a:solidFill>
                 <a:latin typeface="Calibri"/>
               </a:rPr>
-              <a:t>Live product accessible at vaughnmartin.com — no login required for the 12-Minute Test Drive. All slide metrics are either proprietary platform counts, mathematically derived, or labeled as targets/models. Confidential — For Qualified Investor Use Only.</a:t>
+              <a:t>12-Minute Test Drive available without login at vaughnmartin.com/12-minute-experience. Full platform access requires application — the Founding Partner Program is the current access path. Full platform capabilities represent VaughnMartin intellectual property and are not publicly accessible. Platform metrics cited are live production figures from the authenticated environment.</a:t>
             </a:r>
           </a:p>
         </p:txBody>

</xml_diff>

<commit_message>
Update presentation slides and speaker notes for accuracy
Update the presentation file by correcting outdated speaker notes and adding new ones for appendix slides. Also, update the metadata title to reflect the current state of the presentation.

Replit-Commit-Author: Agent
Replit-Commit-Session-Id: 85f09f3c-352d-446d-b98e-3f307c26fc5a
Replit-Commit-Checkpoint-Type: full_checkpoint
Replit-Commit-Event-Id: 2b1bb64f-e35e-499b-b310-c1c63c493cf6
Replit-Commit-Screenshot-Url: https://storage.googleapis.com/screenshot-production-us-central1/3bd53afc-ff4f-401b-9e3d-b367791ef629/85f09f3c-352d-446d-b98e-3f307c26fc5a/zIh07K6
Replit-Helium-Checkpoint-Created: true
</commit_message>
<xml_diff>
--- a/attached_assets/VaughnMartin-4min-Pitch.pptx
+++ b/attached_assets/VaughnMartin-4min-Pitch.pptx
@@ -707,6 +707,316 @@
 </p:notes>
 </file>
 
+<file path=ppt/notesSlides/notesSlide11.xml><?xml version="1.0" encoding="utf-8"?>
+<p:notes xmlns:a="http://schemas.openxmlformats.org/drawingml/2006/main" xmlns:p="http://schemas.openxmlformats.org/presentationml/2006/main" xmlns:r="http://schemas.openxmlformats.org/officeDocument/2006/relationships">
+  <p:cSld>
+    <p:spTree>
+      <p:nvGrpSpPr>
+        <p:cNvPr id="1" name=""/>
+        <p:cNvGrpSpPr/>
+        <p:nvPr/>
+      </p:nvGrpSpPr>
+      <p:grpSpPr>
+        <a:xfrm>
+          <a:off x="0" y="0"/>
+          <a:ext cx="0" cy="0"/>
+          <a:chOff x="0" y="0"/>
+          <a:chExt cx="0" cy="0"/>
+        </a:xfrm>
+      </p:grpSpPr>
+      <p:sp>
+        <p:nvSpPr>
+          <p:cNvPr id="2" name="Slide Image Placeholder 1"/>
+          <p:cNvSpPr>
+            <a:spLocks noGrp="1"/>
+          </p:cNvSpPr>
+          <p:nvPr>
+            <p:ph type="sldImg" idx="2"/>
+          </p:nvPr>
+        </p:nvSpPr>
+        <p:spPr/>
+      </p:sp>
+      <p:sp>
+        <p:nvSpPr>
+          <p:cNvPr id="3" name="Notes Placeholder 2"/>
+          <p:cNvSpPr>
+            <a:spLocks noGrp="1"/>
+          </p:cNvSpPr>
+          <p:nvPr>
+            <p:ph type="body" idx="3" sz="quarter"/>
+          </p:nvPr>
+        </p:nvSpPr>
+        <p:spPr/>
+        <p:txBody>
+          <a:bodyPr/>
+          <a:lstStyle/>
+          <a:p>
+            <a:r>
+              <a:t>APPENDIX — DATA &amp; PRIVACY  [Flip to if asked]
+USE WHEN: An investor or enterprise contact asks about data security, AI safety, or compliance.
+TALKING POINTS:
+→ Customer data is owned by the customer. VaughnMartin cannot access it without explicit consent.
+→ Every query is org-scoped at the database layer — cross-tenant reads are architecturally prevented, not just policy.
+→ AI processing runs through Azure OpenAI under enterprise data processing agreements. Your data does not train their models.
+→ TLS encrypted in transit. Encrypted at rest. Neon PostgreSQL infrastructure is SOC 2 Type II certified today.
+→ Platform-level SOC 2 audit is on the roadmap for GA. We have a full architecture documentation package available on request.
+→ No Readiness Protocol activates without executive sign-off — every action requires named human authorization.
+IF THEY PUSH ON SOC 2: "Our infrastructure is certified today. The platform audit is scheduled as part of GA. For Founding Partners working with us during the validation period, we can share the full security architecture document."
+Direct them to: vaughnmartin.com/security-compliance</a:t>
+            </a:r>
+          </a:p>
+        </p:txBody>
+      </p:sp>
+      <p:sp>
+        <p:nvSpPr>
+          <p:cNvPr id="4" name="Slide Number Placeholder 3"/>
+          <p:cNvSpPr>
+            <a:spLocks noGrp="1"/>
+          </p:cNvSpPr>
+          <p:nvPr>
+            <p:ph type="sldNum" idx="5" sz="quarter"/>
+          </p:nvPr>
+        </p:nvSpPr>
+        <p:spPr/>
+      </p:sp>
+    </p:spTree>
+  </p:cSld>
+  <p:clrMapOvr>
+    <a:masterClrMapping/>
+  </p:clrMapOvr>
+</p:notes>
+</file>
+
+<file path=ppt/notesSlides/notesSlide12.xml><?xml version="1.0" encoding="utf-8"?>
+<p:notes xmlns:a="http://schemas.openxmlformats.org/drawingml/2006/main" xmlns:p="http://schemas.openxmlformats.org/presentationml/2006/main" xmlns:r="http://schemas.openxmlformats.org/officeDocument/2006/relationships">
+  <p:cSld>
+    <p:spTree>
+      <p:nvGrpSpPr>
+        <p:cNvPr id="1" name=""/>
+        <p:cNvGrpSpPr/>
+        <p:nvPr/>
+      </p:nvGrpSpPr>
+      <p:grpSpPr>
+        <a:xfrm>
+          <a:off x="0" y="0"/>
+          <a:ext cx="0" cy="0"/>
+          <a:chOff x="0" y="0"/>
+          <a:chExt cx="0" cy="0"/>
+        </a:xfrm>
+      </p:grpSpPr>
+      <p:sp>
+        <p:nvSpPr>
+          <p:cNvPr id="2" name="Slide Image Placeholder 1"/>
+          <p:cNvSpPr>
+            <a:spLocks noGrp="1"/>
+          </p:cNvSpPr>
+          <p:nvPr>
+            <p:ph type="sldImg" idx="2"/>
+          </p:nvPr>
+        </p:nvSpPr>
+        <p:spPr/>
+      </p:sp>
+      <p:sp>
+        <p:nvSpPr>
+          <p:cNvPr id="3" name="Notes Placeholder 2"/>
+          <p:cNvSpPr>
+            <a:spLocks noGrp="1"/>
+          </p:cNvSpPr>
+          <p:nvPr>
+            <p:ph type="body" idx="3" sz="quarter"/>
+          </p:nvPr>
+        </p:nvSpPr>
+        <p:spPr/>
+        <p:txBody>
+          <a:bodyPr/>
+          <a:lstStyle/>
+          <a:p>
+            <a:r>
+              <a:t>APPENDIX — LIVE PRODUCT: SIGNAL INTELLIGENCE &amp; EXECUTION CHAIN  [Flip to if asked to see the product]
+USE WHEN: An investor says "can you show me the product?" or "what does it actually look like?"
+TALKING POINTS:
+→ Left screenshot: The Command Tower. This is live — 221 triggers monitored across 8 sources every 15 minutes. The score you see recalculates continuously. This is not a mock.
+→ Right screenshot: The Execution Chain. This is the animated signal → protocol → task assignment → executive authorization → war room open sequence. Every step you see here happens in the live product.
+THEN OFFER: "Go to vaughnmartin.com/12-minute-experience right now — no login. Pick Activist Investor or Ransomware. You'll see the full cycle in twelve minutes."
+NOTE: The 12-Minute Test Drive is public. The full Command Tower, full war room, and full protocol library are behind the Founding Partner access gate.</a:t>
+            </a:r>
+          </a:p>
+        </p:txBody>
+      </p:sp>
+      <p:sp>
+        <p:nvSpPr>
+          <p:cNvPr id="4" name="Slide Number Placeholder 3"/>
+          <p:cNvSpPr>
+            <a:spLocks noGrp="1"/>
+          </p:cNvSpPr>
+          <p:nvPr>
+            <p:ph type="sldNum" idx="5" sz="quarter"/>
+          </p:nvPr>
+        </p:nvSpPr>
+        <p:spPr/>
+      </p:sp>
+    </p:spTree>
+  </p:cSld>
+  <p:clrMapOvr>
+    <a:masterClrMapping/>
+  </p:clrMapOvr>
+</p:notes>
+</file>
+
+<file path=ppt/notesSlides/notesSlide13.xml><?xml version="1.0" encoding="utf-8"?>
+<p:notes xmlns:a="http://schemas.openxmlformats.org/drawingml/2006/main" xmlns:p="http://schemas.openxmlformats.org/presentationml/2006/main" xmlns:r="http://schemas.openxmlformats.org/officeDocument/2006/relationships">
+  <p:cSld>
+    <p:spTree>
+      <p:nvGrpSpPr>
+        <p:cNvPr id="1" name=""/>
+        <p:cNvGrpSpPr/>
+        <p:nvPr/>
+      </p:nvGrpSpPr>
+      <p:grpSpPr>
+        <a:xfrm>
+          <a:off x="0" y="0"/>
+          <a:ext cx="0" cy="0"/>
+          <a:chOff x="0" y="0"/>
+          <a:chExt cx="0" cy="0"/>
+        </a:xfrm>
+      </p:grpSpPr>
+      <p:sp>
+        <p:nvSpPr>
+          <p:cNvPr id="2" name="Slide Image Placeholder 1"/>
+          <p:cNvSpPr>
+            <a:spLocks noGrp="1"/>
+          </p:cNvSpPr>
+          <p:nvPr>
+            <p:ph type="sldImg" idx="2"/>
+          </p:nvPr>
+        </p:nvSpPr>
+        <p:spPr/>
+      </p:sp>
+      <p:sp>
+        <p:nvSpPr>
+          <p:cNvPr id="3" name="Notes Placeholder 2"/>
+          <p:cNvSpPr>
+            <a:spLocks noGrp="1"/>
+          </p:cNvSpPr>
+          <p:nvPr>
+            <p:ph type="body" idx="3" sz="quarter"/>
+          </p:nvPr>
+        </p:nvSpPr>
+        <p:spPr/>
+        <p:txBody>
+          <a:bodyPr/>
+          <a:lstStyle/>
+          <a:p>
+            <a:r>
+              <a:t>APPENDIX — LIVE PRODUCT: TEST DRIVE &amp; PROTOCOL DEPTH  [Flip to if asked about scale or proof]
+USE WHEN: An investor asks "how do I know it works?" or "how deep is the protocol library?"
+TALKING POINTS:
+→ Left screenshot: The 12-Minute Test Drive. Seven scenarios, no login, full cycle. This is your live proof — available during this meeting.
+→ Right screenshot: The Protocol Library. 170 Readiness Protocols mapped across GROWTH &amp; POSITIONING, RISK &amp; RESILIENCE, and TRANSFORMATION. 12 Compound Protocol Engines for simultaneous multi-threat response. This is what "pre-staged" means at depth.
+IF THEY WANT TO RUN IT NOW: Have them open vaughnmartin.com/12-minute-experience on their phone.
+If they want to see more: "Full access is through the Founding Partner Program — that is the correct path for any organization ready to engage."</a:t>
+            </a:r>
+          </a:p>
+        </p:txBody>
+      </p:sp>
+      <p:sp>
+        <p:nvSpPr>
+          <p:cNvPr id="4" name="Slide Number Placeholder 3"/>
+          <p:cNvSpPr>
+            <a:spLocks noGrp="1"/>
+          </p:cNvSpPr>
+          <p:nvPr>
+            <p:ph type="sldNum" idx="5" sz="quarter"/>
+          </p:nvPr>
+        </p:nvSpPr>
+        <p:spPr/>
+      </p:sp>
+    </p:spTree>
+  </p:cSld>
+  <p:clrMapOvr>
+    <a:masterClrMapping/>
+  </p:clrMapOvr>
+</p:notes>
+</file>
+
+<file path=ppt/notesSlides/notesSlide14.xml><?xml version="1.0" encoding="utf-8"?>
+<p:notes xmlns:a="http://schemas.openxmlformats.org/drawingml/2006/main" xmlns:p="http://schemas.openxmlformats.org/presentationml/2006/main" xmlns:r="http://schemas.openxmlformats.org/officeDocument/2006/relationships">
+  <p:cSld>
+    <p:spTree>
+      <p:nvGrpSpPr>
+        <p:cNvPr id="1" name=""/>
+        <p:cNvGrpSpPr/>
+        <p:nvPr/>
+      </p:nvGrpSpPr>
+      <p:grpSpPr>
+        <a:xfrm>
+          <a:off x="0" y="0"/>
+          <a:ext cx="0" cy="0"/>
+          <a:chOff x="0" y="0"/>
+          <a:chExt cx="0" cy="0"/>
+        </a:xfrm>
+      </p:grpSpPr>
+      <p:sp>
+        <p:nvSpPr>
+          <p:cNvPr id="2" name="Slide Image Placeholder 1"/>
+          <p:cNvSpPr>
+            <a:spLocks noGrp="1"/>
+          </p:cNvSpPr>
+          <p:nvPr>
+            <p:ph type="sldImg" idx="2"/>
+          </p:nvPr>
+        </p:nvSpPr>
+        <p:spPr/>
+      </p:sp>
+      <p:sp>
+        <p:nvSpPr>
+          <p:cNvPr id="3" name="Notes Placeholder 2"/>
+          <p:cNvSpPr>
+            <a:spLocks noGrp="1"/>
+          </p:cNvSpPr>
+          <p:nvPr>
+            <p:ph type="body" idx="3" sz="quarter"/>
+          </p:nvPr>
+        </p:nvSpPr>
+        <p:spPr/>
+        <p:txBody>
+          <a:bodyPr/>
+          <a:lstStyle/>
+          <a:p>
+            <a:r>
+              <a:t>APPENDIX — SOURCES &amp; REFERENCES  [Flip to if sources are challenged]
+USE WHEN: An investor challenges the $42B TAM, the 3,600× figure, or asks where the numbers come from.
+KEY SOURCE EXPLANATIONS:
+$42B TAM: Gartner Strategic Portfolio Management 2025 — SPM + GRC + EPMO combined categories. This is the enterprise coordination, governance, and execution infrastructure market.
+$4.8B SAM: Same Gartner source, scoped to Fortune 5000 and PE-backed enterprises at target ACV.
+3,600×: This is math, not marketing. 30 days × 24 hours × 60 minutes = 43,200 minutes. Divided by 12 minutes = 3,600×. The 30-day baseline is average Fortune 1000 cross-functional mobilization from McKinsey Organizational Agility Research (2025).
+67% execution improvement: Simulation-validated — labeled as such on Slide 6. Not a customer cohort claim.
+Platform metrics (221 triggers, 170 protocols, 8 sources): Live production system. Verifiable at vaughnmartin.com — authenticated environment only.
+Business model: Internal pricing model. All metrics labeled as targets where applicable.</a:t>
+            </a:r>
+          </a:p>
+        </p:txBody>
+      </p:sp>
+      <p:sp>
+        <p:nvSpPr>
+          <p:cNvPr id="4" name="Slide Number Placeholder 3"/>
+          <p:cNvSpPr>
+            <a:spLocks noGrp="1"/>
+          </p:cNvSpPr>
+          <p:nvPr>
+            <p:ph type="sldNum" idx="5" sz="quarter"/>
+          </p:nvPr>
+        </p:nvSpPr>
+        <p:spPr/>
+      </p:sp>
+    </p:spTree>
+  </p:cSld>
+  <p:clrMapOvr>
+    <a:masterClrMapping/>
+  </p:clrMapOvr>
+</p:notes>
+</file>
+
 <file path=ppt/notesSlides/notesSlide2.xml><?xml version="1.0" encoding="utf-8"?>
 <p:notes xmlns:a="http://schemas.openxmlformats.org/drawingml/2006/main" xmlns:p="http://schemas.openxmlformats.org/presentationml/2006/main" xmlns:r="http://schemas.openxmlformats.org/officeDocument/2006/relationships">
   <p:cSld>
@@ -1454,56 +1764,18 @@
           <a:lstStyle/>
           <a:p>
             <a:r>
-              <a:t>SLIDE 08 — PROOF + BUSINESS MODEL  [3:10 – 3:38]  TARGET: 28 seconds</a:t>
-            </a:r>
-          </a:p>
-          <a:p/>
-          <a:p>
-            <a:r>
-              <a:t>"The product is live. You can run it during this meeting — no login, no demo call required."</a:t>
-            </a:r>
-          </a:p>
-          <a:p/>
-          <a:p>
-            <a:r>
-              <a:t>[Point to /12-minute-experience]</a:t>
-            </a:r>
-          </a:p>
-          <a:p>
-            <a:r>
-              <a:t>"Go to slash 12-minute-experience right now. Seven scenarios. Full Activist Investor response — signal detected to executive authorization — in twelve minutes. On your phone, on your laptop, right now."</a:t>
-            </a:r>
-          </a:p>
-          <a:p/>
-          <a:p>
-            <a:r>
-              <a:t>"This is not a prototype. Not a roadmap. Twelve full scenarios demonstrable on demand."</a:t>
-            </a:r>
-          </a:p>
-          <a:p/>
-          <a:p>
-            <a:r>
-              <a:t>[Pivot to business model — right side]</a:t>
-            </a:r>
-          </a:p>
-          <a:p>
-            <a:r>
-              <a:t>"The model is annual SaaS. Average ACV is a hundred and twenty thousand dollars. Target gross margin is ninety-two percent. Implementation under six months, payback in eighteen."</a:t>
-            </a:r>
-          </a:p>
-          <a:p/>
-          <a:p>
-            <a:r>
-              <a:t>"Three tiers — Core opens the account. Industry packs expand it. Enterprise seals multi-year. Land and expand built into the architecture."</a:t>
-            </a:r>
-          </a:p>
-          <a:p/>
-          <a:p>
-            <a:r>
-              <a:t>TRANSITION: "Which is exactly what the seed round funds."</a:t>
-            </a:r>
-          </a:p>
-          <a:p/>
+              <a:t>SLIDE 08 — PROOF + BUSINESS MODEL  [3:10 – 3:38]  TARGET: 28 seconds
+"The product is live. The 12-Minute Test Drive is public — no login required."
+[Point to /12-minute-experience]
+"Go to slash 12-minute-experience right now. Seven scenarios. Full Activist Investor response — signal detected to executive authorization — in twelve minutes. On your phone, on your laptop, right now."
+NOTE: The Test Drive is the public proof point. Full platform access — the authenticated war room, full protocol library, activation console — requires application through the Founding Partner Program. That is intentional. The full platform is proprietary IP and is not publicly accessible.
+"This is not a prototype. Not a roadmap. Twelve full scenarios demonstrable on demand."
+[Pivot to business model — right side]
+"The model is annual SaaS. Average ACV is a hundred and twenty thousand dollars. Target gross margin is ninety-two percent. First results in two to four weeks. Customer payback under six months."
+"Three tiers — Core opens the account at seventy-five to a hundred and twenty thousand. Industry packs expand it. Enterprise seals multi-year."
+TRANSITION: "Here is what we're asking for — and where the money goes."</a:t>
+            </a:r>
+          </a:p>
         </p:txBody>
       </p:sp>
       <p:sp>
@@ -1571,51 +1843,16 @@
           <a:lstStyle/>
           <a:p>
             <a:r>
-              <a:t>SLIDE 09 — THE ASK  [3:38 – 3:52]  TARGET: 14 seconds</a:t>
-            </a:r>
-          </a:p>
-          <a:p/>
-          <a:p>
-            <a:r>
-              <a:t>"We are raising seven hundred and fifty thousand dollars — eighteen months, three milestones."</a:t>
-            </a:r>
-          </a:p>
-          <a:p/>
-          <a:p>
-            <a:r>
-              <a:t>[Point to milestones quickly]</a:t>
-            </a:r>
-          </a:p>
-          <a:p>
-            <a:r>
-              <a:t>"Milestone one: close three to five Founding Partners at a hundred and twenty to a hundred and eighty thousand ACV. Document the proof points."</a:t>
-            </a:r>
-          </a:p>
-          <a:p/>
-          <a:p>
-            <a:r>
-              <a:t>"Milestone two: enter Series A with real ARR contracted and the land-and-expand path proven through industry packs."</a:t>
-            </a:r>
-          </a:p>
-          <a:p/>
-          <a:p>
-            <a:r>
-              <a:t>"Milestone three: own the category name. The operating model layer above the Microsoft investment."</a:t>
-            </a:r>
-          </a:p>
-          <a:p/>
-          <a:p>
-            <a:r>
-              <a:t>"Sixty percent of the raise goes to product and engineering. Twenty-five to go-to-market. Fifteen to operations."</a:t>
-            </a:r>
-          </a:p>
-          <a:p/>
-          <a:p>
-            <a:r>
-              <a:t>TRANSITION: [Advance to close immediately]</a:t>
-            </a:r>
-          </a:p>
-          <a:p/>
+              <a:t>SLIDE 09 — THE ASK  [3:38 – 3:52]  TARGET: 14 seconds
+"We are raising seven hundred and fifty thousand dollars — eighteen months, three milestones."
+[Point to milestones quickly]
+"Milestone one: close three to five Founding Partners at a hundred and twenty to a hundred and eighty thousand ACV. Document the proof points."
+"Milestone two: enter Series A with real ARR contracted and the land-and-expand path proven through industry packs."
+"Milestone three: own the category name. The operating model layer above the Microsoft investment."
+"The product is built and in production. This round is a go-to-market round — forty percent goes to customer acquisition and sales, thirty-five to engineering for industry packs and enterprise controls, fifteen to operations, ten held in reserve."
+TRANSITION: [Advance to close immediately]</a:t>
+            </a:r>
+          </a:p>
         </p:txBody>
       </p:sp>
       <p:sp>

</xml_diff>

<commit_message>
Update presentation slides with improved language
Update speaker notes in presentation to refine phrasing from technical "trigger fires" to more descriptive "situation arrives" and clarify system recognition of scenarios.

Replit-Commit-Author: Agent
Replit-Commit-Session-Id: 85f09f3c-352d-446d-b98e-3f307c26fc5a
Replit-Commit-Checkpoint-Type: full_checkpoint
Replit-Commit-Event-Id: 7345e817-f29c-4869-ba95-1d7f2dad9d9a
Replit-Commit-Screenshot-Url: https://storage.googleapis.com/screenshot-production-us-central1/3bd53afc-ff4f-401b-9e3d-b367791ef629/85f09f3c-352d-446d-b98e-3f307c26fc5a/DWXMRMs
Replit-Helium-Checkpoint-Created: true
</commit_message>
<xml_diff>
--- a/attached_assets/VaughnMartin-4min-Pitch.pptx
+++ b/attached_assets/VaughnMartin-4min-Pitch.pptx
@@ -630,61 +630,18 @@
           <a:lstStyle/>
           <a:p>
             <a:r>
-              <a:t>SLIDE 10 — CLOSE  [3:52 – 4:00]  TARGET: 8 seconds</a:t>
-            </a:r>
-          </a:p>
-          <a:p/>
-          <a:p>
-            <a:r>
-              <a:t>[Pause. Let the room settle.]</a:t>
-            </a:r>
-          </a:p>
-          <a:p/>
-          <a:p>
-            <a:r>
-              <a:t>"Every organization that prepares for every situation it will face is no longer afraid of strategic triggers."</a:t>
-            </a:r>
-          </a:p>
-          <a:p/>
-          <a:p>
-            <a:r>
-              <a:t>[One more beat.]</a:t>
-            </a:r>
-          </a:p>
-          <a:p/>
-          <a:p>
-            <a:r>
-              <a:t>"It is fearless."</a:t>
-            </a:r>
-          </a:p>
-          <a:p/>
-          <a:p>
-            <a:r>
-              <a:t>[Leave the slide up. Do not advance. Wait for the question.]</a:t>
-            </a:r>
-          </a:p>
-          <a:p/>
-          <a:p>
-            <a:r>
-              <a:t>--- POST-PRESENTATION ---</a:t>
-            </a:r>
-          </a:p>
-          <a:p>
-            <a:r>
-              <a:t>If they ask for a demo: "Run slash 12-minute-experience right now. No login. Pick Activist Investor."</a:t>
-            </a:r>
-          </a:p>
-          <a:p>
-            <a:r>
-              <a:t>If they ask about competition: "Slide in the appendix of our full deck — or I'll answer it now."</a:t>
-            </a:r>
-          </a:p>
-          <a:p>
-            <a:r>
-              <a:t>If they ask about revenue: "The Founding Partner Program is the revenue proof — three agreements at a hundred and twenty thousand validates the model before Series A."</a:t>
-            </a:r>
-          </a:p>
-          <a:p/>
+              <a:t>SLIDE 10 — CLOSE  [3:52 – 4:00]  TARGET: 8 seconds
+[Pause. Let the room settle.]
+"Every organization that prepares for every situation it will face is no longer afraid of any situation they will face."
+[One more beat.]
+"It is fearless."
+[Leave the slide up. Do not advance. Wait for the question.]
+--- POST-PRESENTATION ---
+If they ask for a demo: "Run slash 12-minute-experience right now. No login. Pick Activist Investor."
+If they ask about competition: "Slide in the appendix of our full deck — or I'll answer it now."
+If they ask about revenue: "The Founding Partner Program is the revenue proof — three agreements at a hundred and twenty thousand validates the model before Series A."</a:t>
+            </a:r>
+          </a:p>
         </p:txBody>
       </p:sp>
       <p:sp>
@@ -1062,67 +1019,19 @@
           <a:lstStyle/>
           <a:p>
             <a:r>
-              <a:t>SLIDE 02 — THE PROBLEM  [0:20 – 0:55]  TARGET: 35 seconds</a:t>
-            </a:r>
-          </a:p>
-          <a:p/>
-          <a:p>
-            <a:r>
-              <a:t>"When a strategic trigger fires — an activist investor files a 13D, a ransomware attack hits, a supply chain collapses — what happens next in most enterprises?"</a:t>
-            </a:r>
-          </a:p>
-          <a:p/>
-          <a:p>
-            <a:r>
-              <a:t>[Point to DETECT column]</a:t>
-            </a:r>
-          </a:p>
-          <a:p>
-            <a:r>
-              <a:t>"First, two to four weeks figuring out who monitors signals. Who's in the room. What the threshold is."</a:t>
-            </a:r>
-          </a:p>
-          <a:p/>
-          <a:p>
-            <a:r>
-              <a:t>[Point to ALIGN column]  </a:t>
-            </a:r>
-          </a:p>
-          <a:p>
-            <a:r>
-              <a:t>"Then another three to six weeks aligning on a plan. Getting approvals. Scheduling the meeting."</a:t>
-            </a:r>
-          </a:p>
-          <a:p/>
-          <a:p>
-            <a:r>
-              <a:t>[Point to EXECUTE column — RED]</a:t>
-            </a:r>
-          </a:p>
-          <a:p>
-            <a:r>
-              <a:t>"By the time execution starts, the window is closed. The crisis wins. Not because the executives were slow. Because the OPERATING MODEL had no answer pre-staged."</a:t>
-            </a:r>
-          </a:p>
-          <a:p/>
-          <a:p>
-            <a:r>
-              <a:t>"Every solution in this market — Copilot, ChatGPT, strategy consultants — bolted AI onto this same broken model. Faster notes from the same slow meeting."</a:t>
-            </a:r>
-          </a:p>
-          <a:p/>
-          <a:p>
-            <a:r>
-              <a:t>"We didn't do that."</a:t>
-            </a:r>
-          </a:p>
-          <a:p/>
-          <a:p>
-            <a:r>
-              <a:t>TRANSITION: "We rebuilt the operating model itself."</a:t>
-            </a:r>
-          </a:p>
-          <a:p/>
+              <a:t>SLIDE 02 — THE PROBLEM  [0:20 – 0:55]  TARGET: 35 seconds
+"When a situation the organization has prepared for finally arrives — an activist investor files a 13D, a ransomware attack hits, a supply chain collapses — what happens next in most enterprises?"
+[Point to DETECT column]
+"First, two to four weeks figuring out who monitors signals. Who's in the room. What the threshold is."
+[Point to ALIGN column]  
+"Then another three to six weeks aligning on a plan. Getting approvals. Scheduling the meeting."
+[Point to EXECUTE column — RED]
+"By the time execution starts, the window is closed. The crisis wins. Not because the executives were slow. Because the OPERATING MODEL had no answer pre-staged."
+"Every solution in this market — Copilot, ChatGPT, strategy consultants — bolted AI onto this same broken model. Faster notes from the same slow meeting."
+"We didn't do that."
+TRANSITION: "We rebuilt the operating model itself."</a:t>
+            </a:r>
+          </a:p>
         </p:txBody>
       </p:sp>
       <p:sp>
@@ -1190,58 +1099,17 @@
           <a:lstStyle/>
           <a:p>
             <a:r>
-              <a:t>SLIDE 03 — THE PLATFORM  [0:55 – 1:30]  TARGET: 35 seconds</a:t>
-            </a:r>
-          </a:p>
-          <a:p/>
-          <a:p>
-            <a:r>
-              <a:t>"Readiness OS is not a tool you pick up when the crisis hits. It is infrastructure that never stops running."</a:t>
-            </a:r>
-          </a:p>
-          <a:p/>
-          <a:p>
-            <a:r>
-              <a:t>[Run through layers quickly — point to each colored bar]</a:t>
-            </a:r>
-          </a:p>
-          <a:p/>
-          <a:p>
-            <a:r>
-              <a:t>"Layer 1: The system is always monitoring — 8 live intelligence sources, every 15 minutes, scored against 221 strategic triggers."</a:t>
-            </a:r>
-          </a:p>
-          <a:p/>
-          <a:p>
-            <a:r>
-              <a:t>"Layer 2: When signals cluster, the system classifies the trigger — using a proprietary algorithm with grouped data points and mandatory conditions. Not a single signal. An architecture."</a:t>
-            </a:r>
-          </a:p>
-          <a:p/>
-          <a:p>
-            <a:r>
-              <a:t>"Layer 3: Instantly — a pre-staged Readiness Protocol deploys. The war room is armed before anyone picks up the phone."</a:t>
-            </a:r>
-          </a:p>
-          <a:p/>
-          <a:p>
-            <a:r>
-              <a:t>"Layer 4: Tasks are auto-assigned, stakeholders are notified, and the executive authorizes. No action without sign-off. 12 minutes end to end."</a:t>
-            </a:r>
-          </a:p>
-          <a:p/>
-          <a:p>
-            <a:r>
-              <a:t>"Layer 5: Every activation teaches the system. Institutional memory compounds. The longer you are on the platform, the faster and more accurate the response."</a:t>
-            </a:r>
-          </a:p>
-          <a:p/>
-          <a:p>
-            <a:r>
-              <a:t>TRANSITION: "The number everyone asks about is the 3,600× head start. Let me show you what that actually looks like in practice."</a:t>
-            </a:r>
-          </a:p>
-          <a:p/>
+              <a:t>SLIDE 03 — THE PLATFORM  [0:55 – 1:30]  TARGET: 35 seconds
+"Readiness OS is not a tool you pick up when the crisis hits. It is infrastructure that never stops running."
+[Run through layers quickly — point to each colored bar]
+"Layer 1: The system is always monitoring — 8 live intelligence sources, every 15 minutes, scored against 221 strategic triggers."
+"Layer 2: When signals cluster, the system recognizes the situation and confirms the threshold — using a proprietary algorithm with grouped data points and mandatory conditions. Not a single signal. An architecture."
+"Layer 3: Instantly — a pre-staged Readiness Protocol deploys. The war room is armed before anyone picks up the phone."
+"Layer 4: Tasks are auto-assigned, stakeholders are notified, and the executive authorizes. No action without sign-off. 12 minutes end to end."
+"Layer 5: Every activation teaches the system. Institutional memory compounds. The longer you are on the platform, the faster and more accurate the response."
+TRANSITION: "The number everyone asks about is the 3,600× head start. Let me show you what that actually looks like in practice."</a:t>
+            </a:r>
+          </a:p>
         </p:txBody>
       </p:sp>
       <p:sp>
@@ -1309,50 +1177,16 @@
           <a:lstStyle/>
           <a:p>
             <a:r>
-              <a:t>SLIDE 04 — THE 3,600× HEAD START  [1:30 – 2:05]  TARGET: 35 seconds</a:t>
-            </a:r>
-          </a:p>
-          <a:p/>
-          <a:p>
-            <a:r>
-              <a:t>"Let me make the 3,600× concrete. This is not a marketing number."</a:t>
-            </a:r>
-          </a:p>
-          <a:p/>
-          <a:p>
-            <a:r>
-              <a:t>[Point to left side]</a:t>
-            </a:r>
-          </a:p>
-          <a:p>
-            <a:r>
-              <a:t>"Without Readiness OS: Week one and two, the enterprise is figuring out who even monitors this type of signal. Week three and four, they're aligning stakeholders. Week five through eight, tasks are finally being assigned. Week nine — if the window is still open — execution begins. That's thirty days just to mobilize."</a:t>
-            </a:r>
-          </a:p>
-          <a:p/>
-          <a:p>
-            <a:r>
-              <a:t>[Point to right side — TEAL column]</a:t>
-            </a:r>
-          </a:p>
-          <a:p>
-            <a:r>
-              <a:t>"With Readiness OS: At minute zero, the trigger group threshold is met. The system already knows. At minute two, Protocol 58 deploys automatically — every task pre-staged, every stakeholder pre-identified. At minute twelve, the executive authorizes, and the war room is open."</a:t>
-            </a:r>
-          </a:p>
-          <a:p/>
-          <a:p>
-            <a:r>
-              <a:t>"Thirty days versus twelve minutes. That is the 3,600× execution head start. And the executive makes every decision — the preparation compresses the mobilization, not the authority."</a:t>
-            </a:r>
-          </a:p>
-          <a:p/>
-          <a:p>
-            <a:r>
-              <a:t>TRANSITION: "But here's what separates us from every simulation tool — real crises don't arrive one at a time."</a:t>
-            </a:r>
-          </a:p>
-          <a:p/>
+              <a:t>SLIDE 04 — THE 3,600× HEAD START  [1:30 – 2:05]  TARGET: 35 seconds
+"Let me make the 3,600× concrete. This is not a marketing number."
+[Point to left side]
+"Without Readiness OS: Week one and two, the enterprise is figuring out who even monitors this type of signal. Week three and four, they're aligning stakeholders. Week five through eight, tasks are finally being assigned. Week nine — if the window is still open — execution begins. That's thirty days just to mobilize."
+[Point to right side — TEAL column]
+"With Readiness OS: At minute zero, the system recognizes the situation — the threshold is confirmed, the scenario is classified. The system already knows. At minute two, Protocol 58 deploys automatically — every task pre-staged, every stakeholder pre-identified. At minute twelve, the executive authorizes, and the war room is open."
+"Thirty days versus twelve minutes. That is the 3,600× execution head start. And the executive makes every decision — the preparation compresses the mobilization, not the authority."
+TRANSITION: "But here's what separates us from every simulation tool — real crises don't arrive one at a time."</a:t>
+            </a:r>
+          </a:p>
         </p:txBody>
       </p:sp>
       <p:sp>

</xml_diff>

<commit_message>
Update website and speaker notes to broaden the scope of value
Replace "trigger fires" with more general situation-based language and update "crisis" references to reflect broader applicability.

Replit-Commit-Author: Agent
Replit-Commit-Session-Id: 85f09f3c-352d-446d-b98e-3f307c26fc5a
Replit-Commit-Checkpoint-Type: full_checkpoint
Replit-Commit-Event-Id: 1637ccf4-0785-4ad0-9c14-4b3020dd9b62
Replit-Commit-Screenshot-Url: https://storage.googleapis.com/screenshot-production-us-central1/3bd53afc-ff4f-401b-9e3d-b367791ef629/85f09f3c-352d-446d-b98e-3f307c26fc5a/DWXMRMs
Replit-Helium-Checkpoint-Created: true
</commit_message>
<xml_diff>
--- a/attached_assets/VaughnMartin-4min-Pitch.pptx
+++ b/attached_assets/VaughnMartin-4min-Pitch.pptx
@@ -515,54 +515,17 @@
           <a:lstStyle/>
           <a:p>
             <a:r>
-              <a:t>SLIDE 01 — COVER  [0:00 – 0:20]  TARGET: 20 seconds</a:t>
-            </a:r>
-          </a:p>
-          <a:p/>
-          <a:p>
-            <a:r>
-              <a:t>"Readiness OS compresses the 30-day enterprise mobilization cycle to 12 minutes. Before I explain how — let me show you why that gap is the actual crisis."</a:t>
-            </a:r>
-          </a:p>
-          <a:p/>
-          <a:p>
-            <a:r>
-              <a:t>[Pause one beat on the numbers. Don't explain them. Let them land.]</a:t>
-            </a:r>
-          </a:p>
-          <a:p/>
-          <a:p>
-            <a:r>
-              <a:t>KEY NUMBERS TO POINT AT:</a:t>
-            </a:r>
-          </a:p>
-          <a:p>
-            <a:r>
-              <a:t>  → 3,600× Execution Head Start (30 days vs. 12 minutes)</a:t>
-            </a:r>
-          </a:p>
-          <a:p>
-            <a:r>
-              <a:t>  → 12 Minutes — trigger to war room open</a:t>
-            </a:r>
-          </a:p>
-          <a:p>
-            <a:r>
-              <a:t>  → 170 Readiness Protocols — pre-staged</a:t>
-            </a:r>
-          </a:p>
-          <a:p>
-            <a:r>
-              <a:t>  → 221 Strategic Triggers — mapped</a:t>
-            </a:r>
-          </a:p>
-          <a:p/>
-          <a:p>
-            <a:r>
-              <a:t>TRANSITION: "Every organization I've studied has the same failure mode..."</a:t>
-            </a:r>
-          </a:p>
-          <a:p/>
+              <a:t>SLIDE 01 — COVER  [0:00 – 0:20]  TARGET: 20 seconds
+"Readiness OS compresses the 30-day enterprise mobilization cycle to 12 minutes. Before I explain how — let me show you why that gap is the actual problem."
+[Pause one beat on the numbers. Don't explain them. Let them land.]
+KEY NUMBERS TO POINT AT:
+  → 3,600× Execution Head Start (30 days vs. 12 minutes)
+  → 12 Minutes — trigger to war room open
+  → 170 Readiness Protocols — pre-staged
+  → 221 Strategic Triggers — mapped
+TRANSITION: "Every organization I've studied has the same failure mode..."</a:t>
+            </a:r>
+          </a:p>
         </p:txBody>
       </p:sp>
       <p:sp>
@@ -1026,7 +989,7 @@
 [Point to ALIGN column]  
 "Then another three to six weeks aligning on a plan. Getting approvals. Scheduling the meeting."
 [Point to EXECUTE column — RED]
-"By the time execution starts, the window is closed. The crisis wins. Not because the executives were slow. Because the OPERATING MODEL had no answer pre-staged."
+"By the time execution starts, the window is closed. The window closes. Not because the executives were slow. Because the OPERATING MODEL had no answer pre-staged."
 "Every solution in this market — Copilot, ChatGPT, strategy consultants — bolted AI onto this same broken model. Faster notes from the same slow meeting."
 "We didn't do that."
 TRANSITION: "We rebuilt the operating model itself."</a:t>
@@ -1100,7 +1063,7 @@
           <a:p>
             <a:r>
               <a:t>SLIDE 03 — THE PLATFORM  [0:55 – 1:30]  TARGET: 35 seconds
-"Readiness OS is not a tool you pick up when the crisis hits. It is infrastructure that never stops running."
+"Readiness OS is not a tool you pick up when a situation presents itself. It is infrastructure that never stops running."
 [Run through layers quickly — point to each colored bar]
 "Layer 1: The system is always monitoring — 8 live intelligence sources, every 15 minutes, scored against 221 strategic triggers."
 "Layer 2: When signals cluster, the system recognizes the situation and confirms the threshold — using a proprietary algorithm with grouped data points and mandatory conditions. Not a single signal. An architecture."
@@ -1184,7 +1147,7 @@
 [Point to right side — TEAL column]
 "With Readiness OS: At minute zero, the system recognizes the situation — the threshold is confirmed, the scenario is classified. The system already knows. At minute two, Protocol 58 deploys automatically — every task pre-staged, every stakeholder pre-identified. At minute twelve, the executive authorizes, and the war room is open."
 "Thirty days versus twelve minutes. That is the 3,600× execution head start. And the executive makes every decision — the preparation compresses the mobilization, not the authority."
-TRANSITION: "But here's what separates us from every simulation tool — real crises don't arrive one at a time."</a:t>
+TRANSITION: "But here's what separates us from every simulation tool — high-stakes situations don't arrive one at a time."</a:t>
             </a:r>
           </a:p>
         </p:txBody>
@@ -1254,50 +1217,16 @@
           <a:lstStyle/>
           <a:p>
             <a:r>
-              <a:t>SLIDE 05 — COMPOUND INTELLIGENCE  [2:05 – 2:30]  TARGET: 25 seconds</a:t>
-            </a:r>
-          </a:p>
-          <a:p/>
-          <a:p>
-            <a:r>
-              <a:t>"Here is what separates us from every other platform in this space."</a:t>
-            </a:r>
-          </a:p>
-          <a:p/>
-          <a:p>
-            <a:r>
-              <a:t>[Point to both boxes]</a:t>
-            </a:r>
-          </a:p>
-          <a:p>
-            <a:r>
-              <a:t>"Real crises don't arrive one at a time. An activist investor files a 13D on the same day the DOJ opens an inquiry. Ransomware hits while a product recall is in progress. These aren't edge cases — they are the scenarios that destroy enterprises."</a:t>
-            </a:r>
-          </a:p>
-          <a:p/>
-          <a:p>
-            <a:r>
-              <a:t>"We have twelve Compound Protocol Engines that fire two protocols simultaneously — dual-track war room, no coordination delay, no one waiting for the other team to finish."</a:t>
-            </a:r>
-          </a:p>
-          <a:p/>
-          <a:p>
-            <a:r>
-              <a:t>[Pause]</a:t>
-            </a:r>
-          </a:p>
-          <a:p>
-            <a:r>
-              <a:t>"No other enterprise platform does this natively. Not Copilot. Not any workflow tool. Not a strategy consultant on a retainer."</a:t>
-            </a:r>
-          </a:p>
-          <a:p/>
-          <a:p>
-            <a:r>
-              <a:t>TRANSITION: "And here is why customers don't leave — even after the crisis passes."</a:t>
-            </a:r>
-          </a:p>
-          <a:p/>
+              <a:t>SLIDE 05 — COMPOUND INTELLIGENCE  [2:05 – 2:30]  TARGET: 25 seconds
+"Here is what separates us from every other platform in this space."
+[Point to both boxes]
+"High-stakes situations don't arrive one at a time. An activist investor files a 13D on the same day the DOJ opens an inquiry. Ransomware hits while a product recall is in progress. These aren't edge cases — they are the scenarios that overwhelm enterprises that aren't prepared."
+"We have twelve Compound Protocol Engines that fire two protocols simultaneously — dual-track war room, no coordination delay, no one waiting for the other team to finish."
+[Pause]
+"No other enterprise platform does this natively. Not Copilot. Not any workflow tool. Not a strategy consultant on a retainer."
+TRANSITION: "And here is why customers don't leave — even after the situation resolves."</a:t>
+            </a:r>
+          </a:p>
         </p:txBody>
       </p:sp>
       <p:sp>
@@ -1365,66 +1294,19 @@
           <a:lstStyle/>
           <a:p>
             <a:r>
-              <a:t>SLIDE 06 — THE MOAT  [2:30 – 2:52]  TARGET: 22 seconds</a:t>
-            </a:r>
-          </a:p>
-          <a:p/>
-          <a:p>
-            <a:r>
-              <a:t>"Every activation compounds the lead. Here is why customers don't leave — even after the crisis has passed."</a:t>
-            </a:r>
-          </a:p>
-          <a:p/>
-          <a:p>
-            <a:r>
-              <a:t>[Point to Institutional Memory]</a:t>
-            </a:r>
-          </a:p>
-          <a:p>
-            <a:r>
-              <a:t>"Every decision, every outcome, every pattern from every activation is captured in Retrospect™. That institutional memory is proprietary to the organization — learned from their crises, not ours. No competitor can replicate it."</a:t>
-            </a:r>
-          </a:p>
-          <a:p/>
-          <a:p>
-            <a:r>
-              <a:t>[Point to Executive Readiness Score]</a:t>
-            </a:r>
-          </a:p>
-          <a:p>
-            <a:r>
-              <a:t>"The Readiness Score becomes a board-level KPI. Once a board is benchmarking it quarterly, the switching cost is structural. They don't leave because the score is theirs."</a:t>
-            </a:r>
-          </a:p>
-          <a:p/>
-          <a:p>
-            <a:r>
-              <a:t>[Point to Self-Improving]</a:t>
-            </a:r>
-          </a:p>
-          <a:p>
-            <a:r>
-              <a:t>"And the system gets better automatically — every activation updates the protocol timing and trigger conditions. No other platform does this."</a:t>
-            </a:r>
-          </a:p>
-          <a:p/>
-          <a:p>
-            <a:r>
-              <a:t>[Short pause]</a:t>
-            </a:r>
-          </a:p>
-          <a:p>
-            <a:r>
-              <a:t>"The longer you are on the platform, the harder it is to leave — and the wider the gap from every competitor grows."</a:t>
-            </a:r>
-          </a:p>
-          <a:p/>
-          <a:p>
-            <a:r>
-              <a:t>TRANSITION: "Now let me show you why the market timing is right now."</a:t>
-            </a:r>
-          </a:p>
-          <a:p/>
+              <a:t>SLIDE 06 — THE MOAT  [2:30 – 2:52]  TARGET: 22 seconds
+"Every activation compounds the lead. Here is why customers don't leave — even after the situation resolves."
+[Point to Institutional Memory]
+"Every decision, every outcome, every pattern from every activation is captured in Retrospect™. That institutional memory is proprietary to the organization — learned from their own activations, not ours. No competitor can replicate it."
+[Point to Executive Readiness Score]
+"The Readiness Score becomes a board-level KPI. Once a board is benchmarking it quarterly, the switching cost is structural. They don't leave because the score is theirs."
+[Point to Self-Improving]
+"And the system gets better automatically — every activation updates the protocol timing and trigger conditions. No other platform does this."
+[Short pause]
+"The longer you are on the platform, the harder it is to leave — and the wider the gap from every competitor grows."
+TRANSITION: "Now let me show you why the market timing is right now."</a:t>
+            </a:r>
+          </a:p>
         </p:txBody>
       </p:sp>
       <p:sp>

</xml_diff>